<commit_message>
Revise Slide 7 table headers, task alignment and country tags
Centers headers and customer tasks, drops the U.S. screen counts line,
renders country tags in plain text, changes Xplora AI's country to
Spain, and bolds the two question cards.

Co-Authored-By: Claude Opus 5.5 <noreply@anthropic.com>
Claude-Session: https://claude.ai/code/session_0198bm9pfzRwgZQBqNvd56W8
</commit_message>
<xml_diff>
--- a/deck/Optum-LS-Conversational-AI.pptx
+++ b/deck/Optum-LS-Conversational-AI.pptx
@@ -117,27 +117,27 @@
   <p:extLst>
     <p:ext uri="{521415D9-36F7-43E2-AB2F-B90AF26B5E84}">
       <p14:sectionLst xmlns:p14="http://schemas.microsoft.com/office/powerpoint/2010/main">
-        <p14:section name="Executive summary" id="{47f1f869-cb70-7e05-a6e0-61f99546ea93}">
+        <p14:section name="Executive summary" id="{4165ea33-acdb-ec71-2c20-c86f5af95c31}">
           <p14:sldIdLst>
             <p14:sldId id="256"/>
           </p14:sldIdLst>
         </p14:section>
-        <p14:section name="Research catalyst" id="{1cd3ea11-f618-9b44-bfb8-a460808d31d5}">
+        <p14:section name="Research catalyst" id="{f6194a28-4d36-149b-aa31-ffb23280dc7c}">
           <p14:sldIdLst>
             <p14:sldId id="257"/>
           </p14:sldIdLst>
         </p14:section>
-        <p14:section name="U.S. competitive landscape" id="{491b004e-6b88-0e8d-b226-ea7c67c88255}">
+        <p14:section name="U.S. competitive landscape" id="{74229e6b-8a28-2b61-aad1-d70652567e15}">
           <p14:sldIdLst>
             <p14:sldId id="258"/>
           </p14:sldIdLst>
         </p14:section>
-        <p14:section name="International competitor screens" id="{c6d8e432-a468-8c2d-813d-d0762e36d06e}">
+        <p14:section name="International competitor screens" id="{94f5a2b6-dfc3-83df-13b3-adaeb6c0b68e}">
           <p14:sldIdLst>
             <p14:sldId id="259"/>
           </p14:sldIdLst>
         </p14:section>
-        <p14:section name="Workflow deep dives" id="{93e3a72f-ab4a-01be-91ff-ac6d14846afa}">
+        <p14:section name="Workflow deep dives" id="{3cec758c-60d9-4c4a-fc8a-0c16bcb617ef}">
           <p14:sldIdLst>
             <p14:sldId id="260"/>
             <p14:sldId id="261"/>
@@ -146,12 +146,12 @@
             <p14:sldId id="264"/>
           </p14:sldIdLst>
         </p14:section>
-        <p14:section name="AI suppliers" id="{94c7f05d-e188-6669-8057-d2360c423faa}">
+        <p14:section name="AI suppliers" id="{d5e86b82-eb15-b3dd-551a-ac696039c221}">
           <p14:sldIdLst>
             <p14:sldId id="265"/>
           </p14:sldIdLst>
         </p14:section>
-        <p14:section name="Methodology note" id="{e85c2671-39d0-7bda-a542-1b2a881c7107}">
+        <p14:section name="Methodology note" id="{a790dcfc-235c-969f-9a47-1ee105ea7c54}">
           <p14:sldIdLst>
             <p14:sldId id="266"/>
           </p14:sldIdLst>
@@ -4577,7 +4577,7 @@
                     <a:bodyPr/>
                     <a:lstStyle/>
                     <a:p>
-                      <a:pPr indent="0" marL="0">
+                      <a:pPr algn="l" indent="0" marL="0">
                         <a:buNone/>
                       </a:pPr>
                       <a:r>
@@ -4781,7 +4781,7 @@
                     <a:bodyPr/>
                     <a:lstStyle/>
                     <a:p>
-                      <a:pPr indent="0" marL="0">
+                      <a:pPr algn="l" indent="0" marL="0">
                         <a:buNone/>
                       </a:pPr>
                       <a:r>
@@ -4957,7 +4957,7 @@
                     <a:bodyPr/>
                     <a:lstStyle/>
                     <a:p>
-                      <a:pPr indent="0" marL="0">
+                      <a:pPr algn="l" indent="0" marL="0">
                         <a:buNone/>
                       </a:pPr>
                       <a:r>
@@ -12130,7 +12130,7 @@
                     <a:bodyPr/>
                     <a:lstStyle/>
                     <a:p>
-                      <a:pPr indent="0" marL="0">
+                      <a:pPr algn="l" indent="0" marL="0">
                         <a:buNone/>
                       </a:pPr>
                       <a:r>
@@ -12328,7 +12328,7 @@
                     <a:bodyPr/>
                     <a:lstStyle/>
                     <a:p>
-                      <a:pPr indent="0" marL="0">
+                      <a:pPr algn="l" indent="0" marL="0">
                         <a:buNone/>
                       </a:pPr>
                       <a:r>
@@ -12609,7 +12609,7 @@
                     <a:bodyPr/>
                     <a:lstStyle/>
                     <a:p>
-                      <a:pPr indent="0" marL="0">
+                      <a:pPr algn="l" indent="0" marL="0">
                         <a:buNone/>
                       </a:pPr>
                       <a:r>
@@ -13591,7 +13591,7 @@
                     <a:bodyPr/>
                     <a:lstStyle/>
                     <a:p>
-                      <a:pPr indent="0" marL="0">
+                      <a:pPr algn="l" indent="0" marL="0">
                         <a:buNone/>
                       </a:pPr>
                       <a:r>
@@ -13789,7 +13789,7 @@
                     <a:bodyPr/>
                     <a:lstStyle/>
                     <a:p>
-                      <a:pPr indent="0" marL="0">
+                      <a:pPr algn="l" indent="0" marL="0">
                         <a:buNone/>
                       </a:pPr>
                       <a:r>
@@ -14048,7 +14048,7 @@
                     <a:bodyPr/>
                     <a:lstStyle/>
                     <a:p>
-                      <a:pPr indent="0" marL="0">
+                      <a:pPr algn="l" indent="0" marL="0">
                         <a:buNone/>
                       </a:pPr>
                       <a:r>
@@ -14917,7 +14917,7 @@
         <p:spPr>
           <a:xfrm>
             <a:off x="548640" y="1481328"/>
-            <a:ext cx="5486400" cy="201168"/>
+            <a:ext cx="11091672" cy="201168"/>
           </a:xfrm>
           <a:prstGeom prst="rect">
             <a:avLst/>
@@ -14939,42 +14939,6 @@
                 </a:solidFill>
               </a:rPr>
               <a:t>COMMERCIAL INTELLIGENCE — COMPETITIVE EXAMPLES</a:t>
-            </a:r>
-            <a:endParaRPr lang="en-US" sz="1000" dirty="0"/>
-          </a:p>
-        </p:txBody>
-      </p:sp>
-      <p:sp>
-        <p:nvSpPr>
-          <p:cNvPr id="15" name="screen counts"/>
-          <p:cNvSpPr txBox="1"/>
-          <p:nvPr/>
-        </p:nvSpPr>
-        <p:spPr>
-          <a:xfrm>
-            <a:off x="6126480" y="1481328"/>
-            <a:ext cx="5513832" cy="201168"/>
-          </a:xfrm>
-          <a:prstGeom prst="rect">
-            <a:avLst/>
-          </a:prstGeom>
-          <a:noFill/>
-          <a:ln/>
-        </p:spPr>
-        <p:txBody>
-          <a:bodyPr wrap="square" lIns="0" tIns="0" rIns="0" bIns="0" rtlCol="0" anchor="t"/>
-          <a:lstStyle/>
-          <a:p>
-            <a:pPr algn="r" indent="0" marL="0">
-              <a:buNone/>
-            </a:pPr>
-            <a:r>
-              <a:rPr lang="en-US" sz="1000" b="1" dirty="0">
-                <a:solidFill>
-                  <a:schemeClr val="accent1"/>
-                </a:solidFill>
-              </a:rPr>
-              <a:t>U.S. screen: 3 company groups | 4 qualifying conversational AI offerings</a:t>
             </a:r>
             <a:endParaRPr lang="en-US" sz="1000" dirty="0"/>
           </a:p>
@@ -15013,7 +14977,7 @@
                     <a:bodyPr/>
                     <a:lstStyle/>
                     <a:p>
-                      <a:pPr indent="0" marL="0">
+                      <a:pPr algn="ctr" indent="0" marL="0">
                         <a:buNone/>
                       </a:pPr>
                       <a:r>
@@ -15050,7 +15014,7 @@
                     <a:bodyPr/>
                     <a:lstStyle/>
                     <a:p>
-                      <a:pPr indent="0" marL="0">
+                      <a:pPr algn="ctr" indent="0" marL="0">
                         <a:buNone/>
                       </a:pPr>
                       <a:r>
@@ -15059,7 +15023,7 @@
                             <a:schemeClr val="bg1"/>
                           </a:solidFill>
                         </a:rPr>
-                        <a:t>COMPETITOR CONVERSATIONAL AI OFFERINGS</a:t>
+                        <a:t>CONVERSATIONAL AI OFFERINGS</a:t>
                       </a:r>
                       <a:endParaRPr lang="en-US" sz="900" dirty="0"/>
                     </a:p>
@@ -15087,7 +15051,7 @@
                     <a:bodyPr/>
                     <a:lstStyle/>
                     <a:p>
-                      <a:pPr indent="0" marL="0">
+                      <a:pPr algn="ctr" indent="0" marL="0">
                         <a:buNone/>
                       </a:pPr>
                       <a:r>
@@ -15126,7 +15090,7 @@
                     <a:bodyPr/>
                     <a:lstStyle/>
                     <a:p>
-                      <a:pPr indent="0" marL="0">
+                      <a:pPr algn="ctr" indent="0" marL="0">
                         <a:buNone/>
                       </a:pPr>
                       <a:r>
@@ -15257,9 +15221,9 @@
                         <a:buNone/>
                       </a:pPr>
                       <a:r>
-                        <a:rPr lang="en-US" sz="950" b="1" dirty="0">
+                        <a:rPr lang="en-US" sz="950" dirty="0">
                           <a:solidFill>
-                            <a:schemeClr val="accent2"/>
+                            <a:schemeClr val="tx1"/>
                           </a:solidFill>
                         </a:rPr>
                         <a:t>(China)</a:t>
@@ -15318,9 +15282,9 @@
                         <a:buNone/>
                       </a:pPr>
                       <a:r>
-                        <a:rPr lang="en-US" sz="950" b="1" dirty="0">
+                        <a:rPr lang="en-US" sz="950" dirty="0">
                           <a:solidFill>
-                            <a:schemeClr val="accent2"/>
+                            <a:schemeClr val="tx1"/>
                           </a:solidFill>
                         </a:rPr>
                         <a:t>(Australia)</a:t>
@@ -15401,13 +15365,13 @@
                   </a:tcPr>
                 </a:tc>
               </a:tr>
-              <a:tr h="881380">
+              <a:tr h="734187">
                 <a:tc>
                   <a:txBody>
                     <a:bodyPr/>
                     <a:lstStyle/>
                     <a:p>
-                      <a:pPr indent="0" marL="0">
+                      <a:pPr algn="ctr" indent="0" marL="0">
                         <a:buNone/>
                       </a:pPr>
                       <a:r>
@@ -15577,12 +15541,12 @@
                         <a:buNone/>
                       </a:pPr>
                       <a:r>
-                        <a:rPr lang="en-US" sz="950" b="1" dirty="0">
+                        <a:rPr lang="en-US" sz="950" dirty="0">
                           <a:solidFill>
-                            <a:schemeClr val="accent2"/>
+                            <a:schemeClr val="tx1"/>
                           </a:solidFill>
                         </a:rPr>
-                        <a:t>(Argentina)</a:t>
+                        <a:t>(Spain)</a:t>
                       </a:r>
                       <a:pPr indent="0" marL="0">
                         <a:buNone/>
@@ -15666,7 +15630,7 @@
                     <a:bodyPr/>
                     <a:lstStyle/>
                     <a:p>
-                      <a:pPr indent="0" marL="0">
+                      <a:pPr algn="ctr" indent="0" marL="0">
                         <a:buNone/>
                       </a:pPr>
                       <a:r>
@@ -15797,9 +15761,9 @@
                         <a:buNone/>
                       </a:pPr>
                       <a:r>
-                        <a:rPr lang="en-US" sz="950" b="1" dirty="0">
+                        <a:rPr lang="en-US" sz="950" dirty="0">
                           <a:solidFill>
-                            <a:schemeClr val="accent2"/>
+                            <a:schemeClr val="tx1"/>
                           </a:solidFill>
                         </a:rPr>
                         <a:t>(France)</a:t>
@@ -15886,14 +15850,14 @@
       </p:graphicFrame>
       <p:sp>
         <p:nvSpPr>
-          <p:cNvPr id="17" name="questions for comparison card"/>
+          <p:cNvPr id="16" name="questions for comparison card"/>
           <p:cNvSpPr/>
           <p:nvPr/>
         </p:nvSpPr>
         <p:spPr>
           <a:xfrm>
-            <a:off x="548640" y="4507738"/>
-            <a:ext cx="5454396" cy="1143254"/>
+            <a:off x="548640" y="4360545"/>
+            <a:ext cx="5454396" cy="1290447"/>
           </a:xfrm>
           <a:prstGeom prst="rect">
             <a:avLst/>
@@ -15913,13 +15877,13 @@
       </p:sp>
       <p:sp>
         <p:nvSpPr>
-          <p:cNvPr id="18" name="label"/>
-          <p:cNvSpPr txBox="1"/>
-          <p:nvPr/>
-        </p:nvSpPr>
-        <p:spPr>
-          <a:xfrm>
-            <a:off x="749808" y="4644898"/>
+          <p:cNvPr id="17" name="label"/>
+          <p:cNvSpPr txBox="1"/>
+          <p:nvPr/>
+        </p:nvSpPr>
+        <p:spPr>
+          <a:xfrm>
+            <a:off x="749808" y="4497705"/>
             <a:ext cx="5052060" cy="219456"/>
           </a:xfrm>
           <a:prstGeom prst="rect">
@@ -15949,14 +15913,14 @@
       </p:sp>
       <p:sp>
         <p:nvSpPr>
-          <p:cNvPr id="19" name="Text 16"/>
-          <p:cNvSpPr txBox="1"/>
-          <p:nvPr/>
-        </p:nvSpPr>
-        <p:spPr>
-          <a:xfrm>
-            <a:off x="749808" y="4946650"/>
-            <a:ext cx="5052060" cy="603758"/>
+          <p:cNvPr id="18" name="Text 15"/>
+          <p:cNvSpPr txBox="1"/>
+          <p:nvPr/>
+        </p:nvSpPr>
+        <p:spPr>
+          <a:xfrm>
+            <a:off x="749808" y="4799457"/>
+            <a:ext cx="5052060" cy="750951"/>
           </a:xfrm>
           <a:prstGeom prst="rect">
             <a:avLst/>
@@ -15972,7 +15936,7 @@
               <a:buNone/>
             </a:pPr>
             <a:r>
-              <a:rPr lang="en-US" sz="1100" dirty="0">
+              <a:rPr lang="en-US" sz="1100" b="1" dirty="0">
                 <a:solidFill>
                   <a:schemeClr val="tx1"/>
                 </a:solidFill>
@@ -15985,14 +15949,14 @@
       </p:sp>
       <p:sp>
         <p:nvSpPr>
-          <p:cNvPr id="20" name="transition to other workflows card"/>
+          <p:cNvPr id="19" name="transition to other workflows card"/>
           <p:cNvSpPr/>
           <p:nvPr/>
         </p:nvSpPr>
         <p:spPr>
           <a:xfrm>
-            <a:off x="6185916" y="4507738"/>
-            <a:ext cx="5454396" cy="1143254"/>
+            <a:off x="6185916" y="4360545"/>
+            <a:ext cx="5454396" cy="1290447"/>
           </a:xfrm>
           <a:prstGeom prst="rect">
             <a:avLst/>
@@ -16012,13 +15976,13 @@
       </p:sp>
       <p:sp>
         <p:nvSpPr>
-          <p:cNvPr id="21" name="label"/>
-          <p:cNvSpPr txBox="1"/>
-          <p:nvPr/>
-        </p:nvSpPr>
-        <p:spPr>
-          <a:xfrm>
-            <a:off x="6387084" y="4644898"/>
+          <p:cNvPr id="20" name="label"/>
+          <p:cNvSpPr txBox="1"/>
+          <p:nvPr/>
+        </p:nvSpPr>
+        <p:spPr>
+          <a:xfrm>
+            <a:off x="6387084" y="4497705"/>
             <a:ext cx="5052060" cy="219456"/>
           </a:xfrm>
           <a:prstGeom prst="rect">
@@ -16048,14 +16012,14 @@
       </p:sp>
       <p:sp>
         <p:nvSpPr>
-          <p:cNvPr id="22" name="Text 19"/>
-          <p:cNvSpPr txBox="1"/>
-          <p:nvPr/>
-        </p:nvSpPr>
-        <p:spPr>
-          <a:xfrm>
-            <a:off x="6387084" y="4946650"/>
-            <a:ext cx="5052060" cy="603758"/>
+          <p:cNvPr id="21" name="Text 18"/>
+          <p:cNvSpPr txBox="1"/>
+          <p:nvPr/>
+        </p:nvSpPr>
+        <p:spPr>
+          <a:xfrm>
+            <a:off x="6387084" y="4799457"/>
+            <a:ext cx="5052060" cy="750951"/>
           </a:xfrm>
           <a:prstGeom prst="rect">
             <a:avLst/>
@@ -16071,7 +16035,7 @@
               <a:buNone/>
             </a:pPr>
             <a:r>
-              <a:rPr lang="en-US" sz="1100" dirty="0">
+              <a:rPr lang="en-US" sz="1100" b="1" dirty="0">
                 <a:solidFill>
                   <a:schemeClr val="tx1"/>
                 </a:solidFill>
@@ -16084,7 +16048,7 @@
       </p:sp>
       <p:sp>
         <p:nvSpPr>
-          <p:cNvPr id="23" name="evidence boundary"/>
+          <p:cNvPr id="22" name="evidence boundary"/>
           <p:cNvSpPr txBox="1"/>
           <p:nvPr/>
         </p:nvSpPr>
@@ -16747,7 +16711,7 @@
                     <a:bodyPr/>
                     <a:lstStyle/>
                     <a:p>
-                      <a:pPr indent="0" marL="0">
+                      <a:pPr algn="l" indent="0" marL="0">
                         <a:buNone/>
                       </a:pPr>
                       <a:r>
@@ -16906,7 +16870,7 @@
                     <a:bodyPr/>
                     <a:lstStyle/>
                     <a:p>
-                      <a:pPr indent="0" marL="0">
+                      <a:pPr algn="l" indent="0" marL="0">
                         <a:buNone/>
                       </a:pPr>
                       <a:r>
@@ -17126,7 +17090,7 @@
                     <a:bodyPr/>
                     <a:lstStyle/>
                     <a:p>
-                      <a:pPr indent="0" marL="0">
+                      <a:pPr algn="l" indent="0" marL="0">
                         <a:buNone/>
                       </a:pPr>
                       <a:r>
@@ -18036,7 +18000,7 @@
                     <a:bodyPr/>
                     <a:lstStyle/>
                     <a:p>
-                      <a:pPr indent="0" marL="0">
+                      <a:pPr algn="l" indent="0" marL="0">
                         <a:buNone/>
                       </a:pPr>
                       <a:r>
@@ -18195,7 +18159,7 @@
                     <a:bodyPr/>
                     <a:lstStyle/>
                     <a:p>
-                      <a:pPr indent="0" marL="0">
+                      <a:pPr algn="l" indent="0" marL="0">
                         <a:buNone/>
                       </a:pPr>
                       <a:r>
@@ -18376,7 +18340,7 @@
                     <a:bodyPr/>
                     <a:lstStyle/>
                     <a:p>
-                      <a:pPr indent="0" marL="0">
+                      <a:pPr algn="l" indent="0" marL="0">
                         <a:buNone/>
                       </a:pPr>
                       <a:r>

</xml_diff>

<commit_message>
Rename Slide 7 questions card and rebalance table spacing
Co-Authored-By: Claude Opus 5.5 <noreply@anthropic.com>
Claude-Session: https://claude.ai/code/session_0198bm9pfzRwgZQBqNvd56W8
</commit_message>
<xml_diff>
--- a/deck/Optum-LS-Conversational-AI.pptx
+++ b/deck/Optum-LS-Conversational-AI.pptx
@@ -117,27 +117,27 @@
   <p:extLst>
     <p:ext uri="{521415D9-36F7-43E2-AB2F-B90AF26B5E84}">
       <p14:sectionLst xmlns:p14="http://schemas.microsoft.com/office/powerpoint/2010/main">
-        <p14:section name="Executive summary" id="{4165ea33-acdb-ec71-2c20-c86f5af95c31}">
+        <p14:section name="Executive summary" id="{6c9bfa8d-7a5b-09e7-e6d0-dd79a7347360}">
           <p14:sldIdLst>
             <p14:sldId id="256"/>
           </p14:sldIdLst>
         </p14:section>
-        <p14:section name="Research catalyst" id="{f6194a28-4d36-149b-aa31-ffb23280dc7c}">
+        <p14:section name="Research catalyst" id="{68104345-790d-2f27-2fcd-16c33f9462b2}">
           <p14:sldIdLst>
             <p14:sldId id="257"/>
           </p14:sldIdLst>
         </p14:section>
-        <p14:section name="U.S. competitive landscape" id="{74229e6b-8a28-2b61-aad1-d70652567e15}">
+        <p14:section name="U.S. competitive landscape" id="{c37692eb-cf14-6596-400f-ca1c44bbc423}">
           <p14:sldIdLst>
             <p14:sldId id="258"/>
           </p14:sldIdLst>
         </p14:section>
-        <p14:section name="International competitor screens" id="{94f5a2b6-dfc3-83df-13b3-adaeb6c0b68e}">
+        <p14:section name="International competitor screens" id="{0629baca-5c82-7587-5021-b735ecd3d57c}">
           <p14:sldIdLst>
             <p14:sldId id="259"/>
           </p14:sldIdLst>
         </p14:section>
-        <p14:section name="Workflow deep dives" id="{3cec758c-60d9-4c4a-fc8a-0c16bcb617ef}">
+        <p14:section name="Workflow deep dives" id="{6c0e562b-7c67-2658-eea1-18e609ff666e}">
           <p14:sldIdLst>
             <p14:sldId id="260"/>
             <p14:sldId id="261"/>
@@ -146,12 +146,12 @@
             <p14:sldId id="264"/>
           </p14:sldIdLst>
         </p14:section>
-        <p14:section name="AI suppliers" id="{d5e86b82-eb15-b3dd-551a-ac696039c221}">
+        <p14:section name="AI suppliers" id="{ac7aa4ba-e4c9-ac02-a215-dd374a338166}">
           <p14:sldIdLst>
             <p14:sldId id="265"/>
           </p14:sldIdLst>
         </p14:section>
-        <p14:section name="Methodology note" id="{a790dcfc-235c-969f-9a47-1ee105ea7c54}">
+        <p14:section name="Methodology note" id="{af69f129-19c6-f317-f6a6-c70124360a7c}">
           <p14:sldIdLst>
             <p14:sldId id="266"/>
           </p14:sldIdLst>
@@ -6814,7 +6814,7 @@
         <p:spPr>
           <a:xfrm>
             <a:off x="749808" y="4443984"/>
-            <a:ext cx="3172968" cy="1051560"/>
+            <a:ext cx="3172968" cy="1106424"/>
           </a:xfrm>
           <a:prstGeom prst="rect">
             <a:avLst/>
@@ -6913,7 +6913,7 @@
         <p:spPr>
           <a:xfrm>
             <a:off x="4507992" y="4443984"/>
-            <a:ext cx="3172968" cy="1051560"/>
+            <a:ext cx="3172968" cy="1106424"/>
           </a:xfrm>
           <a:prstGeom prst="rect">
             <a:avLst/>
@@ -7012,7 +7012,7 @@
         <p:spPr>
           <a:xfrm>
             <a:off x="8266176" y="4443984"/>
-            <a:ext cx="3172968" cy="1051560"/>
+            <a:ext cx="3172968" cy="1106424"/>
           </a:xfrm>
           <a:prstGeom prst="rect">
             <a:avLst/>
@@ -12899,7 +12899,7 @@
         <p:spPr>
           <a:xfrm>
             <a:off x="749808" y="4659376"/>
-            <a:ext cx="10689336" cy="891032"/>
+            <a:ext cx="10689336" cy="945896"/>
           </a:xfrm>
           <a:prstGeom prst="rect">
             <a:avLst/>
@@ -14299,7 +14299,7 @@
         <p:spPr>
           <a:xfrm>
             <a:off x="749808" y="4702175"/>
-            <a:ext cx="5052060" cy="848233"/>
+            <a:ext cx="5052060" cy="903097"/>
           </a:xfrm>
           <a:prstGeom prst="rect">
             <a:avLst/>
@@ -14398,7 +14398,7 @@
         <p:spPr>
           <a:xfrm>
             <a:off x="6387084" y="4519295"/>
-            <a:ext cx="5052060" cy="1031113"/>
+            <a:ext cx="5052060" cy="1085977"/>
           </a:xfrm>
           <a:prstGeom prst="rect">
             <a:avLst/>
@@ -15084,7 +15084,7 @@
                   </a:tcPr>
                 </a:tc>
               </a:tr>
-              <a:tr h="734187">
+              <a:tr h="862203">
                 <a:tc>
                   <a:txBody>
                     <a:bodyPr/>
@@ -15365,7 +15365,7 @@
                   </a:tcPr>
                 </a:tc>
               </a:tr>
-              <a:tr h="734187">
+              <a:tr h="862203">
                 <a:tc>
                   <a:txBody>
                     <a:bodyPr/>
@@ -15624,7 +15624,7 @@
                   </a:tcPr>
                 </a:tc>
               </a:tr>
-              <a:tr h="624459">
+              <a:tr h="752475">
                 <a:tc>
                   <a:txBody>
                     <a:bodyPr/>
@@ -15850,14 +15850,14 @@
       </p:graphicFrame>
       <p:sp>
         <p:nvSpPr>
-          <p:cNvPr id="16" name="questions for comparison card"/>
+          <p:cNvPr id="16" name="beyond the public evidence card"/>
           <p:cNvSpPr/>
           <p:nvPr/>
         </p:nvSpPr>
         <p:spPr>
           <a:xfrm>
-            <a:off x="548640" y="4360545"/>
-            <a:ext cx="5454396" cy="1290447"/>
+            <a:off x="548640" y="4689729"/>
+            <a:ext cx="5454396" cy="1034415"/>
           </a:xfrm>
           <a:prstGeom prst="rect">
             <a:avLst/>
@@ -15883,7 +15883,7 @@
         </p:nvSpPr>
         <p:spPr>
           <a:xfrm>
-            <a:off x="749808" y="4497705"/>
+            <a:off x="749808" y="4781169"/>
             <a:ext cx="5052060" cy="219456"/>
           </a:xfrm>
           <a:prstGeom prst="rect">
@@ -15905,7 +15905,7 @@
                   <a:schemeClr val="accent2"/>
                 </a:solidFill>
               </a:rPr>
-              <a:t>QUESTIONS FOR COMPARISON</a:t>
+              <a:t>BEYOND THE PUBLIC EVIDENCE</a:t>
             </a:r>
             <a:endParaRPr lang="en-US" sz="1000" dirty="0"/>
           </a:p>
@@ -15919,8 +15919,8 @@
         </p:nvSpPr>
         <p:spPr>
           <a:xfrm>
-            <a:off x="749808" y="4799457"/>
-            <a:ext cx="5052060" cy="750951"/>
+            <a:off x="749808" y="5018913"/>
+            <a:ext cx="5052060" cy="659511"/>
           </a:xfrm>
           <a:prstGeom prst="rect">
             <a:avLst/>
@@ -15936,14 +15936,14 @@
               <a:buNone/>
             </a:pPr>
             <a:r>
-              <a:rPr lang="en-US" sz="1100" b="1" dirty="0">
+              <a:rPr lang="en-US" sz="1050" b="1" dirty="0">
                 <a:solidFill>
                   <a:schemeClr val="tx1"/>
                 </a:solidFill>
               </a:rPr>
               <a:t>Which decisions are these products designed to support? What underlying commercial information can users access? Where does an assistant move beyond analytics into field execution or simulated research?</a:t>
             </a:r>
-            <a:endParaRPr lang="en-US" sz="1100" dirty="0"/>
+            <a:endParaRPr lang="en-US" sz="1050" dirty="0"/>
           </a:p>
         </p:txBody>
       </p:sp>
@@ -15955,8 +15955,8 @@
         </p:nvSpPr>
         <p:spPr>
           <a:xfrm>
-            <a:off x="6185916" y="4360545"/>
-            <a:ext cx="5454396" cy="1290447"/>
+            <a:off x="6185916" y="4689729"/>
+            <a:ext cx="5454396" cy="1034415"/>
           </a:xfrm>
           <a:prstGeom prst="rect">
             <a:avLst/>
@@ -15982,7 +15982,7 @@
         </p:nvSpPr>
         <p:spPr>
           <a:xfrm>
-            <a:off x="6387084" y="4497705"/>
+            <a:off x="6387084" y="4781169"/>
             <a:ext cx="5052060" cy="219456"/>
           </a:xfrm>
           <a:prstGeom prst="rect">
@@ -16018,8 +16018,8 @@
         </p:nvSpPr>
         <p:spPr>
           <a:xfrm>
-            <a:off x="6387084" y="4799457"/>
-            <a:ext cx="5052060" cy="750951"/>
+            <a:off x="6387084" y="5018913"/>
+            <a:ext cx="5052060" cy="659511"/>
           </a:xfrm>
           <a:prstGeom prst="rect">
             <a:avLst/>
@@ -16035,14 +16035,14 @@
               <a:buNone/>
             </a:pPr>
             <a:r>
-              <a:rPr lang="en-US" sz="1100" b="1" dirty="0">
+              <a:rPr lang="en-US" sz="1050" b="1" dirty="0">
                 <a:solidFill>
                   <a:schemeClr val="tx1"/>
                 </a:solidFill>
               </a:rPr>
               <a:t>How does the comparison change for medical affairs, clinical development and market access, where the intended users, evidence requirements and decisions differ?</a:t>
             </a:r>
-            <a:endParaRPr lang="en-US" sz="1100" dirty="0"/>
+            <a:endParaRPr lang="en-US" sz="1050" dirty="0"/>
           </a:p>
         </p:txBody>
       </p:sp>
@@ -16054,7 +16054,7 @@
         </p:nvSpPr>
         <p:spPr>
           <a:xfrm>
-            <a:off x="548640" y="5760720"/>
+            <a:off x="548640" y="5815584"/>
             <a:ext cx="11091672" cy="384048"/>
           </a:xfrm>
           <a:prstGeom prst="rect">
@@ -17319,7 +17319,7 @@
         <p:spPr>
           <a:xfrm>
             <a:off x="749808" y="4696841"/>
-            <a:ext cx="10689336" cy="853567"/>
+            <a:ext cx="10689336" cy="908431"/>
           </a:xfrm>
           <a:prstGeom prst="rect">
             <a:avLst/>
@@ -18569,7 +18569,7 @@
         <p:spPr>
           <a:xfrm>
             <a:off x="749808" y="4409567"/>
-            <a:ext cx="10689336" cy="1140841"/>
+            <a:ext cx="10689336" cy="1195705"/>
           </a:xfrm>
           <a:prstGeom prst="rect">
             <a:avLst/>

</xml_diff>

<commit_message>
Revise Slide 2 timeline and Slides 5-9 tables and cards
Slide 2: company-prefixed product names, month tags for 2024, drops the
intro line and broader-signal card. Slides 5-9: centered headers and
tasks, plain country tags, BEYOND THE PUBLIC EVIDENCE cards with bold,
vertically centered text sized to content; Slide 9 split into clinical
trials and market access tables.

Co-Authored-By: Claude Opus 5.5 <noreply@anthropic.com>
Claude-Session: https://claude.ai/code/session_0198bm9pfzRwgZQBqNvd56W8
</commit_message>
<xml_diff>
--- a/deck/Optum-LS-Conversational-AI.pptx
+++ b/deck/Optum-LS-Conversational-AI.pptx
@@ -117,27 +117,27 @@
   <p:extLst>
     <p:ext uri="{521415D9-36F7-43E2-AB2F-B90AF26B5E84}">
       <p14:sectionLst xmlns:p14="http://schemas.microsoft.com/office/powerpoint/2010/main">
-        <p14:section name="Executive summary" id="{6c9bfa8d-7a5b-09e7-e6d0-dd79a7347360}">
+        <p14:section name="Executive summary" id="{1143a9a4-3204-d4be-ee70-8946b8dae713}">
           <p14:sldIdLst>
             <p14:sldId id="256"/>
           </p14:sldIdLst>
         </p14:section>
-        <p14:section name="Research catalyst" id="{68104345-790d-2f27-2fcd-16c33f9462b2}">
+        <p14:section name="Research catalyst" id="{9203be9a-9172-1ff0-49c3-bd50e2d5d770}">
           <p14:sldIdLst>
             <p14:sldId id="257"/>
           </p14:sldIdLst>
         </p14:section>
-        <p14:section name="U.S. competitive landscape" id="{c37692eb-cf14-6596-400f-ca1c44bbc423}">
+        <p14:section name="U.S. competitive landscape" id="{a9fd9fa7-5e03-3ad6-b66e-a14772e22cb3}">
           <p14:sldIdLst>
             <p14:sldId id="258"/>
           </p14:sldIdLst>
         </p14:section>
-        <p14:section name="International competitor screens" id="{0629baca-5c82-7587-5021-b735ecd3d57c}">
+        <p14:section name="International competitor screens" id="{1abdbefb-206b-8983-571b-cf9f40ec2b15}">
           <p14:sldIdLst>
             <p14:sldId id="259"/>
           </p14:sldIdLst>
         </p14:section>
-        <p14:section name="Workflow deep dives" id="{6c0e562b-7c67-2658-eea1-18e609ff666e}">
+        <p14:section name="Workflow deep dives" id="{8dddd3fc-4aec-8d47-ee6c-9ac5269d35e9}">
           <p14:sldIdLst>
             <p14:sldId id="260"/>
             <p14:sldId id="261"/>
@@ -146,12 +146,12 @@
             <p14:sldId id="264"/>
           </p14:sldIdLst>
         </p14:section>
-        <p14:section name="AI suppliers" id="{ac7aa4ba-e4c9-ac02-a215-dd374a338166}">
+        <p14:section name="AI suppliers" id="{5fe9d585-6911-eb84-2885-14beba9812a3}">
           <p14:sldIdLst>
             <p14:sldId id="265"/>
           </p14:sldIdLst>
         </p14:section>
-        <p14:section name="Methodology note" id="{af69f129-19c6-f317-f6a6-c70124360a7c}">
+        <p14:section name="Methodology note" id="{ad12b04c-4fa3-4ca4-f089-1382db1946a7}">
           <p14:sldIdLst>
             <p14:sldId id="266"/>
           </p14:sldIdLst>
@@ -5989,14 +5989,14 @@
       </p:sp>
       <p:sp>
         <p:nvSpPr>
-          <p:cNvPr id="4" name="Text 2"/>
+          <p:cNvPr id="4" name="label"/>
           <p:cNvSpPr txBox="1"/>
           <p:nvPr/>
         </p:nvSpPr>
         <p:spPr>
           <a:xfrm>
-            <a:off x="548640" y="1389888"/>
-            <a:ext cx="11091672" cy="228600"/>
+            <a:off x="548640" y="1536192"/>
+            <a:ext cx="7315200" cy="201168"/>
           </a:xfrm>
           <a:prstGeom prst="rect">
             <a:avLst/>
@@ -6012,42 +6012,6 @@
               <a:buNone/>
             </a:pPr>
             <a:r>
-              <a:rPr lang="en-US" sz="1200" dirty="0">
-                <a:solidFill>
-                  <a:schemeClr val="tx1"/>
-                </a:solidFill>
-              </a:rPr>
-              <a:t>A series of public announcements brought greater attention to natural-language access to healthcare data, cohort exploration and research workflows.</a:t>
-            </a:r>
-            <a:endParaRPr lang="en-US" sz="1200" dirty="0"/>
-          </a:p>
-        </p:txBody>
-      </p:sp>
-      <p:sp>
-        <p:nvSpPr>
-          <p:cNvPr id="5" name="label"/>
-          <p:cNvSpPr txBox="1"/>
-          <p:nvPr/>
-        </p:nvSpPr>
-        <p:spPr>
-          <a:xfrm>
-            <a:off x="548640" y="1755648"/>
-            <a:ext cx="7315200" cy="201168"/>
-          </a:xfrm>
-          <a:prstGeom prst="rect">
-            <a:avLst/>
-          </a:prstGeom>
-          <a:noFill/>
-          <a:ln/>
-        </p:spPr>
-        <p:txBody>
-          <a:bodyPr wrap="square" lIns="0" tIns="0" rIns="0" bIns="0" rtlCol="0" anchor="t"/>
-          <a:lstStyle/>
-          <a:p>
-            <a:pPr indent="0" marL="0">
-              <a:buNone/>
-            </a:pPr>
-            <a:r>
               <a:rPr lang="en-US" sz="1000" b="1" spc="100" kern="0" dirty="0">
                 <a:solidFill>
                   <a:schemeClr val="accent2"/>
@@ -6061,13 +6025,13 @@
       </p:sp>
       <p:sp>
         <p:nvSpPr>
-          <p:cNvPr id="6" name="timeline"/>
+          <p:cNvPr id="5" name="timeline"/>
           <p:cNvSpPr/>
           <p:nvPr/>
         </p:nvSpPr>
         <p:spPr>
           <a:xfrm>
-            <a:off x="548640" y="2615184"/>
+            <a:off x="548640" y="2450592"/>
             <a:ext cx="11091672" cy="0"/>
           </a:xfrm>
           <a:prstGeom prst="line">
@@ -6084,14 +6048,50 @@
       </p:sp>
       <p:sp>
         <p:nvSpPr>
+          <p:cNvPr id="6" name="Text 4"/>
+          <p:cNvSpPr txBox="1"/>
+          <p:nvPr/>
+        </p:nvSpPr>
+        <p:spPr>
+          <a:xfrm>
+            <a:off x="548640" y="1828800"/>
+            <a:ext cx="2590038" cy="274320"/>
+          </a:xfrm>
+          <a:prstGeom prst="rect">
+            <a:avLst/>
+          </a:prstGeom>
+          <a:noFill/>
+          <a:ln/>
+        </p:spPr>
+        <p:txBody>
+          <a:bodyPr wrap="square" lIns="0" tIns="0" rIns="0" bIns="0" rtlCol="0" anchor="t"/>
+          <a:lstStyle/>
+          <a:p>
+            <a:pPr indent="0" marL="0">
+              <a:buNone/>
+            </a:pPr>
+            <a:r>
+              <a:rPr lang="en-US" sz="1500" b="1" dirty="0">
+                <a:solidFill>
+                  <a:schemeClr val="accent1"/>
+                </a:solidFill>
+              </a:rPr>
+              <a:t>2024</a:t>
+            </a:r>
+            <a:endParaRPr lang="en-US" sz="1500" dirty="0"/>
+          </a:p>
+        </p:txBody>
+      </p:sp>
+      <p:sp>
+        <p:nvSpPr>
           <p:cNvPr id="7" name="Text 5"/>
           <p:cNvSpPr txBox="1"/>
           <p:nvPr/>
         </p:nvSpPr>
         <p:spPr>
           <a:xfrm>
-            <a:off x="548640" y="2011680"/>
-            <a:ext cx="2590038" cy="274320"/>
+            <a:off x="548640" y="2103120"/>
+            <a:ext cx="2590038" cy="201168"/>
           </a:xfrm>
           <a:prstGeom prst="rect">
             <a:avLst/>
@@ -6107,42 +6107,6 @@
               <a:buNone/>
             </a:pPr>
             <a:r>
-              <a:rPr lang="en-US" sz="1500" b="1" dirty="0">
-                <a:solidFill>
-                  <a:schemeClr val="accent1"/>
-                </a:solidFill>
-              </a:rPr>
-              <a:t>2024</a:t>
-            </a:r>
-            <a:endParaRPr lang="en-US" sz="1500" dirty="0"/>
-          </a:p>
-        </p:txBody>
-      </p:sp>
-      <p:sp>
-        <p:nvSpPr>
-          <p:cNvPr id="8" name="Text 6"/>
-          <p:cNvSpPr txBox="1"/>
-          <p:nvPr/>
-        </p:nvSpPr>
-        <p:spPr>
-          <a:xfrm>
-            <a:off x="548640" y="2286000"/>
-            <a:ext cx="2590038" cy="201168"/>
-          </a:xfrm>
-          <a:prstGeom prst="rect">
-            <a:avLst/>
-          </a:prstGeom>
-          <a:noFill/>
-          <a:ln/>
-        </p:spPr>
-        <p:txBody>
-          <a:bodyPr wrap="square" lIns="0" tIns="0" rIns="0" bIns="0" rtlCol="0" anchor="t"/>
-          <a:lstStyle/>
-          <a:p>
-            <a:pPr indent="0" marL="0">
-              <a:buNone/>
-            </a:pPr>
-            <a:r>
               <a:rPr lang="en-US" sz="1000" i="1" dirty="0">
                 <a:solidFill>
                   <a:schemeClr val="accent4"/>
@@ -6156,13 +6120,13 @@
       </p:sp>
       <p:sp>
         <p:nvSpPr>
-          <p:cNvPr id="9" name="milestone"/>
+          <p:cNvPr id="8" name="milestone"/>
           <p:cNvSpPr/>
           <p:nvPr/>
         </p:nvSpPr>
         <p:spPr>
           <a:xfrm>
-            <a:off x="548640" y="2532888"/>
+            <a:off x="548640" y="2368296"/>
             <a:ext cx="164592" cy="164592"/>
           </a:xfrm>
           <a:prstGeom prst="ellipse">
@@ -6181,14 +6145,111 @@
       </p:sp>
       <p:sp>
         <p:nvSpPr>
+          <p:cNvPr id="9" name="Text 7"/>
+          <p:cNvSpPr txBox="1"/>
+          <p:nvPr/>
+        </p:nvSpPr>
+        <p:spPr>
+          <a:xfrm>
+            <a:off x="548640" y="2615184"/>
+            <a:ext cx="2544318" cy="1371600"/>
+          </a:xfrm>
+          <a:prstGeom prst="rect">
+            <a:avLst/>
+          </a:prstGeom>
+          <a:noFill/>
+          <a:ln/>
+        </p:spPr>
+        <p:txBody>
+          <a:bodyPr wrap="square" lIns="0" tIns="0" rIns="0" bIns="0" rtlCol="0" anchor="t"/>
+          <a:lstStyle/>
+          <a:p>
+            <a:pPr indent="0" marL="0">
+              <a:buNone/>
+            </a:pPr>
+            <a:r>
+              <a:rPr lang="en-US" sz="1050" dirty="0">
+                <a:solidFill>
+                  <a:schemeClr val="tx1"/>
+                </a:solidFill>
+              </a:rPr>
+              <a:t>Tempus’s </a:t>
+            </a:r>
+            <a:pPr indent="0" marL="0">
+              <a:buNone/>
+            </a:pPr>
+            <a:r>
+              <a:rPr lang="en-US" sz="1050" b="1" dirty="0">
+                <a:solidFill>
+                  <a:schemeClr val="tx1"/>
+                </a:solidFill>
+              </a:rPr>
+              <a:t>Tempus One / Lens</a:t>
+            </a:r>
+            <a:pPr indent="0" marL="0">
+              <a:buNone/>
+            </a:pPr>
+            <a:r>
+              <a:rPr lang="en-US" sz="1050" dirty="0">
+                <a:solidFill>
+                  <a:schemeClr val="tx1"/>
+                </a:solidFill>
+              </a:rPr>
+              <a:t> — AI-assisted research and cohort exploration (February)</a:t>
+            </a:r>
+            <a:endParaRPr lang="en-US" sz="1050" dirty="0"/>
+          </a:p>
+          <a:p>
+            <a:pPr indent="0" marL="0">
+              <a:spcBef>
+                <a:spcPts val="800"/>
+              </a:spcBef>
+              <a:buNone/>
+            </a:pPr>
+            <a:r>
+              <a:rPr lang="en-US" sz="1050" dirty="0">
+                <a:solidFill>
+                  <a:schemeClr val="tx1"/>
+                </a:solidFill>
+              </a:rPr>
+              <a:t>Komodo Health’s </a:t>
+            </a:r>
+            <a:pPr indent="0" marL="0">
+              <a:buNone/>
+            </a:pPr>
+            <a:r>
+              <a:rPr lang="en-US" sz="1050" b="1" dirty="0">
+                <a:solidFill>
+                  <a:schemeClr val="tx1"/>
+                </a:solidFill>
+              </a:rPr>
+              <a:t>MapAI</a:t>
+            </a:r>
+            <a:pPr indent="0" marL="0">
+              <a:buNone/>
+            </a:pPr>
+            <a:r>
+              <a:rPr lang="en-US" sz="1050" dirty="0">
+                <a:solidFill>
+                  <a:schemeClr val="tx1"/>
+                </a:solidFill>
+              </a:rPr>
+              <a:t> — conversational healthcare analytics (September)</a:t>
+            </a:r>
+            <a:endParaRPr lang="en-US" sz="1050" dirty="0"/>
+          </a:p>
+        </p:txBody>
+      </p:sp>
+      <p:sp>
+        <p:nvSpPr>
           <p:cNvPr id="10" name="Text 8"/>
           <p:cNvSpPr txBox="1"/>
           <p:nvPr/>
         </p:nvSpPr>
         <p:spPr>
           <a:xfrm>
-            <a:off x="548640" y="2788920"/>
-            <a:ext cx="2544318" cy="1051560"/>
+            <a:off x="3321558" y="1828800"/>
+            <a:ext cx="2590038" cy="274320"/>
           </a:xfrm>
           <a:prstGeom prst="rect">
             <a:avLst/>
@@ -6204,53 +6265,14 @@
               <a:buNone/>
             </a:pPr>
             <a:r>
-              <a:rPr lang="en-US" sz="1000" b="1" dirty="0">
-                <a:solidFill>
-                  <a:schemeClr val="tx1"/>
-                </a:solidFill>
-              </a:rPr>
-              <a:t>February:</a:t>
-            </a:r>
-            <a:pPr indent="0" marL="0">
-              <a:buNone/>
-            </a:pPr>
-            <a:r>
-              <a:rPr lang="en-US" sz="1000" dirty="0">
-                <a:solidFill>
-                  <a:schemeClr val="tx1"/>
-                </a:solidFill>
-              </a:rPr>
-              <a:t> Tempus One / Lens — AI-assisted research and cohort exploration</a:t>
-            </a:r>
-            <a:endParaRPr lang="en-US" sz="1000" dirty="0"/>
-          </a:p>
-          <a:p>
-            <a:pPr indent="0" marL="0">
-              <a:spcBef>
-                <a:spcPts val="600"/>
-              </a:spcBef>
-              <a:buNone/>
-            </a:pPr>
-            <a:r>
-              <a:rPr lang="en-US" sz="1000" b="1" dirty="0">
-                <a:solidFill>
-                  <a:schemeClr val="tx1"/>
-                </a:solidFill>
-              </a:rPr>
-              <a:t>September:</a:t>
-            </a:r>
-            <a:pPr indent="0" marL="0">
-              <a:buNone/>
-            </a:pPr>
-            <a:r>
-              <a:rPr lang="en-US" sz="1000" dirty="0">
-                <a:solidFill>
-                  <a:schemeClr val="tx1"/>
-                </a:solidFill>
-              </a:rPr>
-              <a:t> Komodo MapAI — conversational healthcare analytics</a:t>
-            </a:r>
-            <a:endParaRPr lang="en-US" sz="1000" dirty="0"/>
+              <a:rPr lang="en-US" sz="1500" b="1" dirty="0">
+                <a:solidFill>
+                  <a:schemeClr val="accent1"/>
+                </a:solidFill>
+              </a:rPr>
+              <a:t>August 2025</a:t>
+            </a:r>
+            <a:endParaRPr lang="en-US" sz="1500" dirty="0"/>
           </a:p>
         </p:txBody>
       </p:sp>
@@ -6262,8 +6284,8 @@
         </p:nvSpPr>
         <p:spPr>
           <a:xfrm>
-            <a:off x="3321558" y="2011680"/>
-            <a:ext cx="2590038" cy="274320"/>
+            <a:off x="3321558" y="2103120"/>
+            <a:ext cx="2590038" cy="201168"/>
           </a:xfrm>
           <a:prstGeom prst="rect">
             <a:avLst/>
@@ -6279,42 +6301,6 @@
               <a:buNone/>
             </a:pPr>
             <a:r>
-              <a:rPr lang="en-US" sz="1500" b="1" dirty="0">
-                <a:solidFill>
-                  <a:schemeClr val="accent1"/>
-                </a:solidFill>
-              </a:rPr>
-              <a:t>August 2025</a:t>
-            </a:r>
-            <a:endParaRPr lang="en-US" sz="1500" dirty="0"/>
-          </a:p>
-        </p:txBody>
-      </p:sp>
-      <p:sp>
-        <p:nvSpPr>
-          <p:cNvPr id="12" name="Text 10"/>
-          <p:cNvSpPr txBox="1"/>
-          <p:nvPr/>
-        </p:nvSpPr>
-        <p:spPr>
-          <a:xfrm>
-            <a:off x="3321558" y="2286000"/>
-            <a:ext cx="2590038" cy="201168"/>
-          </a:xfrm>
-          <a:prstGeom prst="rect">
-            <a:avLst/>
-          </a:prstGeom>
-          <a:noFill/>
-          <a:ln/>
-        </p:spPr>
-        <p:txBody>
-          <a:bodyPr wrap="square" lIns="0" tIns="0" rIns="0" bIns="0" rtlCol="0" anchor="t"/>
-          <a:lstStyle/>
-          <a:p>
-            <a:pPr indent="0" marL="0">
-              <a:buNone/>
-            </a:pPr>
-            <a:r>
               <a:rPr lang="en-US" sz="1000" i="1" dirty="0">
                 <a:solidFill>
                   <a:schemeClr val="accent4"/>
@@ -6328,13 +6314,13 @@
       </p:sp>
       <p:sp>
         <p:nvSpPr>
-          <p:cNvPr id="13" name="milestone"/>
+          <p:cNvPr id="12" name="milestone"/>
           <p:cNvSpPr/>
           <p:nvPr/>
         </p:nvSpPr>
         <p:spPr>
           <a:xfrm>
-            <a:off x="3321558" y="2532888"/>
+            <a:off x="3321558" y="2368296"/>
             <a:ext cx="164592" cy="164592"/>
           </a:xfrm>
           <a:prstGeom prst="ellipse">
@@ -6353,14 +6339,72 @@
       </p:sp>
       <p:sp>
         <p:nvSpPr>
+          <p:cNvPr id="13" name="Text 11"/>
+          <p:cNvSpPr txBox="1"/>
+          <p:nvPr/>
+        </p:nvSpPr>
+        <p:spPr>
+          <a:xfrm>
+            <a:off x="3321558" y="2615184"/>
+            <a:ext cx="2544318" cy="1371600"/>
+          </a:xfrm>
+          <a:prstGeom prst="rect">
+            <a:avLst/>
+          </a:prstGeom>
+          <a:noFill/>
+          <a:ln/>
+        </p:spPr>
+        <p:txBody>
+          <a:bodyPr wrap="square" lIns="0" tIns="0" rIns="0" bIns="0" rtlCol="0" anchor="t"/>
+          <a:lstStyle/>
+          <a:p>
+            <a:pPr indent="0" marL="0">
+              <a:buNone/>
+            </a:pPr>
+            <a:r>
+              <a:rPr lang="en-US" sz="1050" dirty="0">
+                <a:solidFill>
+                  <a:schemeClr val="tx1"/>
+                </a:solidFill>
+              </a:rPr>
+              <a:t>Komodo Health’s </a:t>
+            </a:r>
+            <a:pPr indent="0" marL="0">
+              <a:buNone/>
+            </a:pPr>
+            <a:r>
+              <a:rPr lang="en-US" sz="1050" b="1" dirty="0">
+                <a:solidFill>
+                  <a:schemeClr val="tx1"/>
+                </a:solidFill>
+              </a:rPr>
+              <a:t>Marmot</a:t>
+            </a:r>
+            <a:pPr indent="0" marL="0">
+              <a:buNone/>
+            </a:pPr>
+            <a:r>
+              <a:rPr lang="en-US" sz="1050" dirty="0">
+                <a:solidFill>
+                  <a:schemeClr val="tx1"/>
+                </a:solidFill>
+              </a:rPr>
+              <a:t> — AI-powered healthcare analytics and research workflows</a:t>
+            </a:r>
+            <a:endParaRPr lang="en-US" sz="1050" dirty="0"/>
+          </a:p>
+        </p:txBody>
+      </p:sp>
+      <p:sp>
+        <p:nvSpPr>
           <p:cNvPr id="14" name="Text 12"/>
           <p:cNvSpPr txBox="1"/>
           <p:nvPr/>
         </p:nvSpPr>
         <p:spPr>
           <a:xfrm>
-            <a:off x="3321558" y="2788920"/>
-            <a:ext cx="2544318" cy="1051560"/>
+            <a:off x="6094476" y="1828800"/>
+            <a:ext cx="2590038" cy="274320"/>
           </a:xfrm>
           <a:prstGeom prst="rect">
             <a:avLst/>
@@ -6376,25 +6420,14 @@
               <a:buNone/>
             </a:pPr>
             <a:r>
-              <a:rPr lang="en-US" sz="1000" b="1" dirty="0">
-                <a:solidFill>
-                  <a:schemeClr val="tx1"/>
-                </a:solidFill>
-              </a:rPr>
-              <a:t>Komodo Marmot</a:t>
-            </a:r>
-            <a:pPr indent="0" marL="0">
-              <a:buNone/>
-            </a:pPr>
-            <a:r>
-              <a:rPr lang="en-US" sz="1000" dirty="0">
-                <a:solidFill>
-                  <a:schemeClr val="tx1"/>
-                </a:solidFill>
-              </a:rPr>
-              <a:t> — AI-powered healthcare analytics and research workflows</a:t>
-            </a:r>
-            <a:endParaRPr lang="en-US" sz="1000" dirty="0"/>
+              <a:rPr lang="en-US" sz="1500" b="1" dirty="0">
+                <a:solidFill>
+                  <a:schemeClr val="accent1"/>
+                </a:solidFill>
+              </a:rPr>
+              <a:t>April–May 2026</a:t>
+            </a:r>
+            <a:endParaRPr lang="en-US" sz="1500" dirty="0"/>
           </a:p>
         </p:txBody>
       </p:sp>
@@ -6406,8 +6439,8 @@
         </p:nvSpPr>
         <p:spPr>
           <a:xfrm>
-            <a:off x="6094476" y="2011680"/>
-            <a:ext cx="2590038" cy="274320"/>
+            <a:off x="6094476" y="2103120"/>
+            <a:ext cx="2590038" cy="201168"/>
           </a:xfrm>
           <a:prstGeom prst="rect">
             <a:avLst/>
@@ -6423,42 +6456,6 @@
               <a:buNone/>
             </a:pPr>
             <a:r>
-              <a:rPr lang="en-US" sz="1500" b="1" dirty="0">
-                <a:solidFill>
-                  <a:schemeClr val="accent1"/>
-                </a:solidFill>
-              </a:rPr>
-              <a:t>April–May 2026</a:t>
-            </a:r>
-            <a:endParaRPr lang="en-US" sz="1500" dirty="0"/>
-          </a:p>
-        </p:txBody>
-      </p:sp>
-      <p:sp>
-        <p:nvSpPr>
-          <p:cNvPr id="16" name="Text 14"/>
-          <p:cNvSpPr txBox="1"/>
-          <p:nvPr/>
-        </p:nvSpPr>
-        <p:spPr>
-          <a:xfrm>
-            <a:off x="6094476" y="2286000"/>
-            <a:ext cx="2590038" cy="201168"/>
-          </a:xfrm>
-          <a:prstGeom prst="rect">
-            <a:avLst/>
-          </a:prstGeom>
-          <a:noFill/>
-          <a:ln/>
-        </p:spPr>
-        <p:txBody>
-          <a:bodyPr wrap="square" lIns="0" tIns="0" rIns="0" bIns="0" rtlCol="0" anchor="t"/>
-          <a:lstStyle/>
-          <a:p>
-            <a:pPr indent="0" marL="0">
-              <a:buNone/>
-            </a:pPr>
-            <a:r>
               <a:rPr lang="en-US" sz="1000" i="1" dirty="0">
                 <a:solidFill>
                   <a:schemeClr val="accent4"/>
@@ -6472,13 +6469,13 @@
       </p:sp>
       <p:sp>
         <p:nvSpPr>
-          <p:cNvPr id="17" name="milestone"/>
+          <p:cNvPr id="16" name="milestone"/>
           <p:cNvSpPr/>
           <p:nvPr/>
         </p:nvSpPr>
         <p:spPr>
           <a:xfrm>
-            <a:off x="6094476" y="2532888"/>
+            <a:off x="6094476" y="2368296"/>
             <a:ext cx="164592" cy="164592"/>
           </a:xfrm>
           <a:prstGeom prst="ellipse">
@@ -6497,14 +6494,111 @@
       </p:sp>
       <p:sp>
         <p:nvSpPr>
+          <p:cNvPr id="17" name="Text 15"/>
+          <p:cNvSpPr txBox="1"/>
+          <p:nvPr/>
+        </p:nvSpPr>
+        <p:spPr>
+          <a:xfrm>
+            <a:off x="6094476" y="2615184"/>
+            <a:ext cx="2544318" cy="1371600"/>
+          </a:xfrm>
+          <a:prstGeom prst="rect">
+            <a:avLst/>
+          </a:prstGeom>
+          <a:noFill/>
+          <a:ln/>
+        </p:spPr>
+        <p:txBody>
+          <a:bodyPr wrap="square" lIns="0" tIns="0" rIns="0" bIns="0" rtlCol="0" anchor="t"/>
+          <a:lstStyle/>
+          <a:p>
+            <a:pPr indent="0" marL="0">
+              <a:buNone/>
+            </a:pPr>
+            <a:r>
+              <a:rPr lang="en-US" sz="1050" dirty="0">
+                <a:solidFill>
+                  <a:schemeClr val="tx1"/>
+                </a:solidFill>
+              </a:rPr>
+              <a:t>Truveta’s </a:t>
+            </a:r>
+            <a:pPr indent="0" marL="0">
+              <a:buNone/>
+            </a:pPr>
+            <a:r>
+              <a:rPr lang="en-US" sz="1050" b="1" dirty="0">
+                <a:solidFill>
+                  <a:schemeClr val="tx1"/>
+                </a:solidFill>
+              </a:rPr>
+              <a:t>Truveta Intelligence</a:t>
+            </a:r>
+            <a:pPr indent="0" marL="0">
+              <a:buNone/>
+            </a:pPr>
+            <a:r>
+              <a:rPr lang="en-US" sz="1050" dirty="0">
+                <a:solidFill>
+                  <a:schemeClr val="tx1"/>
+                </a:solidFill>
+              </a:rPr>
+              <a:t> — natural-language RWE research questions</a:t>
+            </a:r>
+            <a:endParaRPr lang="en-US" sz="1050" dirty="0"/>
+          </a:p>
+          <a:p>
+            <a:pPr indent="0" marL="0">
+              <a:spcBef>
+                <a:spcPts val="800"/>
+              </a:spcBef>
+              <a:buNone/>
+            </a:pPr>
+            <a:r>
+              <a:rPr lang="en-US" sz="1050" dirty="0">
+                <a:solidFill>
+                  <a:schemeClr val="tx1"/>
+                </a:solidFill>
+              </a:rPr>
+              <a:t>Flatiron Health’s </a:t>
+            </a:r>
+            <a:pPr indent="0" marL="0">
+              <a:buNone/>
+            </a:pPr>
+            <a:r>
+              <a:rPr lang="en-US" sz="1050" b="1" dirty="0">
+                <a:solidFill>
+                  <a:schemeClr val="tx1"/>
+                </a:solidFill>
+              </a:rPr>
+              <a:t>Telescope</a:t>
+            </a:r>
+            <a:pPr indent="0" marL="0">
+              <a:buNone/>
+            </a:pPr>
+            <a:r>
+              <a:rPr lang="en-US" sz="1050" dirty="0">
+                <a:solidFill>
+                  <a:schemeClr val="tx1"/>
+                </a:solidFill>
+              </a:rPr>
+              <a:t> — conversational oncology cohort exploration</a:t>
+            </a:r>
+            <a:endParaRPr lang="en-US" sz="1050" dirty="0"/>
+          </a:p>
+        </p:txBody>
+      </p:sp>
+      <p:sp>
+        <p:nvSpPr>
           <p:cNvPr id="18" name="Text 16"/>
           <p:cNvSpPr txBox="1"/>
           <p:nvPr/>
         </p:nvSpPr>
         <p:spPr>
           <a:xfrm>
-            <a:off x="6094476" y="2788920"/>
-            <a:ext cx="2544318" cy="1051560"/>
+            <a:off x="8867394" y="1828800"/>
+            <a:ext cx="2590038" cy="274320"/>
           </a:xfrm>
           <a:prstGeom prst="rect">
             <a:avLst/>
@@ -6520,53 +6614,14 @@
               <a:buNone/>
             </a:pPr>
             <a:r>
-              <a:rPr lang="en-US" sz="1000" b="1" dirty="0">
-                <a:solidFill>
-                  <a:schemeClr val="tx1"/>
-                </a:solidFill>
-              </a:rPr>
-              <a:t>Truveta Intelligence</a:t>
-            </a:r>
-            <a:pPr indent="0" marL="0">
-              <a:buNone/>
-            </a:pPr>
-            <a:r>
-              <a:rPr lang="en-US" sz="1000" dirty="0">
-                <a:solidFill>
-                  <a:schemeClr val="tx1"/>
-                </a:solidFill>
-              </a:rPr>
-              <a:t> — natural-language RWE research questions</a:t>
-            </a:r>
-            <a:endParaRPr lang="en-US" sz="1000" dirty="0"/>
-          </a:p>
-          <a:p>
-            <a:pPr indent="0" marL="0">
-              <a:spcBef>
-                <a:spcPts val="600"/>
-              </a:spcBef>
-              <a:buNone/>
-            </a:pPr>
-            <a:r>
-              <a:rPr lang="en-US" sz="1000" b="1" dirty="0">
-                <a:solidFill>
-                  <a:schemeClr val="tx1"/>
-                </a:solidFill>
-              </a:rPr>
-              <a:t>Flatiron Telescope</a:t>
-            </a:r>
-            <a:pPr indent="0" marL="0">
-              <a:buNone/>
-            </a:pPr>
-            <a:r>
-              <a:rPr lang="en-US" sz="1000" dirty="0">
-                <a:solidFill>
-                  <a:schemeClr val="tx1"/>
-                </a:solidFill>
-              </a:rPr>
-              <a:t> — conversational oncology cohort exploration</a:t>
-            </a:r>
-            <a:endParaRPr lang="en-US" sz="1000" dirty="0"/>
+              <a:rPr lang="en-US" sz="1500" b="1" dirty="0">
+                <a:solidFill>
+                  <a:schemeClr val="accent1"/>
+                </a:solidFill>
+              </a:rPr>
+              <a:t>September 2026</a:t>
+            </a:r>
+            <a:endParaRPr lang="en-US" sz="1500" dirty="0"/>
           </a:p>
         </p:txBody>
       </p:sp>
@@ -6578,8 +6633,8 @@
         </p:nvSpPr>
         <p:spPr>
           <a:xfrm>
-            <a:off x="8867394" y="2011680"/>
-            <a:ext cx="2590038" cy="274320"/>
+            <a:off x="8867394" y="2103120"/>
+            <a:ext cx="2590038" cy="201168"/>
           </a:xfrm>
           <a:prstGeom prst="rect">
             <a:avLst/>
@@ -6595,42 +6650,6 @@
               <a:buNone/>
             </a:pPr>
             <a:r>
-              <a:rPr lang="en-US" sz="1500" b="1" dirty="0">
-                <a:solidFill>
-                  <a:schemeClr val="accent1"/>
-                </a:solidFill>
-              </a:rPr>
-              <a:t>September 2026</a:t>
-            </a:r>
-            <a:endParaRPr lang="en-US" sz="1500" dirty="0"/>
-          </a:p>
-        </p:txBody>
-      </p:sp>
-      <p:sp>
-        <p:nvSpPr>
-          <p:cNvPr id="20" name="Text 18"/>
-          <p:cNvSpPr txBox="1"/>
-          <p:nvPr/>
-        </p:nvSpPr>
-        <p:spPr>
-          <a:xfrm>
-            <a:off x="8867394" y="2286000"/>
-            <a:ext cx="2590038" cy="201168"/>
-          </a:xfrm>
-          <a:prstGeom prst="rect">
-            <a:avLst/>
-          </a:prstGeom>
-          <a:noFill/>
-          <a:ln/>
-        </p:spPr>
-        <p:txBody>
-          <a:bodyPr wrap="square" lIns="0" tIns="0" rIns="0" bIns="0" rtlCol="0" anchor="t"/>
-          <a:lstStyle/>
-          <a:p>
-            <a:pPr indent="0" marL="0">
-              <a:buNone/>
-            </a:pPr>
-            <a:r>
               <a:rPr lang="en-US" sz="1000" i="1" dirty="0">
                 <a:solidFill>
                   <a:schemeClr val="accent4"/>
@@ -6644,13 +6663,13 @@
       </p:sp>
       <p:sp>
         <p:nvSpPr>
-          <p:cNvPr id="21" name="milestone"/>
+          <p:cNvPr id="20" name="milestone"/>
           <p:cNvSpPr/>
           <p:nvPr/>
         </p:nvSpPr>
         <p:spPr>
           <a:xfrm>
-            <a:off x="8867394" y="2532888"/>
+            <a:off x="8867394" y="2368296"/>
             <a:ext cx="164592" cy="164592"/>
           </a:xfrm>
           <a:prstGeom prst="ellipse">
@@ -6669,14 +6688,14 @@
       </p:sp>
       <p:sp>
         <p:nvSpPr>
-          <p:cNvPr id="22" name="Text 20"/>
+          <p:cNvPr id="21" name="Text 19"/>
           <p:cNvSpPr txBox="1"/>
           <p:nvPr/>
         </p:nvSpPr>
         <p:spPr>
           <a:xfrm>
-            <a:off x="8867394" y="2788920"/>
-            <a:ext cx="2544318" cy="1051560"/>
+            <a:off x="8867394" y="2615184"/>
+            <a:ext cx="2544318" cy="1371600"/>
           </a:xfrm>
           <a:prstGeom prst="rect">
             <a:avLst/>
@@ -6692,66 +6711,88 @@
               <a:buNone/>
             </a:pPr>
             <a:r>
-              <a:rPr lang="en-US" sz="1000" b="1" dirty="0">
+              <a:rPr lang="en-US" sz="1050" dirty="0">
                 <a:solidFill>
                   <a:schemeClr val="tx1"/>
                 </a:solidFill>
               </a:rPr>
-              <a:t>Verana Agent Claire</a:t>
+              <a:t>Verana Health’s </a:t>
             </a:r>
             <a:pPr indent="0" marL="0">
               <a:buNone/>
             </a:pPr>
             <a:r>
-              <a:rPr lang="en-US" sz="1000" dirty="0">
+              <a:rPr lang="en-US" sz="1050" b="1" dirty="0">
                 <a:solidFill>
                   <a:schemeClr val="tx1"/>
                 </a:solidFill>
               </a:rPr>
+              <a:t>Agent Claire</a:t>
+            </a:r>
+            <a:pPr indent="0" marL="0">
+              <a:buNone/>
+            </a:pPr>
+            <a:r>
+              <a:rPr lang="en-US" sz="1050" dirty="0">
+                <a:solidFill>
+                  <a:schemeClr val="tx1"/>
+                </a:solidFill>
+              </a:rPr>
               <a:t> — conversational specialty-data research</a:t>
             </a:r>
-            <a:endParaRPr lang="en-US" sz="1000" dirty="0"/>
+            <a:endParaRPr lang="en-US" sz="1050" dirty="0"/>
           </a:p>
           <a:p>
             <a:pPr indent="0" marL="0">
               <a:spcBef>
-                <a:spcPts val="600"/>
+                <a:spcPts val="800"/>
               </a:spcBef>
               <a:buNone/>
             </a:pPr>
             <a:r>
-              <a:rPr lang="en-US" sz="1000" b="1" dirty="0">
-                <a:solidFill>
-                  <a:schemeClr val="accent4"/>
-                </a:solidFill>
-              </a:rPr>
-              <a:t>Norstella Atlas Patient Analytics</a:t>
+              <a:rPr lang="en-US" sz="1050" dirty="0">
+                <a:solidFill>
+                  <a:schemeClr val="tx1"/>
+                </a:solidFill>
+              </a:rPr>
+              <a:t>Norstella’s </a:t>
             </a:r>
             <a:pPr indent="0" marL="0">
               <a:buNone/>
             </a:pPr>
             <a:r>
-              <a:rPr lang="en-US" sz="1000" dirty="0">
-                <a:solidFill>
-                  <a:schemeClr val="accent4"/>
+              <a:rPr lang="en-US" sz="1050" b="1" dirty="0">
+                <a:solidFill>
+                  <a:schemeClr val="tx1"/>
+                </a:solidFill>
+              </a:rPr>
+              <a:t>Atlas Patient Analytics</a:t>
+            </a:r>
+            <a:pPr indent="0" marL="0">
+              <a:buNone/>
+            </a:pPr>
+            <a:r>
+              <a:rPr lang="en-US" sz="1050" dirty="0">
+                <a:solidFill>
+                  <a:schemeClr val="tx1"/>
                 </a:solidFill>
               </a:rPr>
               <a:t> — agentic, managed cohort analytics</a:t>
             </a:r>
-            <a:endParaRPr lang="en-US" sz="1000" dirty="0"/>
-          </a:p>
-        </p:txBody>
-      </p:sp>
-      <p:sp>
-        <p:nvSpPr>
-          <p:cNvPr id="23" name="broader competitive signal card"/>
+            <a:endParaRPr lang="en-US" sz="1050" dirty="0"/>
+          </a:p>
+        </p:txBody>
+      </p:sp>
+      <p:sp>
+        <p:nvSpPr>
+          <p:cNvPr id="22" name="the broader competitive question card"/>
           <p:cNvSpPr/>
           <p:nvPr/>
         </p:nvSpPr>
         <p:spPr>
           <a:xfrm>
-            <a:off x="548640" y="4005072"/>
-            <a:ext cx="3575304" cy="1591056"/>
+            <a:off x="548640" y="3931920"/>
+            <a:ext cx="5454396" cy="1645920"/>
           </a:xfrm>
           <a:prstGeom prst="rect">
             <a:avLst/>
@@ -6771,14 +6812,14 @@
       </p:sp>
       <p:sp>
         <p:nvSpPr>
-          <p:cNvPr id="24" name="label"/>
+          <p:cNvPr id="23" name="label"/>
           <p:cNvSpPr txBox="1"/>
           <p:nvPr/>
         </p:nvSpPr>
         <p:spPr>
           <a:xfrm>
-            <a:off x="749808" y="4142232"/>
-            <a:ext cx="3172968" cy="219456"/>
+            <a:off x="749808" y="4338828"/>
+            <a:ext cx="5052060" cy="201168"/>
           </a:xfrm>
           <a:prstGeom prst="rect">
             <a:avLst/>
@@ -6799,7 +6840,7 @@
                   <a:schemeClr val="accent2"/>
                 </a:solidFill>
               </a:rPr>
-              <a:t>BROADER COMPETITIVE SIGNAL</a:t>
+              <a:t>THE BROADER COMPETITIVE QUESTION</a:t>
             </a:r>
             <a:endParaRPr lang="en-US" sz="1000" dirty="0"/>
           </a:p>
@@ -6807,14 +6848,14 @@
       </p:sp>
       <p:sp>
         <p:nvSpPr>
-          <p:cNvPr id="25" name="Text 23"/>
+          <p:cNvPr id="24" name="Text 22"/>
           <p:cNvSpPr txBox="1"/>
           <p:nvPr/>
         </p:nvSpPr>
         <p:spPr>
           <a:xfrm>
-            <a:off x="749808" y="4443984"/>
-            <a:ext cx="3172968" cy="1106424"/>
+            <a:off x="749808" y="4613148"/>
+            <a:ext cx="5052060" cy="612648"/>
           </a:xfrm>
           <a:prstGeom prst="rect">
             <a:avLst/>
@@ -6830,27 +6871,27 @@
               <a:buNone/>
             </a:pPr>
             <a:r>
-              <a:rPr lang="en-US" sz="1100" dirty="0">
-                <a:solidFill>
-                  <a:schemeClr val="tx1"/>
-                </a:solidFill>
-              </a:rPr>
-              <a:t>AI model providers are actively expanding enterprise sales into life sciences, offering models, integrations and implementation partnerships that may accelerate AI adoption among established healthcare-data vendors.</a:t>
-            </a:r>
-            <a:endParaRPr lang="en-US" sz="1100" dirty="0"/>
-          </a:p>
-        </p:txBody>
-      </p:sp>
-      <p:sp>
-        <p:nvSpPr>
-          <p:cNvPr id="26" name="the broader competitive question card"/>
+              <a:rPr lang="en-US" sz="1200" b="1" dirty="0">
+                <a:solidFill>
+                  <a:schemeClr val="accent1"/>
+                </a:solidFill>
+              </a:rPr>
+              <a:t>Where else are life sciences vendors marketing conversational AI, what tasks does it serve, and how does that positioning compare with Optum Life Sciences?</a:t>
+            </a:r>
+            <a:endParaRPr lang="en-US" sz="1200" dirty="0"/>
+          </a:p>
+        </p:txBody>
+      </p:sp>
+      <p:sp>
+        <p:nvSpPr>
+          <p:cNvPr id="25" name="our research response card"/>
           <p:cNvSpPr/>
           <p:nvPr/>
         </p:nvSpPr>
         <p:spPr>
           <a:xfrm>
-            <a:off x="4306824" y="4005072"/>
-            <a:ext cx="3575304" cy="1591056"/>
+            <a:off x="6185916" y="3931920"/>
+            <a:ext cx="5454396" cy="1645920"/>
           </a:xfrm>
           <a:prstGeom prst="rect">
             <a:avLst/>
@@ -6870,14 +6911,14 @@
       </p:sp>
       <p:sp>
         <p:nvSpPr>
-          <p:cNvPr id="27" name="label"/>
+          <p:cNvPr id="26" name="label"/>
           <p:cNvSpPr txBox="1"/>
           <p:nvPr/>
         </p:nvSpPr>
         <p:spPr>
           <a:xfrm>
-            <a:off x="4507992" y="4142232"/>
-            <a:ext cx="3172968" cy="219456"/>
+            <a:off x="6387084" y="4245864"/>
+            <a:ext cx="5052060" cy="201168"/>
           </a:xfrm>
           <a:prstGeom prst="rect">
             <a:avLst/>
@@ -6898,7 +6939,7 @@
                   <a:schemeClr val="accent2"/>
                 </a:solidFill>
               </a:rPr>
-              <a:t>THE BROADER COMPETITIVE QUESTION</a:t>
+              <a:t>OUR RESEARCH RESPONSE</a:t>
             </a:r>
             <a:endParaRPr lang="en-US" sz="1000" dirty="0"/>
           </a:p>
@@ -6906,14 +6947,14 @@
       </p:sp>
       <p:sp>
         <p:nvSpPr>
-          <p:cNvPr id="28" name="Text 26"/>
+          <p:cNvPr id="27" name="Text 25"/>
           <p:cNvSpPr txBox="1"/>
           <p:nvPr/>
         </p:nvSpPr>
         <p:spPr>
           <a:xfrm>
-            <a:off x="4507992" y="4443984"/>
-            <a:ext cx="3172968" cy="1106424"/>
+            <a:off x="6387084" y="4520184"/>
+            <a:ext cx="5052060" cy="798576"/>
           </a:xfrm>
           <a:prstGeom prst="rect">
             <a:avLst/>
@@ -6929,119 +6970,20 @@
               <a:buNone/>
             </a:pPr>
             <a:r>
-              <a:rPr lang="en-US" sz="1100" b="1" dirty="0">
-                <a:solidFill>
-                  <a:schemeClr val="accent1"/>
-                </a:solidFill>
-              </a:rPr>
-              <a:t>Where else are life sciences vendors marketing conversational AI, what tasks does it serve, and how does that positioning compare with Optum Life Sciences?</a:t>
-            </a:r>
-            <a:endParaRPr lang="en-US" sz="1100" dirty="0"/>
-          </a:p>
-        </p:txBody>
-      </p:sp>
-      <p:sp>
-        <p:nvSpPr>
-          <p:cNvPr id="29" name="our research response card"/>
-          <p:cNvSpPr/>
-          <p:nvPr/>
-        </p:nvSpPr>
-        <p:spPr>
-          <a:xfrm>
-            <a:off x="8065008" y="4005072"/>
-            <a:ext cx="3575304" cy="1591056"/>
-          </a:xfrm>
-          <a:prstGeom prst="rect">
-            <a:avLst/>
-          </a:prstGeom>
-          <a:solidFill>
-            <a:schemeClr val="bg1"/>
-          </a:solidFill>
-          <a:ln/>
-          <a:effectLst>
-            <a:outerShdw sx="100000" sy="100000" kx="0" ky="0" algn="bl" rotWithShape="0" blurRad="101600" dist="25400" dir="5400000">
-              <a:srgbClr val="000000">
-                <a:alpha val="10000"/>
-              </a:srgbClr>
-            </a:outerShdw>
-          </a:effectLst>
-        </p:spPr>
-      </p:sp>
-      <p:sp>
-        <p:nvSpPr>
-          <p:cNvPr id="30" name="label"/>
-          <p:cNvSpPr txBox="1"/>
-          <p:nvPr/>
-        </p:nvSpPr>
-        <p:spPr>
-          <a:xfrm>
-            <a:off x="8266176" y="4142232"/>
-            <a:ext cx="3172968" cy="219456"/>
-          </a:xfrm>
-          <a:prstGeom prst="rect">
-            <a:avLst/>
-          </a:prstGeom>
-          <a:noFill/>
-          <a:ln/>
-        </p:spPr>
-        <p:txBody>
-          <a:bodyPr wrap="square" lIns="0" tIns="0" rIns="0" bIns="0" rtlCol="0" anchor="t"/>
-          <a:lstStyle/>
-          <a:p>
-            <a:pPr indent="0" marL="0">
-              <a:buNone/>
-            </a:pPr>
-            <a:r>
-              <a:rPr lang="en-US" sz="1000" b="1" spc="100" kern="0" dirty="0">
-                <a:solidFill>
-                  <a:schemeClr val="accent2"/>
-                </a:solidFill>
-              </a:rPr>
-              <a:t>OUR RESEARCH RESPONSE</a:t>
-            </a:r>
-            <a:endParaRPr lang="en-US" sz="1000" dirty="0"/>
-          </a:p>
-        </p:txBody>
-      </p:sp>
-      <p:sp>
-        <p:nvSpPr>
-          <p:cNvPr id="31" name="Text 29"/>
-          <p:cNvSpPr txBox="1"/>
-          <p:nvPr/>
-        </p:nvSpPr>
-        <p:spPr>
-          <a:xfrm>
-            <a:off x="8266176" y="4443984"/>
-            <a:ext cx="3172968" cy="1106424"/>
-          </a:xfrm>
-          <a:prstGeom prst="rect">
-            <a:avLst/>
-          </a:prstGeom>
-          <a:noFill/>
-          <a:ln/>
-        </p:spPr>
-        <p:txBody>
-          <a:bodyPr wrap="square" lIns="0" tIns="0" rIns="0" bIns="0" rtlCol="0" anchor="t"/>
-          <a:lstStyle/>
-          <a:p>
-            <a:pPr indent="0" marL="0">
-              <a:buNone/>
-            </a:pPr>
-            <a:r>
-              <a:rPr lang="en-US" sz="1100" dirty="0">
+              <a:rPr lang="en-US" sz="1200" b="1" dirty="0">
                 <a:solidFill>
                   <a:schemeClr val="tx1"/>
                 </a:solidFill>
               </a:rPr>
               <a:t>Expand beyond RWE to assess publicly marketed conversational AI across five Optum-aligned decision workflows, prioritizing the U.S. competitive landscape and using selected international offerings for context.</a:t>
             </a:r>
-            <a:endParaRPr lang="en-US" sz="1100" dirty="0"/>
-          </a:p>
-        </p:txBody>
-      </p:sp>
-      <p:sp>
-        <p:nvSpPr>
-          <p:cNvPr id="32" name="evidence boundary"/>
+            <a:endParaRPr lang="en-US" sz="1200" dirty="0"/>
+          </a:p>
+        </p:txBody>
+      </p:sp>
+      <p:sp>
+        <p:nvSpPr>
+          <p:cNvPr id="28" name="evidence boundary"/>
           <p:cNvSpPr txBox="1"/>
           <p:nvPr/>
         </p:nvSpPr>
@@ -12017,7 +11959,7 @@
                     <a:bodyPr/>
                     <a:lstStyle/>
                     <a:p>
-                      <a:pPr indent="0" marL="0">
+                      <a:pPr algn="ctr" indent="0" marL="0">
                         <a:buNone/>
                       </a:pPr>
                       <a:r>
@@ -12054,7 +11996,7 @@
                     <a:bodyPr/>
                     <a:lstStyle/>
                     <a:p>
-                      <a:pPr indent="0" marL="0">
+                      <a:pPr algn="ctr" indent="0" marL="0">
                         <a:buNone/>
                       </a:pPr>
                       <a:r>
@@ -12063,7 +12005,7 @@
                             <a:schemeClr val="bg1"/>
                           </a:solidFill>
                         </a:rPr>
-                        <a:t>COMPETITOR CONVERSATIONAL AI OFFERINGS</a:t>
+                        <a:t>CONVERSATIONAL AI OFFERINGS</a:t>
                       </a:r>
                       <a:endParaRPr lang="en-US" sz="900" dirty="0"/>
                     </a:p>
@@ -12091,7 +12033,7 @@
                     <a:bodyPr/>
                     <a:lstStyle/>
                     <a:p>
-                      <a:pPr indent="0" marL="0">
+                      <a:pPr algn="ctr" indent="0" marL="0">
                         <a:buNone/>
                       </a:pPr>
                       <a:r>
@@ -12124,13 +12066,13 @@
                   </a:tcPr>
                 </a:tc>
               </a:tr>
-              <a:tr h="539242">
+              <a:tr h="712555">
                 <a:tc>
                   <a:txBody>
                     <a:bodyPr/>
                     <a:lstStyle/>
                     <a:p>
-                      <a:pPr algn="l" indent="0" marL="0">
+                      <a:pPr algn="ctr" indent="0" marL="0">
                         <a:buNone/>
                       </a:pPr>
                       <a:r>
@@ -12322,13 +12264,13 @@
                   </a:tcPr>
                 </a:tc>
               </a:tr>
-              <a:tr h="734187">
+              <a:tr h="907500">
                 <a:tc>
                   <a:txBody>
                     <a:bodyPr/>
                     <a:lstStyle/>
                     <a:p>
-                      <a:pPr algn="l" indent="0" marL="0">
+                      <a:pPr algn="ctr" indent="0" marL="0">
                         <a:buNone/>
                       </a:pPr>
                       <a:r>
@@ -12520,9 +12462,9 @@
                         <a:buNone/>
                       </a:pPr>
                       <a:r>
-                        <a:rPr lang="en-US" sz="950" b="1" dirty="0">
+                        <a:rPr lang="en-US" sz="950" dirty="0">
                           <a:solidFill>
-                            <a:schemeClr val="accent2"/>
+                            <a:schemeClr val="tx1"/>
                           </a:solidFill>
                         </a:rPr>
                         <a:t>(Israel)</a:t>
@@ -12603,13 +12545,13 @@
                   </a:tcPr>
                 </a:tc>
               </a:tr>
-              <a:tr h="679323">
+              <a:tr h="852636">
                 <a:tc>
                   <a:txBody>
                     <a:bodyPr/>
                     <a:lstStyle/>
                     <a:p>
-                      <a:pPr algn="l" indent="0" marL="0">
+                      <a:pPr algn="ctr" indent="0" marL="0">
                         <a:buNone/>
                       </a:pPr>
                       <a:r>
@@ -12740,9 +12682,9 @@
                         <a:buNone/>
                       </a:pPr>
                       <a:r>
-                        <a:rPr lang="en-US" sz="950" b="1" dirty="0">
+                        <a:rPr lang="en-US" sz="950" dirty="0">
                           <a:solidFill>
-                            <a:schemeClr val="accent2"/>
+                            <a:schemeClr val="tx1"/>
                           </a:solidFill>
                         </a:rPr>
                         <a:t>(Finland)</a:t>
@@ -12829,14 +12771,14 @@
       </p:graphicFrame>
       <p:sp>
         <p:nvSpPr>
-          <p:cNvPr id="16" name="questions for comparison card"/>
+          <p:cNvPr id="16" name="beyond the public evidence card"/>
           <p:cNvSpPr/>
           <p:nvPr/>
         </p:nvSpPr>
         <p:spPr>
           <a:xfrm>
-            <a:off x="548640" y="4220464"/>
-            <a:ext cx="11091672" cy="1430528"/>
+            <a:off x="548640" y="4740402"/>
+            <a:ext cx="11091672" cy="965454"/>
           </a:xfrm>
           <a:prstGeom prst="rect">
             <a:avLst/>
@@ -12862,8 +12804,8 @@
         </p:nvSpPr>
         <p:spPr>
           <a:xfrm>
-            <a:off x="749808" y="4357624"/>
-            <a:ext cx="10689336" cy="219456"/>
+            <a:off x="749808" y="4923282"/>
+            <a:ext cx="10689336" cy="201168"/>
           </a:xfrm>
           <a:prstGeom prst="rect">
             <a:avLst/>
@@ -12884,7 +12826,7 @@
                   <a:schemeClr val="accent2"/>
                 </a:solidFill>
               </a:rPr>
-              <a:t>QUESTIONS FOR COMPARISON</a:t>
+              <a:t>BEYOND THE PUBLIC EVIDENCE</a:t>
             </a:r>
             <a:endParaRPr lang="en-US" sz="1000" dirty="0"/>
           </a:p>
@@ -12898,8 +12840,8 @@
         </p:nvSpPr>
         <p:spPr>
           <a:xfrm>
-            <a:off x="749808" y="4659376"/>
-            <a:ext cx="10689336" cy="945896"/>
+            <a:off x="749808" y="5197602"/>
+            <a:ext cx="10689336" cy="380238"/>
           </a:xfrm>
           <a:prstGeom prst="rect">
             <a:avLst/>
@@ -12915,14 +12857,14 @@
               <a:buNone/>
             </a:pPr>
             <a:r>
-              <a:rPr lang="en-US" sz="1100" dirty="0">
+              <a:rPr lang="en-US" sz="1050" b="1" dirty="0">
                 <a:solidFill>
                   <a:schemeClr val="tx1"/>
                 </a:solidFill>
               </a:rPr>
               <a:t>What information can researchers query directly? What outputs can they generate, inspect and reuse? Where do dataset permissions, cohort definitions or specialist involvement constrain the experience?</a:t>
             </a:r>
-            <a:endParaRPr lang="en-US" sz="1100" dirty="0"/>
+            <a:endParaRPr lang="en-US" sz="1050" dirty="0"/>
           </a:p>
         </p:txBody>
       </p:sp>
@@ -12934,7 +12876,7 @@
         </p:nvSpPr>
         <p:spPr>
           <a:xfrm>
-            <a:off x="548640" y="5760720"/>
+            <a:off x="548640" y="5797296"/>
             <a:ext cx="11091672" cy="384048"/>
           </a:xfrm>
           <a:prstGeom prst="rect">
@@ -13478,7 +13420,7 @@
                     <a:bodyPr/>
                     <a:lstStyle/>
                     <a:p>
-                      <a:pPr indent="0" marL="0">
+                      <a:pPr algn="ctr" indent="0" marL="0">
                         <a:buNone/>
                       </a:pPr>
                       <a:r>
@@ -13515,7 +13457,7 @@
                     <a:bodyPr/>
                     <a:lstStyle/>
                     <a:p>
-                      <a:pPr indent="0" marL="0">
+                      <a:pPr algn="ctr" indent="0" marL="0">
                         <a:buNone/>
                       </a:pPr>
                       <a:r>
@@ -13524,7 +13466,7 @@
                             <a:schemeClr val="bg1"/>
                           </a:solidFill>
                         </a:rPr>
-                        <a:t>COMPETITOR CONVERSATIONAL AI OFFERINGS</a:t>
+                        <a:t>CONVERSATIONAL AI OFFERINGS</a:t>
                       </a:r>
                       <a:endParaRPr lang="en-US" sz="900" dirty="0"/>
                     </a:p>
@@ -13552,7 +13494,7 @@
                     <a:bodyPr/>
                     <a:lstStyle/>
                     <a:p>
-                      <a:pPr indent="0" marL="0">
+                      <a:pPr algn="ctr" indent="0" marL="0">
                         <a:buNone/>
                       </a:pPr>
                       <a:r>
@@ -13585,13 +13527,13 @@
                   </a:tcPr>
                 </a:tc>
               </a:tr>
-              <a:tr h="539242">
+              <a:tr h="647107">
                 <a:tc>
                   <a:txBody>
                     <a:bodyPr/>
                     <a:lstStyle/>
                     <a:p>
-                      <a:pPr algn="l" indent="0" marL="0">
+                      <a:pPr algn="ctr" indent="0" marL="0">
                         <a:buNone/>
                       </a:pPr>
                       <a:r>
@@ -13783,13 +13725,13 @@
                   </a:tcPr>
                 </a:tc>
               </a:tr>
-              <a:tr h="734187">
+              <a:tr h="842052">
                 <a:tc>
                   <a:txBody>
                     <a:bodyPr/>
                     <a:lstStyle/>
                     <a:p>
-                      <a:pPr algn="l" indent="0" marL="0">
+                      <a:pPr algn="ctr" indent="0" marL="0">
                         <a:buNone/>
                       </a:pPr>
                       <a:r>
@@ -13959,9 +13901,9 @@
                         <a:buNone/>
                       </a:pPr>
                       <a:r>
-                        <a:rPr lang="en-US" sz="950" b="1" dirty="0">
+                        <a:rPr lang="en-US" sz="950" dirty="0">
                           <a:solidFill>
-                            <a:schemeClr val="accent2"/>
+                            <a:schemeClr val="tx1"/>
                           </a:solidFill>
                         </a:rPr>
                         <a:t>(China)</a:t>
@@ -14042,13 +13984,13 @@
                   </a:tcPr>
                 </a:tc>
               </a:tr>
-              <a:tr h="539242">
+              <a:tr h="647107">
                 <a:tc>
                   <a:txBody>
                     <a:bodyPr/>
                     <a:lstStyle/>
                     <a:p>
-                      <a:pPr algn="l" indent="0" marL="0">
+                      <a:pPr algn="ctr" indent="0" marL="0">
                         <a:buNone/>
                       </a:pPr>
                       <a:r>
@@ -14140,9 +14082,9 @@
                         <a:buNone/>
                       </a:pPr>
                       <a:r>
-                        <a:rPr lang="en-US" sz="950" b="1" dirty="0">
+                        <a:rPr lang="en-US" sz="950" dirty="0">
                           <a:solidFill>
-                            <a:schemeClr val="accent2"/>
+                            <a:schemeClr val="tx1"/>
                           </a:solidFill>
                         </a:rPr>
                         <a:t>(Israel)</a:t>
@@ -14235,8 +14177,8 @@
         </p:nvSpPr>
         <p:spPr>
           <a:xfrm>
-            <a:off x="548640" y="4080383"/>
-            <a:ext cx="5454396" cy="1570609"/>
+            <a:off x="548640" y="4403979"/>
+            <a:ext cx="5454396" cy="1301877"/>
           </a:xfrm>
           <a:prstGeom prst="rect">
             <a:avLst/>
@@ -14262,8 +14204,8 @@
         </p:nvSpPr>
         <p:spPr>
           <a:xfrm>
-            <a:off x="749808" y="4217543"/>
-            <a:ext cx="5052060" cy="402336"/>
+            <a:off x="749808" y="4586859"/>
+            <a:ext cx="5052060" cy="374904"/>
           </a:xfrm>
           <a:prstGeom prst="rect">
             <a:avLst/>
@@ -14298,8 +14240,8 @@
         </p:nvSpPr>
         <p:spPr>
           <a:xfrm>
-            <a:off x="749808" y="4702175"/>
-            <a:ext cx="5052060" cy="903097"/>
+            <a:off x="749808" y="5034915"/>
+            <a:ext cx="5052060" cy="542925"/>
           </a:xfrm>
           <a:prstGeom prst="rect">
             <a:avLst/>
@@ -14315,27 +14257,27 @@
               <a:buNone/>
             </a:pPr>
             <a:r>
-              <a:rPr lang="en-US" sz="1100" dirty="0">
+              <a:rPr lang="en-US" sz="1050" b="1" dirty="0">
                 <a:solidFill>
                   <a:schemeClr val="tx1"/>
                 </a:solidFill>
               </a:rPr>
               <a:t>Optum also markets epidemiology studies and Evidence Engine services. The conversational products above are not automatically equivalent to those scientific services.</a:t>
             </a:r>
-            <a:endParaRPr lang="en-US" sz="1100" dirty="0"/>
-          </a:p>
-        </p:txBody>
-      </p:sp>
-      <p:sp>
-        <p:nvSpPr>
-          <p:cNvPr id="19" name="questions for comparison card"/>
+            <a:endParaRPr lang="en-US" sz="1050" dirty="0"/>
+          </a:p>
+        </p:txBody>
+      </p:sp>
+      <p:sp>
+        <p:nvSpPr>
+          <p:cNvPr id="19" name="beyond the public evidence card"/>
           <p:cNvSpPr/>
           <p:nvPr/>
         </p:nvSpPr>
         <p:spPr>
           <a:xfrm>
-            <a:off x="6185916" y="4080383"/>
-            <a:ext cx="5454396" cy="1570609"/>
+            <a:off x="6185916" y="4403979"/>
+            <a:ext cx="5454396" cy="1301877"/>
           </a:xfrm>
           <a:prstGeom prst="rect">
             <a:avLst/>
@@ -14361,8 +14303,8 @@
         </p:nvSpPr>
         <p:spPr>
           <a:xfrm>
-            <a:off x="6387084" y="4217543"/>
-            <a:ext cx="5052060" cy="219456"/>
+            <a:off x="6387084" y="4592384"/>
+            <a:ext cx="5052060" cy="201168"/>
           </a:xfrm>
           <a:prstGeom prst="rect">
             <a:avLst/>
@@ -14383,7 +14325,7 @@
                   <a:schemeClr val="accent2"/>
                 </a:solidFill>
               </a:rPr>
-              <a:t>QUESTIONS FOR COMPARISON</a:t>
+              <a:t>BEYOND THE PUBLIC EVIDENCE</a:t>
             </a:r>
             <a:endParaRPr lang="en-US" sz="1000" dirty="0"/>
           </a:p>
@@ -14397,8 +14339,8 @@
         </p:nvSpPr>
         <p:spPr>
           <a:xfrm>
-            <a:off x="6387084" y="4519295"/>
-            <a:ext cx="5052060" cy="1085977"/>
+            <a:off x="6387084" y="4866704"/>
+            <a:ext cx="5052060" cy="705612"/>
           </a:xfrm>
           <a:prstGeom prst="rect">
             <a:avLst/>
@@ -14414,14 +14356,14 @@
               <a:buNone/>
             </a:pPr>
             <a:r>
-              <a:rPr lang="en-US" sz="1100" dirty="0">
+              <a:rPr lang="en-US" sz="1050" b="1" dirty="0">
                 <a:solidFill>
                   <a:schemeClr val="tx1"/>
                 </a:solidFill>
               </a:rPr>
               <a:t>Which tools support exploratory questions versus reproducible study analyses? What supporting methods, provenance and review can customers inspect? Which capabilities are publicly demonstrated, and which require further validation?</a:t>
             </a:r>
-            <a:endParaRPr lang="en-US" sz="1100" dirty="0"/>
+            <a:endParaRPr lang="en-US" sz="1050" dirty="0"/>
           </a:p>
         </p:txBody>
       </p:sp>
@@ -14433,7 +14375,7 @@
         </p:nvSpPr>
         <p:spPr>
           <a:xfrm>
-            <a:off x="548640" y="5760720"/>
+            <a:off x="548640" y="5797296"/>
             <a:ext cx="11091672" cy="384048"/>
           </a:xfrm>
           <a:prstGeom prst="rect">
@@ -15084,7 +15026,7 @@
                   </a:tcPr>
                 </a:tc>
               </a:tr>
-              <a:tr h="862203">
+              <a:tr h="806577">
                 <a:tc>
                   <a:txBody>
                     <a:bodyPr/>
@@ -15365,7 +15307,7 @@
                   </a:tcPr>
                 </a:tc>
               </a:tr>
-              <a:tr h="862203">
+              <a:tr h="806577">
                 <a:tc>
                   <a:txBody>
                     <a:bodyPr/>
@@ -15624,7 +15566,7 @@
                   </a:tcPr>
                 </a:tc>
               </a:tr>
-              <a:tr h="752475">
+              <a:tr h="696849">
                 <a:tc>
                   <a:txBody>
                     <a:bodyPr/>
@@ -15856,8 +15798,8 @@
         </p:nvSpPr>
         <p:spPr>
           <a:xfrm>
-            <a:off x="548640" y="4689729"/>
-            <a:ext cx="5454396" cy="1034415"/>
+            <a:off x="548640" y="4577715"/>
+            <a:ext cx="5454396" cy="1128141"/>
           </a:xfrm>
           <a:prstGeom prst="rect">
             <a:avLst/>
@@ -15883,8 +15825,8 @@
         </p:nvSpPr>
         <p:spPr>
           <a:xfrm>
-            <a:off x="749808" y="4781169"/>
-            <a:ext cx="5052060" cy="219456"/>
+            <a:off x="749808" y="4760595"/>
+            <a:ext cx="5052060" cy="201168"/>
           </a:xfrm>
           <a:prstGeom prst="rect">
             <a:avLst/>
@@ -15919,8 +15861,8 @@
         </p:nvSpPr>
         <p:spPr>
           <a:xfrm>
-            <a:off x="749808" y="5018913"/>
-            <a:ext cx="5052060" cy="659511"/>
+            <a:off x="749808" y="5034915"/>
+            <a:ext cx="5052060" cy="542925"/>
           </a:xfrm>
           <a:prstGeom prst="rect">
             <a:avLst/>
@@ -15955,8 +15897,8 @@
         </p:nvSpPr>
         <p:spPr>
           <a:xfrm>
-            <a:off x="6185916" y="4689729"/>
-            <a:ext cx="5454396" cy="1034415"/>
+            <a:off x="6185916" y="4577715"/>
+            <a:ext cx="5454396" cy="1128141"/>
           </a:xfrm>
           <a:prstGeom prst="rect">
             <a:avLst/>
@@ -15982,8 +15924,8 @@
         </p:nvSpPr>
         <p:spPr>
           <a:xfrm>
-            <a:off x="6387084" y="4781169"/>
-            <a:ext cx="5052060" cy="219456"/>
+            <a:off x="6387084" y="4760595"/>
+            <a:ext cx="5052060" cy="201168"/>
           </a:xfrm>
           <a:prstGeom prst="rect">
             <a:avLst/>
@@ -16018,8 +15960,8 @@
         </p:nvSpPr>
         <p:spPr>
           <a:xfrm>
-            <a:off x="6387084" y="5018913"/>
-            <a:ext cx="5052060" cy="659511"/>
+            <a:off x="6387084" y="5034915"/>
+            <a:ext cx="5052060" cy="542925"/>
           </a:xfrm>
           <a:prstGeom prst="rect">
             <a:avLst/>
@@ -16054,7 +15996,7 @@
         </p:nvSpPr>
         <p:spPr>
           <a:xfrm>
-            <a:off x="548640" y="5815584"/>
+            <a:off x="548640" y="5797296"/>
             <a:ext cx="11091672" cy="384048"/>
           </a:xfrm>
           <a:prstGeom prst="rect">
@@ -16598,7 +16540,7 @@
                     <a:bodyPr/>
                     <a:lstStyle/>
                     <a:p>
-                      <a:pPr indent="0" marL="0">
+                      <a:pPr algn="ctr" indent="0" marL="0">
                         <a:buNone/>
                       </a:pPr>
                       <a:r>
@@ -16635,7 +16577,7 @@
                     <a:bodyPr/>
                     <a:lstStyle/>
                     <a:p>
-                      <a:pPr indent="0" marL="0">
+                      <a:pPr algn="ctr" indent="0" marL="0">
                         <a:buNone/>
                       </a:pPr>
                       <a:r>
@@ -16644,7 +16586,7 @@
                             <a:schemeClr val="bg1"/>
                           </a:solidFill>
                         </a:rPr>
-                        <a:t>COMPETITOR CONVERSATIONAL AI OFFERINGS</a:t>
+                        <a:t>CONVERSATIONAL AI OFFERINGS</a:t>
                       </a:r>
                       <a:endParaRPr lang="en-US" sz="900" dirty="0"/>
                     </a:p>
@@ -16672,7 +16614,7 @@
                     <a:bodyPr/>
                     <a:lstStyle/>
                     <a:p>
-                      <a:pPr indent="0" marL="0">
+                      <a:pPr algn="ctr" indent="0" marL="0">
                         <a:buNone/>
                       </a:pPr>
                       <a:r>
@@ -16705,13 +16647,13 @@
                   </a:tcPr>
                 </a:tc>
               </a:tr>
-              <a:tr h="539242">
+              <a:tr h="700066">
                 <a:tc>
                   <a:txBody>
                     <a:bodyPr/>
                     <a:lstStyle/>
                     <a:p>
-                      <a:pPr algn="l" indent="0" marL="0">
+                      <a:pPr algn="ctr" indent="0" marL="0">
                         <a:buNone/>
                       </a:pPr>
                       <a:r>
@@ -16864,13 +16806,13 @@
                   </a:tcPr>
                 </a:tc>
               </a:tr>
-              <a:tr h="826516">
+              <a:tr h="987340">
                 <a:tc>
                   <a:txBody>
                     <a:bodyPr/>
                     <a:lstStyle/>
                     <a:p>
-                      <a:pPr algn="l" indent="0" marL="0">
+                      <a:pPr algn="ctr" indent="0" marL="0">
                         <a:buNone/>
                       </a:pPr>
                       <a:r>
@@ -17001,9 +16943,9 @@
                         <a:buNone/>
                       </a:pPr>
                       <a:r>
-                        <a:rPr lang="en-US" sz="950" b="1" dirty="0">
+                        <a:rPr lang="en-US" sz="950" dirty="0">
                           <a:solidFill>
-                            <a:schemeClr val="accent2"/>
+                            <a:schemeClr val="tx1"/>
                           </a:solidFill>
                         </a:rPr>
                         <a:t>(Spain)</a:t>
@@ -17084,13 +17026,13 @@
                   </a:tcPr>
                 </a:tc>
               </a:tr>
-              <a:tr h="624459">
+              <a:tr h="785283">
                 <a:tc>
                   <a:txBody>
                     <a:bodyPr/>
                     <a:lstStyle/>
                     <a:p>
-                      <a:pPr algn="l" indent="0" marL="0">
+                      <a:pPr algn="ctr" indent="0" marL="0">
                         <a:buNone/>
                       </a:pPr>
                       <a:r>
@@ -17249,14 +17191,14 @@
       </p:graphicFrame>
       <p:sp>
         <p:nvSpPr>
-          <p:cNvPr id="16" name="questions for comparison card"/>
+          <p:cNvPr id="16" name="beyond the public evidence card"/>
           <p:cNvSpPr/>
           <p:nvPr/>
         </p:nvSpPr>
         <p:spPr>
           <a:xfrm>
-            <a:off x="548640" y="4257929"/>
-            <a:ext cx="11091672" cy="1393063"/>
+            <a:off x="548640" y="4740402"/>
+            <a:ext cx="11091672" cy="965454"/>
           </a:xfrm>
           <a:prstGeom prst="rect">
             <a:avLst/>
@@ -17282,8 +17224,8 @@
         </p:nvSpPr>
         <p:spPr>
           <a:xfrm>
-            <a:off x="749808" y="4395089"/>
-            <a:ext cx="10689336" cy="219456"/>
+            <a:off x="749808" y="4923282"/>
+            <a:ext cx="10689336" cy="201168"/>
           </a:xfrm>
           <a:prstGeom prst="rect">
             <a:avLst/>
@@ -17304,7 +17246,7 @@
                   <a:schemeClr val="accent2"/>
                 </a:solidFill>
               </a:rPr>
-              <a:t>QUESTIONS FOR COMPARISON</a:t>
+              <a:t>BEYOND THE PUBLIC EVIDENCE</a:t>
             </a:r>
             <a:endParaRPr lang="en-US" sz="1000" dirty="0"/>
           </a:p>
@@ -17318,8 +17260,8 @@
         </p:nvSpPr>
         <p:spPr>
           <a:xfrm>
-            <a:off x="749808" y="4696841"/>
-            <a:ext cx="10689336" cy="908431"/>
+            <a:off x="749808" y="5197602"/>
+            <a:ext cx="10689336" cy="380238"/>
           </a:xfrm>
           <a:prstGeom prst="rect">
             <a:avLst/>
@@ -17335,14 +17277,14 @@
               <a:buNone/>
             </a:pPr>
             <a:r>
-              <a:rPr lang="en-US" sz="1100" dirty="0">
+              <a:rPr lang="en-US" sz="1050" b="1" dirty="0">
                 <a:solidFill>
                   <a:schemeClr val="tx1"/>
                 </a:solidFill>
               </a:rPr>
               <a:t>Which offerings help users find evidence, and which help them interpret or act on it? What source traceability, permissions and scientific review are built into the marketed experience? Where are these fundamentally different services?</a:t>
             </a:r>
-            <a:endParaRPr lang="en-US" sz="1100" dirty="0"/>
+            <a:endParaRPr lang="en-US" sz="1050" dirty="0"/>
           </a:p>
         </p:txBody>
       </p:sp>
@@ -17354,7 +17296,7 @@
         </p:nvSpPr>
         <p:spPr>
           <a:xfrm>
-            <a:off x="548640" y="5760720"/>
+            <a:off x="548640" y="5797296"/>
             <a:ext cx="11091672" cy="384048"/>
           </a:xfrm>
           <a:prstGeom prst="rect">
@@ -17812,7 +17754,7 @@
                   <a:schemeClr val="accent1"/>
                 </a:solidFill>
               </a:rPr>
-              <a:t>Conversational offerings address specific trial operations and pricing questions—not the entire clinical or market-access workflow</a:t>
+              <a:t>Conversational offerings address specific trial operations and pricing questions, not the entire clinical or market-access workflow</a:t>
             </a:r>
             <a:endParaRPr lang="en-US" sz="2200" dirty="0"/>
           </a:p>
@@ -17848,7 +17790,7 @@
                   <a:schemeClr val="accent2"/>
                 </a:solidFill>
               </a:rPr>
-              <a:t>TWO DISTINCT WORKFLOWS — COMPETITIVE EXAMPLES</a:t>
+              <a:t>CLINICAL TRIALS — COMPETITIVE EXAMPLES</a:t>
             </a:r>
             <a:endParaRPr lang="en-US" sz="1000" dirty="0"/>
           </a:p>
@@ -17887,7 +17829,7 @@
                     <a:bodyPr/>
                     <a:lstStyle/>
                     <a:p>
-                      <a:pPr indent="0" marL="0">
+                      <a:pPr algn="ctr" indent="0" marL="0">
                         <a:buNone/>
                       </a:pPr>
                       <a:r>
@@ -17924,7 +17866,7 @@
                     <a:bodyPr/>
                     <a:lstStyle/>
                     <a:p>
-                      <a:pPr indent="0" marL="0">
+                      <a:pPr algn="ctr" indent="0" marL="0">
                         <a:buNone/>
                       </a:pPr>
                       <a:r>
@@ -17933,7 +17875,7 @@
                             <a:schemeClr val="bg1"/>
                           </a:solidFill>
                         </a:rPr>
-                        <a:t>COMPETITOR CONVERSATIONAL AI OFFERINGS</a:t>
+                        <a:t>CONVERSATIONAL AI OFFERINGS</a:t>
                       </a:r>
                       <a:endParaRPr lang="en-US" sz="900" dirty="0"/>
                     </a:p>
@@ -17961,7 +17903,7 @@
                     <a:bodyPr/>
                     <a:lstStyle/>
                     <a:p>
-                      <a:pPr indent="0" marL="0">
+                      <a:pPr algn="ctr" indent="0" marL="0">
                         <a:buNone/>
                       </a:pPr>
                       <a:r>
@@ -18000,7 +17942,7 @@
                     <a:bodyPr/>
                     <a:lstStyle/>
                     <a:p>
-                      <a:pPr algn="l" indent="0" marL="0">
+                      <a:pPr algn="ctr" indent="0" marL="0">
                         <a:buNone/>
                       </a:pPr>
                       <a:r>
@@ -18159,7 +18101,7 @@
                     <a:bodyPr/>
                     <a:lstStyle/>
                     <a:p>
-                      <a:pPr algn="l" indent="0" marL="0">
+                      <a:pPr algn="ctr" indent="0" marL="0">
                         <a:buNone/>
                       </a:pPr>
                       <a:r>
@@ -18251,9 +18193,9 @@
                         <a:buNone/>
                       </a:pPr>
                       <a:r>
-                        <a:rPr lang="en-US" sz="950" b="1" dirty="0">
+                        <a:rPr lang="en-US" sz="950" dirty="0">
                           <a:solidFill>
-                            <a:schemeClr val="accent2"/>
+                            <a:schemeClr val="tx1"/>
                           </a:solidFill>
                         </a:rPr>
                         <a:t>(China)</a:t>
@@ -18282,9 +18224,9 @@
                     <a:lnT w="0" cap="flat" cmpd="sng" algn="ctr">
                       <a:noFill/>
                     </a:lnT>
-                    <a:lnB w="19050" cap="flat" cmpd="sng" algn="ctr">
+                    <a:lnB w="9525" cap="flat" cmpd="sng" algn="ctr">
                       <a:solidFill>
-                        <a:srgbClr val="002677"/>
+                        <a:srgbClr val="D9D4C7"/>
                       </a:solidFill>
                       <a:prstDash val="solid"/>
                       <a:round/>
@@ -18322,9 +18264,9 @@
                     <a:lnT w="0" cap="flat" cmpd="sng" algn="ctr">
                       <a:noFill/>
                     </a:lnT>
-                    <a:lnB w="19050" cap="flat" cmpd="sng" algn="ctr">
+                    <a:lnB w="9525" cap="flat" cmpd="sng" algn="ctr">
                       <a:solidFill>
-                        <a:srgbClr val="002677"/>
+                        <a:srgbClr val="D9D4C7"/>
                       </a:solidFill>
                       <a:prstDash val="solid"/>
                       <a:round/>
@@ -18334,13 +18276,193 @@
                   </a:tcPr>
                 </a:tc>
               </a:tr>
+            </a:tbl>
+          </a:graphicData>
+        </a:graphic>
+      </p:graphicFrame>
+      <p:sp>
+        <p:nvSpPr>
+          <p:cNvPr id="16" name="label"/>
+          <p:cNvSpPr txBox="1"/>
+          <p:nvPr/>
+        </p:nvSpPr>
+        <p:spPr>
+          <a:xfrm>
+            <a:off x="548640" y="3394837"/>
+            <a:ext cx="11091672" cy="201168"/>
+          </a:xfrm>
+          <a:prstGeom prst="rect">
+            <a:avLst/>
+          </a:prstGeom>
+          <a:noFill/>
+          <a:ln/>
+        </p:spPr>
+        <p:txBody>
+          <a:bodyPr wrap="square" lIns="0" tIns="0" rIns="0" bIns="0" rtlCol="0" anchor="t"/>
+          <a:lstStyle/>
+          <a:p>
+            <a:pPr indent="0" marL="0">
+              <a:buNone/>
+            </a:pPr>
+            <a:r>
+              <a:rPr lang="en-US" sz="1000" b="1" spc="100" kern="0" dirty="0">
+                <a:solidFill>
+                  <a:schemeClr val="accent2"/>
+                </a:solidFill>
+              </a:rPr>
+              <a:t>MARKET ACCESS — COMPETITIVE EXAMPLES</a:t>
+            </a:r>
+            <a:endParaRPr lang="en-US" sz="1000" dirty="0"/>
+          </a:p>
+        </p:txBody>
+      </p:sp>
+      <p:graphicFrame>
+        <p:nvGraphicFramePr>
+          <p:cNvPr id="19" name="task table"/>
+          <p:cNvGraphicFramePr>
+            <a:graphicFrameLocks noGrp="1"/>
+          </p:cNvGraphicFramePr>
+          <p:nvPr>
+            <p:extLst>
+              <p:ext uri="{D42A27DB-BD31-4B8C-83A1-F6EECF244321}">
+                <p14:modId xmlns:p14="http://schemas.microsoft.com/office/powerpoint/2010/main" val="1579011935"/>
+              </p:ext>
+            </p:extLst>
+          </p:nvPr>
+        </p:nvGraphicFramePr>
+        <p:xfrm>
+          <a:off x="548640" y="3669157"/>
+          <a:ext cx="11091672" cy="914400"/>
+        </p:xfrm>
+        <a:graphic>
+          <a:graphicData uri="http://schemas.openxmlformats.org/drawingml/2006/table">
+            <a:tbl>
+              <a:tblPr/>
+              <a:tblGrid>
+                <a:gridCol w="2286000"/>
+                <a:gridCol w="5760720"/>
+                <a:gridCol w="3044952"/>
+              </a:tblGrid>
+              <a:tr h="329184">
+                <a:tc>
+                  <a:txBody>
+                    <a:bodyPr/>
+                    <a:lstStyle/>
+                    <a:p>
+                      <a:pPr algn="ctr" indent="0" marL="0">
+                        <a:buNone/>
+                      </a:pPr>
+                      <a:r>
+                        <a:rPr lang="en-US" sz="900" b="1" spc="100" kern="0" dirty="0">
+                          <a:solidFill>
+                            <a:schemeClr val="bg1"/>
+                          </a:solidFill>
+                        </a:rPr>
+                        <a:t>CUSTOMER TASK</a:t>
+                      </a:r>
+                      <a:endParaRPr lang="en-US" sz="900" dirty="0"/>
+                    </a:p>
+                  </a:txBody>
+                  <a:tcPr marL="109728" marR="109728" marT="64008" marB="64008" anchor="ctr">
+                    <a:lnL w="0" cap="flat" cmpd="sng" algn="ctr">
+                      <a:noFill/>
+                    </a:lnL>
+                    <a:lnR w="0" cap="flat" cmpd="sng" algn="ctr">
+                      <a:noFill/>
+                    </a:lnR>
+                    <a:lnT w="0" cap="flat" cmpd="sng" algn="ctr">
+                      <a:noFill/>
+                    </a:lnT>
+                    <a:lnB w="0" cap="flat" cmpd="sng" algn="ctr">
+                      <a:noFill/>
+                    </a:lnB>
+                    <a:solidFill>
+                      <a:schemeClr val="accent1"/>
+                    </a:solidFill>
+                  </a:tcPr>
+                </a:tc>
+                <a:tc>
+                  <a:txBody>
+                    <a:bodyPr/>
+                    <a:lstStyle/>
+                    <a:p>
+                      <a:pPr algn="ctr" indent="0" marL="0">
+                        <a:buNone/>
+                      </a:pPr>
+                      <a:r>
+                        <a:rPr lang="en-US" sz="900" b="1" spc="100" kern="0" dirty="0">
+                          <a:solidFill>
+                            <a:schemeClr val="bg1"/>
+                          </a:solidFill>
+                        </a:rPr>
+                        <a:t>CONVERSATIONAL AI OFFERINGS</a:t>
+                      </a:r>
+                      <a:endParaRPr lang="en-US" sz="900" dirty="0"/>
+                    </a:p>
+                  </a:txBody>
+                  <a:tcPr marL="109728" marR="109728" marT="64008" marB="64008" anchor="ctr">
+                    <a:lnL w="0" cap="flat" cmpd="sng" algn="ctr">
+                      <a:noFill/>
+                    </a:lnL>
+                    <a:lnR w="0" cap="flat" cmpd="sng" algn="ctr">
+                      <a:noFill/>
+                    </a:lnR>
+                    <a:lnT w="0" cap="flat" cmpd="sng" algn="ctr">
+                      <a:noFill/>
+                    </a:lnT>
+                    <a:lnB w="0" cap="flat" cmpd="sng" algn="ctr">
+                      <a:noFill/>
+                    </a:lnB>
+                    <a:solidFill>
+                      <a:schemeClr val="accent1"/>
+                    </a:solidFill>
+                  </a:tcPr>
+                </a:tc>
+                <a:tc>
+                  <a:txBody>
+                    <a:bodyPr/>
+                    <a:lstStyle/>
+                    <a:p>
+                      <a:pPr algn="ctr" indent="0" marL="0">
+                        <a:buNone/>
+                      </a:pPr>
+                      <a:r>
+                        <a:rPr lang="en-US" sz="900" b="1" spc="100" kern="0" dirty="0">
+                          <a:solidFill>
+                            <a:schemeClr val="bg1"/>
+                          </a:solidFill>
+                        </a:rPr>
+                        <a:t>RELEVANT OPTUM OFFERINGS</a:t>
+                      </a:r>
+                      <a:endParaRPr lang="en-US" sz="900" dirty="0"/>
+                    </a:p>
+                  </a:txBody>
+                  <a:tcPr marL="109728" marR="109728" marT="64008" marB="64008" anchor="ctr">
+                    <a:lnL w="0" cap="flat" cmpd="sng" algn="ctr">
+                      <a:noFill/>
+                    </a:lnL>
+                    <a:lnR w="0" cap="flat" cmpd="sng" algn="ctr">
+                      <a:noFill/>
+                    </a:lnR>
+                    <a:lnT w="0" cap="flat" cmpd="sng" algn="ctr">
+                      <a:noFill/>
+                    </a:lnT>
+                    <a:lnB w="0" cap="flat" cmpd="sng" algn="ctr">
+                      <a:noFill/>
+                    </a:lnB>
+                    <a:solidFill>
+                      <a:schemeClr val="accent1"/>
+                    </a:solidFill>
+                  </a:tcPr>
+                </a:tc>
+              </a:tr>
               <a:tr h="539242">
                 <a:tc>
                   <a:txBody>
                     <a:bodyPr/>
                     <a:lstStyle/>
                     <a:p>
-                      <a:pPr algn="l" indent="0" marL="0">
+                      <a:pPr algn="ctr" indent="0" marL="0">
                         <a:buNone/>
                       </a:pPr>
                       <a:r>
@@ -18499,14 +18621,14 @@
       </p:graphicFrame>
       <p:sp>
         <p:nvSpPr>
-          <p:cNvPr id="16" name="questions for comparison card"/>
+          <p:cNvPr id="18" name="beyond the public evidence card"/>
           <p:cNvSpPr/>
           <p:nvPr/>
         </p:nvSpPr>
         <p:spPr>
           <a:xfrm>
-            <a:off x="548640" y="3970655"/>
-            <a:ext cx="11091672" cy="1680337"/>
+            <a:off x="548640" y="4702175"/>
+            <a:ext cx="11091672" cy="1003681"/>
           </a:xfrm>
           <a:prstGeom prst="rect">
             <a:avLst/>
@@ -18526,14 +18648,14 @@
       </p:sp>
       <p:sp>
         <p:nvSpPr>
-          <p:cNvPr id="17" name="label"/>
+          <p:cNvPr id="19" name="label"/>
           <p:cNvSpPr txBox="1"/>
           <p:nvPr/>
         </p:nvSpPr>
         <p:spPr>
           <a:xfrm>
-            <a:off x="749808" y="4107815"/>
-            <a:ext cx="10689336" cy="219456"/>
+            <a:off x="749808" y="4786249"/>
+            <a:ext cx="10689336" cy="201168"/>
           </a:xfrm>
           <a:prstGeom prst="rect">
             <a:avLst/>
@@ -18554,7 +18676,7 @@
                   <a:schemeClr val="accent2"/>
                 </a:solidFill>
               </a:rPr>
-              <a:t>QUESTIONS FOR COMPARISON</a:t>
+              <a:t>BEYOND THE PUBLIC EVIDENCE</a:t>
             </a:r>
             <a:endParaRPr lang="en-US" sz="1000" dirty="0"/>
           </a:p>
@@ -18562,14 +18684,14 @@
       </p:sp>
       <p:sp>
         <p:nvSpPr>
-          <p:cNvPr id="18" name="Text 15"/>
+          <p:cNvPr id="20" name="Text 16"/>
           <p:cNvSpPr txBox="1"/>
           <p:nvPr/>
         </p:nvSpPr>
         <p:spPr>
           <a:xfrm>
-            <a:off x="749808" y="4409567"/>
-            <a:ext cx="10689336" cy="1195705"/>
+            <a:off x="749808" y="5060569"/>
+            <a:ext cx="10689336" cy="616077"/>
           </a:xfrm>
           <a:prstGeom prst="rect">
             <a:avLst/>
@@ -18585,14 +18707,14 @@
               <a:buNone/>
             </a:pPr>
             <a:r>
-              <a:rPr lang="en-US" sz="1100" dirty="0">
+              <a:rPr lang="en-US" sz="1050" b="1" dirty="0">
                 <a:solidFill>
                   <a:schemeClr val="tx1"/>
                 </a:solidFill>
               </a:rPr>
               <a:t>For trials, does the interface help identify viable sites, evaluate patients or manage trial documents—and how far does it go?</a:t>
             </a:r>
-            <a:endParaRPr lang="en-US" sz="1100" dirty="0"/>
+            <a:endParaRPr lang="en-US" sz="1050" dirty="0"/>
           </a:p>
           <a:p>
             <a:pPr indent="0" marL="0">
@@ -18602,26 +18724,26 @@
               <a:buNone/>
             </a:pPr>
             <a:r>
-              <a:rPr lang="en-US" sz="1100" dirty="0">
+              <a:rPr lang="en-US" sz="1050" b="1" dirty="0">
                 <a:solidFill>
                   <a:schemeClr val="tx1"/>
                 </a:solidFill>
               </a:rPr>
               <a:t>For market access, is the customer asking for pricing intelligence, reimbursement information or new economic evidence? Where do the vendor offerings overlap with Optum, and where do they solve a different problem?</a:t>
             </a:r>
-            <a:endParaRPr lang="en-US" sz="1100" dirty="0"/>
-          </a:p>
-        </p:txBody>
-      </p:sp>
-      <p:sp>
-        <p:nvSpPr>
-          <p:cNvPr id="19" name="evidence boundary"/>
+            <a:endParaRPr lang="en-US" sz="1050" dirty="0"/>
+          </a:p>
+        </p:txBody>
+      </p:sp>
+      <p:sp>
+        <p:nvSpPr>
+          <p:cNvPr id="21" name="evidence boundary"/>
           <p:cNvSpPr txBox="1"/>
           <p:nvPr/>
         </p:nvSpPr>
         <p:spPr>
           <a:xfrm>
-            <a:off x="548640" y="5760720"/>
+            <a:off x="548640" y="5797296"/>
             <a:ext cx="11091672" cy="384048"/>
           </a:xfrm>
           <a:prstGeom prst="rect">

</xml_diff>

<commit_message>
Apply round-four edits to Slides 1-4 and 10; split notes over two slides
Co-Authored-By: Claude Opus 5.5 <noreply@anthropic.com>
Claude-Session: https://claude.ai/code/session_0198bm9pfzRwgZQBqNvd56W8
</commit_message>
<xml_diff>
--- a/deck/Optum-LS-Conversational-AI.pptx
+++ b/deck/Optum-LS-Conversational-AI.pptx
@@ -16,9 +16,10 @@
     <p:sldId id="264" r:id="rId10"/>
     <p:sldId id="265" r:id="rId11"/>
     <p:sldId id="266" r:id="rId12"/>
+    <p:sldId id="267" r:id="rId13"/>
   </p:sldIdLst>
   <p:notesMasterIdLst>
-    <p:notesMasterId r:id="rId13"/>
+    <p:notesMasterId r:id="rId14"/>
   </p:notesMasterIdLst>
   <p:sldSz cx="12192000" cy="6858000"/>
   <p:notesSz cx="6858000" cy="12192000"/>
@@ -117,27 +118,27 @@
   <p:extLst>
     <p:ext uri="{521415D9-36F7-43E2-AB2F-B90AF26B5E84}">
       <p14:sectionLst xmlns:p14="http://schemas.microsoft.com/office/powerpoint/2010/main">
-        <p14:section name="Executive summary" id="{589ff8ef-c522-8bde-1389-f1cd2fd71fc2}">
+        <p14:section name="Executive summary" id="{5c9c7a13-c587-b780-a51c-dc2b13c4093d}">
           <p14:sldIdLst>
             <p14:sldId id="256"/>
           </p14:sldIdLst>
         </p14:section>
-        <p14:section name="Research catalyst" id="{99ff7973-5ab5-f41c-bfcc-2ef207cf7794}">
+        <p14:section name="Research catalyst" id="{d0411a08-de86-e269-ae86-2b2e47bffd53}">
           <p14:sldIdLst>
             <p14:sldId id="257"/>
           </p14:sldIdLst>
         </p14:section>
-        <p14:section name="U.S. competitive landscape" id="{bb97d092-1f32-d315-02cb-b42954d0acf5}">
+        <p14:section name="U.S. competitive landscape" id="{d38da37d-8120-5290-d975-821b4e5af839}">
           <p14:sldIdLst>
             <p14:sldId id="258"/>
           </p14:sldIdLst>
         </p14:section>
-        <p14:section name="International competitor screens" id="{8031b0f2-e9b6-62e1-59fd-8bb4855d0017}">
+        <p14:section name="International competitor screens" id="{1e360efe-ebba-2721-a891-c2e37f7cf88d}">
           <p14:sldIdLst>
             <p14:sldId id="259"/>
           </p14:sldIdLst>
         </p14:section>
-        <p14:section name="Workflow deep dives" id="{a43a8ecc-d618-108e-56d6-35d770ba8024}">
+        <p14:section name="Workflow deep dives" id="{54ef858e-9456-c931-c8d9-b759bcb9f922}">
           <p14:sldIdLst>
             <p14:sldId id="260"/>
             <p14:sldId id="261"/>
@@ -146,14 +147,15 @@
             <p14:sldId id="264"/>
           </p14:sldIdLst>
         </p14:section>
-        <p14:section name="AI suppliers" id="{4e39b0d6-c52e-ece2-dc99-26a5f5811bc0}">
+        <p14:section name="AI suppliers" id="{674a1153-0968-bca4-0cf0-73cf565f366d}">
           <p14:sldIdLst>
             <p14:sldId id="265"/>
           </p14:sldIdLst>
         </p14:section>
-        <p14:section name="Methodology note" id="{7647554e-7234-5e4d-79fc-fe8dedf24176}">
+        <p14:section name="Methodology note" id="{224c7fbf-e05b-8c78-9c12-37c19b2e7852}">
           <p14:sldIdLst>
             <p14:sldId id="266"/>
+            <p14:sldId id="267"/>
           </p14:sldIdLst>
         </p14:section>
       </p14:sectionLst>
@@ -1614,6 +1616,94 @@
 </p:notes>
 </file>
 
+<file path=ppt/notesSlides/notesSlide12.xml><?xml version="1.0" encoding="utf-8"?>
+<p:notes xmlns:a="http://schemas.openxmlformats.org/drawingml/2006/main" xmlns:r="http://schemas.openxmlformats.org/officeDocument/2006/relationships" xmlns:p="http://schemas.openxmlformats.org/presentationml/2006/main">
+  <p:cSld>
+    <p:spTree>
+      <p:nvGrpSpPr>
+        <p:cNvPr id="1" name=""/>
+        <p:cNvGrpSpPr/>
+        <p:nvPr/>
+      </p:nvGrpSpPr>
+      <p:grpSpPr>
+        <a:xfrm>
+          <a:off x="0" y="0"/>
+          <a:ext cx="0" cy="0"/>
+          <a:chOff x="0" y="0"/>
+          <a:chExt cx="0" cy="0"/>
+        </a:xfrm>
+      </p:grpSpPr>
+      <p:sp>
+        <p:nvSpPr>
+          <p:cNvPr id="2" name="Slide Image Placeholder 1"/>
+          <p:cNvSpPr>
+            <a:spLocks noGrp="1" noRot="1" noChangeAspect="1"/>
+          </p:cNvSpPr>
+          <p:nvPr>
+            <p:ph type="sldImg"/>
+          </p:nvPr>
+        </p:nvSpPr>
+        <p:spPr/>
+      </p:sp>
+      <p:sp>
+        <p:nvSpPr>
+          <p:cNvPr id="3" name="Notes Placeholder 2"/>
+          <p:cNvSpPr>
+            <a:spLocks noGrp="1"/>
+          </p:cNvSpPr>
+          <p:nvPr>
+            <p:ph type="body" idx="1"/>
+          </p:nvPr>
+        </p:nvSpPr>
+        <p:spPr/>
+        <p:txBody>
+          <a:bodyPr/>
+          <a:lstStyle/>
+          <a:p>
+            <a:r>
+              <a:rPr lang="en-US" dirty="0"/>
+              <a:t/>
+            </a:r>
+            <a:endParaRPr lang="en-US" dirty="0"/>
+          </a:p>
+        </p:txBody>
+      </p:sp>
+      <p:sp>
+        <p:nvSpPr>
+          <p:cNvPr id="4" name="Slide Number Placeholder 3"/>
+          <p:cNvSpPr>
+            <a:spLocks noGrp="1"/>
+          </p:cNvSpPr>
+          <p:nvPr>
+            <p:ph type="sldNum" sz="quarter" idx="10"/>
+          </p:nvPr>
+        </p:nvSpPr>
+        <p:spPr/>
+        <p:txBody>
+          <a:bodyPr/>
+          <a:lstStyle/>
+          <a:p>
+            <a:fld id="{F7021451-1387-4CA6-816F-3879F97B5CBC}" type="slidenum">
+              <a:rPr lang="en-US"/>
+              <a:t>12</a:t>
+            </a:fld>
+            <a:endParaRPr lang="en-US"/>
+          </a:p>
+        </p:txBody>
+      </p:sp>
+    </p:spTree>
+    <p:extLst>
+      <p:ext uri="{BB962C8B-B14F-4D97-AF65-F5344CB8AC3E}">
+        <p14:creationId xmlns:p14="http://schemas.microsoft.com/office/powerpoint/2010/main" val="1024086991"/>
+      </p:ext>
+    </p:extLst>
+  </p:cSld>
+  <p:clrMapOvr>
+    <a:masterClrMapping/>
+  </p:clrMapOvr>
+</p:notes>
+</file>
+
 <file path=ppt/notesSlides/notesSlide2.xml><?xml version="1.0" encoding="utf-8"?>
 <p:notes xmlns:a="http://schemas.openxmlformats.org/drawingml/2006/main" xmlns:r="http://schemas.openxmlformats.org/officeDocument/2006/relationships" xmlns:p="http://schemas.openxmlformats.org/presentationml/2006/main">
   <p:cSld>
@@ -2999,7 +3089,7 @@
         <p:spPr>
           <a:xfrm>
             <a:off x="548640" y="1536192"/>
-            <a:ext cx="11091672" cy="1371600"/>
+            <a:ext cx="11091672" cy="1536192"/>
           </a:xfrm>
           <a:prstGeom prst="rect">
             <a:avLst/>
@@ -3135,7 +3225,7 @@
             <a:r>
               <a:rPr lang="en-US" sz="1100" b="1" dirty="0">
                 <a:solidFill>
-                  <a:schemeClr val="accent1"/>
+                  <a:schemeClr val="accent2"/>
                 </a:solidFill>
               </a:rPr>
               <a:t>publicly-marketed</a:t>
@@ -3149,7 +3239,7 @@
                   <a:schemeClr val="tx1"/>
                 </a:solidFill>
               </a:rPr>
-              <a:t> conversational AI products across five Optum Life Sciences-relevant business domains.</a:t>
+              <a:t> conversational AI products across five Optum Life Sciences-relevant business domains:</a:t>
             </a:r>
             <a:endParaRPr lang="en-US" sz="1100" dirty="0"/>
           </a:p>
@@ -3409,13 +3499,49 @@
       </p:sp>
       <p:sp>
         <p:nvSpPr>
-          <p:cNvPr id="17" name="workflow chip Market Access"/>
+          <p:cNvPr id="17" name="Text 14"/>
+          <p:cNvSpPr txBox="1"/>
+          <p:nvPr/>
+        </p:nvSpPr>
+        <p:spPr>
+          <a:xfrm>
+            <a:off x="7403897" y="2322576"/>
+            <a:ext cx="310896" cy="246888"/>
+          </a:xfrm>
+          <a:prstGeom prst="rect">
+            <a:avLst/>
+          </a:prstGeom>
+          <a:noFill/>
+          <a:ln/>
+        </p:spPr>
+        <p:txBody>
+          <a:bodyPr wrap="square" lIns="0" tIns="0" rIns="0" bIns="0" rtlCol="0" anchor="ctr"/>
+          <a:lstStyle/>
+          <a:p>
+            <a:pPr algn="ctr" indent="0" marL="0">
+              <a:buNone/>
+            </a:pPr>
+            <a:r>
+              <a:rPr lang="en-US" sz="1000" dirty="0">
+                <a:solidFill>
+                  <a:schemeClr val="accent4"/>
+                </a:solidFill>
+              </a:rPr>
+              <a:t>and</a:t>
+            </a:r>
+            <a:endParaRPr lang="en-US" sz="1000" dirty="0"/>
+          </a:p>
+        </p:txBody>
+      </p:sp>
+      <p:sp>
+        <p:nvSpPr>
+          <p:cNvPr id="18" name="workflow chip Market Access"/>
           <p:cNvSpPr/>
           <p:nvPr/>
         </p:nvSpPr>
         <p:spPr>
           <a:xfrm>
-            <a:off x="7403897" y="2322576"/>
+            <a:off x="7769657" y="2322576"/>
             <a:ext cx="1100298" cy="246888"/>
           </a:xfrm>
           <a:prstGeom prst="roundRect">
@@ -3436,48 +3562,48 @@
       </p:sp>
       <p:sp>
         <p:nvSpPr>
-          <p:cNvPr id="18" name="Text 15"/>
-          <p:cNvSpPr txBox="1"/>
-          <p:nvPr/>
-        </p:nvSpPr>
-        <p:spPr>
-          <a:xfrm>
-            <a:off x="7403897" y="2322576"/>
-            <a:ext cx="1100298" cy="246888"/>
-          </a:xfrm>
-          <a:prstGeom prst="rect">
-            <a:avLst/>
-          </a:prstGeom>
-          <a:noFill/>
-          <a:ln/>
-        </p:spPr>
-        <p:txBody>
-          <a:bodyPr wrap="square" lIns="0" tIns="0" rIns="0" bIns="0" rtlCol="0" anchor="ctr"/>
-          <a:lstStyle/>
-          <a:p>
-            <a:pPr algn="ctr" indent="0" marL="0">
-              <a:buNone/>
-            </a:pPr>
-            <a:r>
-              <a:rPr lang="en-US" sz="950" b="1" dirty="0">
-                <a:solidFill>
-                  <a:schemeClr val="accent1"/>
-                </a:solidFill>
-              </a:rPr>
-              <a:t>Market Access</a:t>
-            </a:r>
-            <a:endParaRPr lang="en-US" sz="950" dirty="0"/>
-          </a:p>
-        </p:txBody>
-      </p:sp>
-      <p:sp>
-        <p:nvSpPr>
           <p:cNvPr id="19" name="Text 16"/>
           <p:cNvSpPr txBox="1"/>
           <p:nvPr/>
         </p:nvSpPr>
         <p:spPr>
           <a:xfrm>
+            <a:off x="7769657" y="2322576"/>
+            <a:ext cx="1100298" cy="246888"/>
+          </a:xfrm>
+          <a:prstGeom prst="rect">
+            <a:avLst/>
+          </a:prstGeom>
+          <a:noFill/>
+          <a:ln/>
+        </p:spPr>
+        <p:txBody>
+          <a:bodyPr wrap="square" lIns="0" tIns="0" rIns="0" bIns="0" rtlCol="0" anchor="ctr"/>
+          <a:lstStyle/>
+          <a:p>
+            <a:pPr algn="ctr" indent="0" marL="0">
+              <a:buNone/>
+            </a:pPr>
+            <a:r>
+              <a:rPr lang="en-US" sz="950" b="1" dirty="0">
+                <a:solidFill>
+                  <a:schemeClr val="accent1"/>
+                </a:solidFill>
+              </a:rPr>
+              <a:t>Market Access</a:t>
+            </a:r>
+            <a:endParaRPr lang="en-US" sz="950" dirty="0"/>
+          </a:p>
+        </p:txBody>
+      </p:sp>
+      <p:sp>
+        <p:nvSpPr>
+          <p:cNvPr id="20" name="Text 17"/>
+          <p:cNvSpPr txBox="1"/>
+          <p:nvPr/>
+        </p:nvSpPr>
+        <p:spPr>
+          <a:xfrm>
             <a:off x="1417320" y="2651760"/>
             <a:ext cx="9966960" cy="201168"/>
           </a:xfrm>
@@ -3508,14 +3634,14 @@
       </p:sp>
       <p:sp>
         <p:nvSpPr>
-          <p:cNvPr id="20" name="key findings card"/>
+          <p:cNvPr id="21" name="key findings card"/>
           <p:cNvSpPr/>
           <p:nvPr/>
         </p:nvSpPr>
         <p:spPr>
           <a:xfrm>
-            <a:off x="548640" y="3035808"/>
-            <a:ext cx="3575304" cy="2606040"/>
+            <a:off x="548640" y="3218688"/>
+            <a:ext cx="3575304" cy="2834640"/>
           </a:xfrm>
           <a:prstGeom prst="rect">
             <a:avLst/>
@@ -3535,13 +3661,13 @@
       </p:sp>
       <p:sp>
         <p:nvSpPr>
-          <p:cNvPr id="21" name="icon circle"/>
+          <p:cNvPr id="22" name="icon circle"/>
           <p:cNvSpPr/>
           <p:nvPr/>
         </p:nvSpPr>
         <p:spPr>
           <a:xfrm>
-            <a:off x="777240" y="3236976"/>
+            <a:off x="777240" y="3419856"/>
             <a:ext cx="457200" cy="457200"/>
           </a:xfrm>
           <a:prstGeom prst="ellipse">
@@ -3555,7 +3681,7 @@
       </p:sp>
       <p:pic>
         <p:nvPicPr>
-          <p:cNvPr id="22" name="icon MdInsights" descr="preencoded.png">    </p:cNvPr>
+          <p:cNvPr id="23" name="icon MdInsights" descr="preencoded.png">    </p:cNvPr>
           <p:cNvPicPr>
             <a:picLocks noChangeAspect="1"/>
           </p:cNvPicPr>
@@ -3569,7 +3695,7 @@
         </p:blipFill>
         <p:spPr>
           <a:xfrm>
-            <a:off x="877824" y="3337560"/>
+            <a:off x="877824" y="3520440"/>
             <a:ext cx="256032" cy="256032"/>
           </a:xfrm>
           <a:prstGeom prst="rect">
@@ -3579,13 +3705,13 @@
       </p:pic>
       <p:sp>
         <p:nvSpPr>
-          <p:cNvPr id="23" name="card label"/>
+          <p:cNvPr id="24" name="card label"/>
           <p:cNvSpPr txBox="1"/>
           <p:nvPr/>
         </p:nvSpPr>
         <p:spPr>
           <a:xfrm>
-            <a:off x="1353312" y="3328416"/>
+            <a:off x="1353312" y="3511296"/>
             <a:ext cx="2660904" cy="237744"/>
           </a:xfrm>
           <a:prstGeom prst="rect">
@@ -3615,13 +3741,13 @@
       </p:sp>
       <p:sp>
         <p:nvSpPr>
-          <p:cNvPr id="24" name="hero 19"/>
+          <p:cNvPr id="25" name="hero 19"/>
           <p:cNvSpPr txBox="1"/>
           <p:nvPr/>
         </p:nvSpPr>
         <p:spPr>
           <a:xfrm>
-            <a:off x="777240" y="3840480"/>
+            <a:off x="777240" y="4069080"/>
             <a:ext cx="621792" cy="502920"/>
           </a:xfrm>
           <a:prstGeom prst="rect">
@@ -3651,13 +3777,13 @@
       </p:sp>
       <p:sp>
         <p:nvSpPr>
-          <p:cNvPr id="25" name="Text 21"/>
+          <p:cNvPr id="26" name="Text 22"/>
           <p:cNvSpPr txBox="1"/>
           <p:nvPr/>
         </p:nvSpPr>
         <p:spPr>
           <a:xfrm>
-            <a:off x="1444752" y="3904488"/>
+            <a:off x="1444752" y="4133088"/>
             <a:ext cx="2478024" cy="749808"/>
           </a:xfrm>
           <a:prstGeom prst="rect">
@@ -3679,7 +3805,7 @@
                   <a:schemeClr val="tx1"/>
                 </a:solidFill>
               </a:rPr>
-              <a:t>The U.S. screen identified 19 qualifying conversational AI offerings across five decision workflows, </a:t>
+              <a:t>The U.S. screen identified </a:t>
             </a:r>
             <a:pPr indent="0" marL="0">
               <a:buNone/>
@@ -3690,7 +3816,7 @@
                   <a:schemeClr val="tx1"/>
                 </a:solidFill>
               </a:rPr>
-              <a:t>concentrated in RWE and commercial intelligence</a:t>
+              <a:t>19 conversational AI offerings</a:t>
             </a:r>
             <a:pPr indent="0" marL="0">
               <a:buNone/>
@@ -3701,6 +3827,28 @@
                   <a:schemeClr val="tx1"/>
                 </a:solidFill>
               </a:rPr>
+              <a:t> across five business domains, </a:t>
+            </a:r>
+            <a:pPr indent="0" marL="0">
+              <a:buNone/>
+            </a:pPr>
+            <a:r>
+              <a:rPr lang="en-US" sz="1050" b="1" dirty="0">
+                <a:solidFill>
+                  <a:schemeClr val="tx1"/>
+                </a:solidFill>
+              </a:rPr>
+              <a:t>concentrated in RWE and Commercial Intelligence</a:t>
+            </a:r>
+            <a:pPr indent="0" marL="0">
+              <a:buNone/>
+            </a:pPr>
+            <a:r>
+              <a:rPr lang="en-US" sz="1050" dirty="0">
+                <a:solidFill>
+                  <a:schemeClr val="tx1"/>
+                </a:solidFill>
+              </a:rPr>
               <a:t>.</a:t>
             </a:r>
             <a:endParaRPr lang="en-US" sz="1050" dirty="0"/>
@@ -3709,13 +3857,13 @@
       </p:sp>
       <p:sp>
         <p:nvSpPr>
-          <p:cNvPr id="26" name="Shape 22"/>
+          <p:cNvPr id="27" name="Shape 23"/>
           <p:cNvSpPr/>
           <p:nvPr/>
         </p:nvSpPr>
         <p:spPr>
           <a:xfrm>
-            <a:off x="777240" y="4690872"/>
+            <a:off x="777240" y="5010912"/>
             <a:ext cx="3118104" cy="0"/>
           </a:xfrm>
           <a:prstGeom prst="line">
@@ -3732,13 +3880,13 @@
       </p:sp>
       <p:sp>
         <p:nvSpPr>
-          <p:cNvPr id="27" name="hero 10"/>
+          <p:cNvPr id="28" name="hero 10"/>
           <p:cNvSpPr txBox="1"/>
           <p:nvPr/>
         </p:nvSpPr>
         <p:spPr>
           <a:xfrm>
-            <a:off x="777240" y="4736592"/>
+            <a:off x="777240" y="5056632"/>
             <a:ext cx="621792" cy="502920"/>
           </a:xfrm>
           <a:prstGeom prst="rect">
@@ -3768,13 +3916,13 @@
       </p:sp>
       <p:sp>
         <p:nvSpPr>
-          <p:cNvPr id="28" name="Text 24"/>
+          <p:cNvPr id="29" name="Text 25"/>
           <p:cNvSpPr txBox="1"/>
           <p:nvPr/>
         </p:nvSpPr>
         <p:spPr>
           <a:xfrm>
-            <a:off x="1444752" y="4800600"/>
+            <a:off x="1444752" y="5120640"/>
             <a:ext cx="2478024" cy="749808"/>
           </a:xfrm>
           <a:prstGeom prst="rect">
@@ -3796,7 +3944,29 @@
                   <a:schemeClr val="tx1"/>
                 </a:solidFill>
               </a:rPr>
-              <a:t>The selected international comparison identified 10 qualifying offerings, providing additional examples of how vendors position conversational interaction.</a:t>
+              <a:t>The selected international comparison identified </a:t>
+            </a:r>
+            <a:pPr indent="0" marL="0">
+              <a:buNone/>
+            </a:pPr>
+            <a:r>
+              <a:rPr lang="en-US" sz="1050" b="1" dirty="0">
+                <a:solidFill>
+                  <a:schemeClr val="tx1"/>
+                </a:solidFill>
+              </a:rPr>
+              <a:t>10 conversational AI offerings,</a:t>
+            </a:r>
+            <a:pPr indent="0" marL="0">
+              <a:buNone/>
+            </a:pPr>
+            <a:r>
+              <a:rPr lang="en-US" sz="1050" dirty="0">
+                <a:solidFill>
+                  <a:schemeClr val="tx1"/>
+                </a:solidFill>
+              </a:rPr>
+              <a:t> providing additional examples of how vendors position conversational interaction.</a:t>
             </a:r>
             <a:endParaRPr lang="en-US" sz="1050" dirty="0"/>
           </a:p>
@@ -3804,14 +3974,14 @@
       </p:sp>
       <p:sp>
         <p:nvSpPr>
-          <p:cNvPr id="29" name="optum positioning card"/>
+          <p:cNvPr id="30" name="optum positioning card"/>
           <p:cNvSpPr/>
           <p:nvPr/>
         </p:nvSpPr>
         <p:spPr>
           <a:xfrm>
-            <a:off x="4306824" y="3035808"/>
-            <a:ext cx="3575304" cy="2606040"/>
+            <a:off x="4306824" y="3218688"/>
+            <a:ext cx="3575304" cy="2834640"/>
           </a:xfrm>
           <a:prstGeom prst="rect">
             <a:avLst/>
@@ -3831,13 +4001,13 @@
       </p:sp>
       <p:sp>
         <p:nvSpPr>
-          <p:cNvPr id="30" name="icon circle"/>
+          <p:cNvPr id="31" name="icon circle"/>
           <p:cNvSpPr/>
           <p:nvPr/>
         </p:nvSpPr>
         <p:spPr>
           <a:xfrm>
-            <a:off x="4535424" y="3236976"/>
+            <a:off x="4535424" y="3419856"/>
             <a:ext cx="457200" cy="457200"/>
           </a:xfrm>
           <a:prstGeom prst="ellipse">
@@ -3851,7 +4021,7 @@
       </p:sp>
       <p:pic>
         <p:nvPicPr>
-          <p:cNvPr id="31" name="icon MdOutlineLayers" descr="preencoded.png">    </p:cNvPr>
+          <p:cNvPr id="32" name="icon MdOutlineLayers" descr="preencoded.png">    </p:cNvPr>
           <p:cNvPicPr>
             <a:picLocks noChangeAspect="1"/>
           </p:cNvPicPr>
@@ -3865,7 +4035,7 @@
         </p:blipFill>
         <p:spPr>
           <a:xfrm>
-            <a:off x="4636008" y="3337560"/>
+            <a:off x="4636008" y="3520440"/>
             <a:ext cx="256032" cy="256032"/>
           </a:xfrm>
           <a:prstGeom prst="rect">
@@ -3875,13 +4045,13 @@
       </p:pic>
       <p:sp>
         <p:nvSpPr>
-          <p:cNvPr id="32" name="card label"/>
+          <p:cNvPr id="33" name="card label"/>
           <p:cNvSpPr txBox="1"/>
           <p:nvPr/>
         </p:nvSpPr>
         <p:spPr>
           <a:xfrm>
-            <a:off x="5111496" y="3328416"/>
+            <a:off x="5111496" y="3511296"/>
             <a:ext cx="2660904" cy="237744"/>
           </a:xfrm>
           <a:prstGeom prst="rect">
@@ -3911,13 +4081,13 @@
       </p:sp>
       <p:sp>
         <p:nvSpPr>
-          <p:cNvPr id="33" name="Text 28"/>
+          <p:cNvPr id="34" name="Text 29"/>
           <p:cNvSpPr txBox="1"/>
           <p:nvPr/>
         </p:nvSpPr>
         <p:spPr>
           <a:xfrm>
-            <a:off x="4535424" y="3904488"/>
+            <a:off x="4535424" y="4087368"/>
             <a:ext cx="3118104" cy="1645920"/>
           </a:xfrm>
           <a:prstGeom prst="rect">
@@ -3984,14 +4154,14 @@
       </p:sp>
       <p:sp>
         <p:nvSpPr>
-          <p:cNvPr id="34" name="strategic implication card"/>
+          <p:cNvPr id="35" name="strategic implication card"/>
           <p:cNvSpPr/>
           <p:nvPr/>
         </p:nvSpPr>
         <p:spPr>
           <a:xfrm>
-            <a:off x="8065008" y="3035808"/>
-            <a:ext cx="3575304" cy="2606040"/>
+            <a:off x="8065008" y="3218688"/>
+            <a:ext cx="3575304" cy="2834640"/>
           </a:xfrm>
           <a:prstGeom prst="rect">
             <a:avLst/>
@@ -4011,13 +4181,13 @@
       </p:sp>
       <p:sp>
         <p:nvSpPr>
-          <p:cNvPr id="35" name="icon circle"/>
+          <p:cNvPr id="36" name="icon circle"/>
           <p:cNvSpPr/>
           <p:nvPr/>
         </p:nvSpPr>
         <p:spPr>
           <a:xfrm>
-            <a:off x="8293608" y="3236976"/>
+            <a:off x="8293608" y="3419856"/>
             <a:ext cx="457200" cy="457200"/>
           </a:xfrm>
           <a:prstGeom prst="ellipse">
@@ -4031,7 +4201,7 @@
       </p:sp>
       <p:pic>
         <p:nvPicPr>
-          <p:cNvPr id="36" name="icon MdOutlineLightbulb" descr="preencoded.png">    </p:cNvPr>
+          <p:cNvPr id="37" name="icon MdOutlineLightbulb" descr="preencoded.png">    </p:cNvPr>
           <p:cNvPicPr>
             <a:picLocks noChangeAspect="1"/>
           </p:cNvPicPr>
@@ -4045,7 +4215,7 @@
         </p:blipFill>
         <p:spPr>
           <a:xfrm>
-            <a:off x="8394192" y="3337560"/>
+            <a:off x="8394192" y="3520440"/>
             <a:ext cx="256032" cy="256032"/>
           </a:xfrm>
           <a:prstGeom prst="rect">
@@ -4055,13 +4225,13 @@
       </p:pic>
       <p:sp>
         <p:nvSpPr>
-          <p:cNvPr id="37" name="card label"/>
+          <p:cNvPr id="38" name="card label"/>
           <p:cNvSpPr txBox="1"/>
           <p:nvPr/>
         </p:nvSpPr>
         <p:spPr>
           <a:xfrm>
-            <a:off x="8869680" y="3328416"/>
+            <a:off x="8869680" y="3511296"/>
             <a:ext cx="2660904" cy="237744"/>
           </a:xfrm>
           <a:prstGeom prst="rect">
@@ -4091,13 +4261,13 @@
       </p:sp>
       <p:sp>
         <p:nvSpPr>
-          <p:cNvPr id="38" name="Text 32"/>
+          <p:cNvPr id="39" name="Text 33"/>
           <p:cNvSpPr txBox="1"/>
           <p:nvPr/>
         </p:nvSpPr>
         <p:spPr>
           <a:xfrm>
-            <a:off x="8293608" y="3904488"/>
+            <a:off x="8293608" y="4087368"/>
             <a:ext cx="3118104" cy="685800"/>
           </a:xfrm>
           <a:prstGeom prst="rect">
@@ -4127,13 +4297,13 @@
       </p:sp>
       <p:sp>
         <p:nvSpPr>
-          <p:cNvPr id="39" name="strategic question"/>
+          <p:cNvPr id="40" name="strategic question"/>
           <p:cNvSpPr txBox="1"/>
           <p:nvPr/>
         </p:nvSpPr>
         <p:spPr>
           <a:xfrm>
-            <a:off x="8293608" y="4636008"/>
+            <a:off x="8293608" y="4818888"/>
             <a:ext cx="3118104" cy="868680"/>
           </a:xfrm>
           <a:prstGeom prst="rect">
@@ -4155,45 +4325,9 @@
                   <a:schemeClr val="accent1"/>
                 </a:solidFill>
               </a:rPr>
-              <a:t>Where could conversational interaction add value to Optum's existing offerings?</a:t>
+              <a:t>Where could conversational interaction add value to Optum LS's existing offerings?</a:t>
             </a:r>
             <a:endParaRPr lang="en-US" sz="1400" dirty="0"/>
-          </a:p>
-        </p:txBody>
-      </p:sp>
-      <p:sp>
-        <p:nvSpPr>
-          <p:cNvPr id="40" name="evidence boundary"/>
-          <p:cNvSpPr txBox="1"/>
-          <p:nvPr/>
-        </p:nvSpPr>
-        <p:spPr>
-          <a:xfrm>
-            <a:off x="548640" y="5760720"/>
-            <a:ext cx="11091672" cy="365760"/>
-          </a:xfrm>
-          <a:prstGeom prst="rect">
-            <a:avLst/>
-          </a:prstGeom>
-          <a:noFill/>
-          <a:ln/>
-        </p:spPr>
-        <p:txBody>
-          <a:bodyPr wrap="square" lIns="0" tIns="0" rIns="0" bIns="0" rtlCol="0" anchor="t"/>
-          <a:lstStyle/>
-          <a:p>
-            <a:pPr indent="0" marL="0">
-              <a:buNone/>
-            </a:pPr>
-            <a:r>
-              <a:rPr lang="en-US" sz="900" i="1" dirty="0">
-                <a:solidFill>
-                  <a:schemeClr val="accent4"/>
-                </a:solidFill>
-              </a:rPr>
-              <a:t>Evidence boundary: Public product marketing and announcements reviewed as of October 13, 2026. The findings describe selected screened inventories—not a market census, adoption rates, verified product performance or undisclosed capabilities.</a:t>
-            </a:r>
-            <a:endParaRPr lang="en-US" sz="900" dirty="0"/>
           </a:p>
         </p:txBody>
       </p:sp>
@@ -4299,7 +4433,7 @@
                   <a:schemeClr val="accent2"/>
                 </a:solidFill>
               </a:rPr>
-              <a:t>AI SUPPLIERS EXPAND INTO LIFE SCIENCES</a:t>
+              <a:t>ADDITIONAL COMPETITIVE DYNAMIC: AI SUPPLIERS EXPAND INTO LIFE SCIENCES</a:t>
             </a:r>
             <a:endParaRPr lang="en-US" sz="1000" dirty="0"/>
           </a:p>
@@ -4337,7 +4471,7 @@
                   <a:schemeClr val="accent1"/>
                 </a:solidFill>
               </a:rPr>
-              <a:t>AI technology providers are expanding into pharmaceutical workflows through partnerships, specialized offerings and acquisitions</a:t>
+              <a:t>Conversational AI providers are expanding into pharmaceutical workflows through partnerships, specialized offerings and acquisitions</a:t>
             </a:r>
             <a:endParaRPr lang="en-US" sz="2200" dirty="0"/>
           </a:p>
@@ -4351,79 +4485,7 @@
         </p:nvSpPr>
         <p:spPr>
           <a:xfrm>
-            <a:off x="548640" y="1417320"/>
-            <a:ext cx="5486400" cy="201168"/>
-          </a:xfrm>
-          <a:prstGeom prst="rect">
-            <a:avLst/>
-          </a:prstGeom>
-          <a:noFill/>
-          <a:ln/>
-        </p:spPr>
-        <p:txBody>
-          <a:bodyPr wrap="square" lIns="0" tIns="0" rIns="0" bIns="0" rtlCol="0" anchor="t"/>
-          <a:lstStyle/>
-          <a:p>
-            <a:pPr indent="0" marL="0">
-              <a:buNone/>
-            </a:pPr>
-            <a:r>
-              <a:rPr lang="en-US" sz="1000" b="1" spc="100" kern="0" dirty="0">
-                <a:solidFill>
-                  <a:schemeClr val="accent2"/>
-                </a:solidFill>
-              </a:rPr>
-              <a:t>A SECOND COMPETITIVE DYNAMIC</a:t>
-            </a:r>
-            <a:endParaRPr lang="en-US" sz="1000" dirty="0"/>
-          </a:p>
-        </p:txBody>
-      </p:sp>
-      <p:sp>
-        <p:nvSpPr>
-          <p:cNvPr id="5" name="Text 3"/>
-          <p:cNvSpPr txBox="1"/>
-          <p:nvPr/>
-        </p:nvSpPr>
-        <p:spPr>
-          <a:xfrm>
-            <a:off x="548640" y="1645920"/>
-            <a:ext cx="11091672" cy="365760"/>
-          </a:xfrm>
-          <a:prstGeom prst="rect">
-            <a:avLst/>
-          </a:prstGeom>
-          <a:noFill/>
-          <a:ln/>
-        </p:spPr>
-        <p:txBody>
-          <a:bodyPr wrap="square" lIns="0" tIns="0" rIns="0" bIns="0" rtlCol="0" anchor="t"/>
-          <a:lstStyle/>
-          <a:p>
-            <a:pPr indent="0" marL="0">
-              <a:buNone/>
-            </a:pPr>
-            <a:r>
-              <a:rPr lang="en-US" sz="1000" dirty="0">
-                <a:solidFill>
-                  <a:schemeClr val="tx1"/>
-                </a:solidFill>
-              </a:rPr>
-              <a:t>The preceding slides examine conversational AI products marketed by established life-sciences data, technology and services companies. At the same time, AI model and infrastructure providers are pursuing life-sciences customers through several distinct approaches—some complementary to incumbent platforms, others potentially competitive.</a:t>
-            </a:r>
-            <a:endParaRPr lang="en-US" sz="1000" dirty="0"/>
-          </a:p>
-        </p:txBody>
-      </p:sp>
-      <p:sp>
-        <p:nvSpPr>
-          <p:cNvPr id="6" name="label"/>
-          <p:cNvSpPr txBox="1"/>
-          <p:nvPr/>
-        </p:nvSpPr>
-        <p:spPr>
-          <a:xfrm>
-            <a:off x="548640" y="2084832"/>
+            <a:off x="548640" y="1481328"/>
             <a:ext cx="7315200" cy="201168"/>
           </a:xfrm>
           <a:prstGeom prst="rect">
@@ -4466,7 +4528,7 @@
           </p:nvPr>
         </p:nvGraphicFramePr>
         <p:xfrm>
-          <a:off x="548640" y="2313432"/>
+          <a:off x="548640" y="1737360"/>
           <a:ext cx="11091672" cy="914400"/>
         </p:xfrm>
         <a:graphic>
@@ -4474,11 +4536,11 @@
             <a:tbl>
               <a:tblPr/>
               <a:tblGrid>
-                <a:gridCol w="1737360"/>
+                <a:gridCol w="1965960"/>
                 <a:gridCol w="5349240"/>
-                <a:gridCol w="4005072"/>
+                <a:gridCol w="3776472"/>
               </a:tblGrid>
-              <a:tr h="329184">
+              <a:tr h="402336">
                 <a:tc>
                   <a:txBody>
                     <a:bodyPr/>
@@ -4567,7 +4629,7 @@
                             <a:schemeClr val="bg1"/>
                           </a:solidFill>
                         </a:rPr>
-                        <a:t>COMPETITIVE SIGNIFICANCE FOR OPTUM LIFE SCIENCES</a:t>
+                        <a:t>COMPETITIVE SIGNIFICANCE FOR OPTUM LS</a:t>
                       </a:r>
                       <a:endParaRPr lang="en-US" sz="900" dirty="0"/>
                     </a:p>
@@ -5125,14 +5187,14 @@
       </p:graphicFrame>
       <p:sp>
         <p:nvSpPr>
-          <p:cNvPr id="8" name="strategic question card"/>
+          <p:cNvPr id="6" name="strategic question card"/>
           <p:cNvSpPr/>
           <p:nvPr/>
         </p:nvSpPr>
         <p:spPr>
           <a:xfrm>
-            <a:off x="548640" y="5241798"/>
-            <a:ext cx="11091672" cy="884682"/>
+            <a:off x="548640" y="4738878"/>
+            <a:ext cx="11091672" cy="1387602"/>
           </a:xfrm>
           <a:prstGeom prst="rect">
             <a:avLst/>
@@ -5152,14 +5214,14 @@
       </p:sp>
       <p:sp>
         <p:nvSpPr>
-          <p:cNvPr id="9" name="icon circle"/>
+          <p:cNvPr id="7" name="icon circle"/>
           <p:cNvSpPr/>
           <p:nvPr/>
         </p:nvSpPr>
         <p:spPr>
           <a:xfrm>
-            <a:off x="731520" y="5492115"/>
-            <a:ext cx="384048" cy="384048"/>
+            <a:off x="749808" y="4812030"/>
+            <a:ext cx="402336" cy="402336"/>
           </a:xfrm>
           <a:prstGeom prst="ellipse">
             <a:avLst/>
@@ -5172,7 +5234,7 @@
       </p:sp>
       <p:pic>
         <p:nvPicPr>
-          <p:cNvPr id="10" name="icon MdOutlineLightbulb" descr="preencoded.png">    </p:cNvPr>
+          <p:cNvPr id="8" name="icon MdOutlineLightbulb" descr="preencoded.png">    </p:cNvPr>
           <p:cNvPicPr>
             <a:picLocks noChangeAspect="1"/>
           </p:cNvPicPr>
@@ -5186,8 +5248,8 @@
         </p:blipFill>
         <p:spPr>
           <a:xfrm>
-            <a:off x="816011" y="5576606"/>
-            <a:ext cx="215067" cy="215067"/>
+            <a:off x="838322" y="4900544"/>
+            <a:ext cx="225308" cy="225308"/>
           </a:xfrm>
           <a:prstGeom prst="rect">
             <a:avLst/>
@@ -5196,14 +5258,14 @@
       </p:pic>
       <p:sp>
         <p:nvSpPr>
-          <p:cNvPr id="11" name="label"/>
+          <p:cNvPr id="9" name="label"/>
           <p:cNvSpPr txBox="1"/>
           <p:nvPr/>
         </p:nvSpPr>
         <p:spPr>
           <a:xfrm>
-            <a:off x="1234440" y="5333238"/>
-            <a:ext cx="1280160" cy="701802"/>
+            <a:off x="1280160" y="4812030"/>
+            <a:ext cx="7315200" cy="402336"/>
           </a:xfrm>
           <a:prstGeom prst="rect">
             <a:avLst/>
@@ -5219,50 +5281,50 @@
               <a:buNone/>
             </a:pPr>
             <a:r>
-              <a:rPr lang="en-US" sz="850" b="1" spc="100" kern="0" dirty="0">
+              <a:rPr lang="en-US" sz="1300" b="1" spc="150" kern="0" dirty="0">
                 <a:solidFill>
                   <a:schemeClr val="accent2"/>
                 </a:solidFill>
               </a:rPr>
-              <a:t>THE STRATEGIC QUESTION FOR OPTUM LIFE SCIENCES</a:t>
-            </a:r>
-            <a:endParaRPr lang="en-US" sz="850" dirty="0"/>
-          </a:p>
-        </p:txBody>
-      </p:sp>
-      <p:sp>
-        <p:nvSpPr>
-          <p:cNvPr id="12" name="Text 8"/>
+              <a:t>STRATEGIC QUESTIONS FOR OPTUM LS</a:t>
+            </a:r>
+            <a:endParaRPr lang="en-US" sz="1300" dirty="0"/>
+          </a:p>
+        </p:txBody>
+      </p:sp>
+      <p:sp>
+        <p:nvSpPr>
+          <p:cNvPr id="10" name="Text 6"/>
           <p:cNvSpPr txBox="1"/>
           <p:nvPr/>
         </p:nvSpPr>
         <p:spPr>
           <a:xfrm>
-            <a:off x="2651760" y="5314950"/>
-            <a:ext cx="8805672" cy="738378"/>
-          </a:xfrm>
-          <a:prstGeom prst="rect">
-            <a:avLst/>
-          </a:prstGeom>
-          <a:noFill/>
-          <a:ln/>
-        </p:spPr>
-        <p:txBody>
-          <a:bodyPr wrap="square" lIns="0" tIns="0" rIns="0" bIns="0" rtlCol="0" anchor="ctr"/>
+            <a:off x="1280160" y="5287518"/>
+            <a:ext cx="10131552" cy="777240"/>
+          </a:xfrm>
+          <a:prstGeom prst="rect">
+            <a:avLst/>
+          </a:prstGeom>
+          <a:noFill/>
+          <a:ln/>
+        </p:spPr>
+        <p:txBody>
+          <a:bodyPr wrap="square" lIns="0" tIns="0" rIns="0" bIns="0" rtlCol="0" anchor="t"/>
           <a:lstStyle/>
           <a:p>
             <a:pPr indent="0" marL="0">
               <a:buNone/>
             </a:pPr>
             <a:r>
-              <a:rPr lang="en-US" sz="1050" b="1" dirty="0">
+              <a:rPr lang="en-US" sz="1100" b="1" dirty="0">
                 <a:solidFill>
                   <a:schemeClr val="accent1"/>
                 </a:solidFill>
               </a:rPr>
-              <a:t>As AI providers expand beyond supplying general-purpose models, where will they remain technology partners to established life-sciences vendors—and where might they increasingly compete for the same pharmaceutical customers and workflows?</a:t>
-            </a:r>
-            <a:endParaRPr lang="en-US" sz="1050" dirty="0"/>
+              <a:t>As conversational AI providers expand beyond supplying general-purpose models, where will they remain technology partners to established life-sciences vendors—and where might they increasingly compete for the same pharmaceutical customers and workflows?</a:t>
+            </a:r>
+            <a:endParaRPr lang="en-US" sz="1100" dirty="0"/>
           </a:p>
           <a:p>
             <a:pPr indent="0" marL="0">
@@ -5272,14 +5334,14 @@
               <a:buNone/>
             </a:pPr>
             <a:r>
-              <a:rPr lang="en-US" sz="1050" b="1" dirty="0">
+              <a:rPr lang="en-US" sz="1100" b="1" dirty="0">
                 <a:solidFill>
                   <a:schemeClr val="accent1"/>
                 </a:solidFill>
               </a:rPr>
               <a:t>What could these developments mean for the competitive positions of companies whose offerings combine differentiated healthcare data, research tools and scientific expertise?</a:t>
             </a:r>
-            <a:endParaRPr lang="en-US" sz="1050" dirty="0"/>
+            <a:endParaRPr lang="en-US" sz="1100" dirty="0"/>
           </a:p>
         </p:txBody>
       </p:sp>
@@ -5393,14 +5455,14 @@
       </p:sp>
       <p:sp>
         <p:nvSpPr>
-          <p:cNvPr id="3" name="slide 3 — methodology note"/>
+          <p:cNvPr id="3" name="slide 1 — evidence boundary"/>
           <p:cNvSpPr/>
           <p:nvPr/>
         </p:nvSpPr>
         <p:spPr>
           <a:xfrm>
-            <a:off x="548640" y="749808"/>
-            <a:ext cx="3599688" cy="1627632"/>
+            <a:off x="548640" y="822960"/>
+            <a:ext cx="3587496" cy="2171700"/>
           </a:xfrm>
           <a:prstGeom prst="rect">
             <a:avLst/>
@@ -5426,8 +5488,8 @@
         </p:nvSpPr>
         <p:spPr>
           <a:xfrm>
-            <a:off x="713232" y="877824"/>
-            <a:ext cx="3270504" cy="201168"/>
+            <a:off x="731520" y="969264"/>
+            <a:ext cx="3221736" cy="219456"/>
           </a:xfrm>
           <a:prstGeom prst="rect">
             <a:avLst/>
@@ -5443,14 +5505,14 @@
               <a:buNone/>
             </a:pPr>
             <a:r>
-              <a:rPr lang="en-US" sz="900" b="1" spc="100" kern="0" dirty="0">
+              <a:rPr lang="en-US" sz="1000" b="1" spc="100" kern="0" dirty="0">
                 <a:solidFill>
                   <a:schemeClr val="accent2"/>
                 </a:solidFill>
               </a:rPr>
-              <a:t>SLIDE 3 — METHODOLOGY NOTE</a:t>
-            </a:r>
-            <a:endParaRPr lang="en-US" sz="900" dirty="0"/>
+              <a:t>SLIDE 1 — EVIDENCE BOUNDARY</a:t>
+            </a:r>
+            <a:endParaRPr lang="en-US" sz="1000" dirty="0"/>
           </a:p>
         </p:txBody>
       </p:sp>
@@ -5462,8 +5524,8 @@
         </p:nvSpPr>
         <p:spPr>
           <a:xfrm>
-            <a:off x="713232" y="1133856"/>
-            <a:ext cx="3270504" cy="1170432"/>
+            <a:off x="731520" y="1243584"/>
+            <a:ext cx="3221736" cy="1677924"/>
           </a:xfrm>
           <a:prstGeom prst="rect">
             <a:avLst/>
@@ -5479,71 +5541,27 @@
               <a:buNone/>
             </a:pPr>
             <a:r>
-              <a:rPr lang="en-US" sz="900" dirty="0">
+              <a:rPr lang="en-US" sz="1000" dirty="0">
                 <a:solidFill>
                   <a:schemeClr val="tx1"/>
                 </a:solidFill>
               </a:rPr>
-              <a:t>Comparable competitors include </a:t>
-            </a:r>
-            <a:pPr indent="0" marL="0">
-              <a:buNone/>
-            </a:pPr>
-            <a:r>
-              <a:rPr lang="en-US" sz="900" b="1" dirty="0">
-                <a:solidFill>
-                  <a:schemeClr val="tx1"/>
-                </a:solidFill>
-              </a:rPr>
-              <a:t>direct and specialized/partial offering-level competitors</a:t>
-            </a:r>
-            <a:pPr indent="0" marL="0">
-              <a:buNone/>
-            </a:pPr>
-            <a:r>
-              <a:rPr lang="en-US" sz="900" dirty="0">
-                <a:solidFill>
-                  <a:schemeClr val="tx1"/>
-                </a:solidFill>
-              </a:rPr>
-              <a:t> serving similar customer tasks; adjacent participants are excluded. Counts represent distinct company groups per workflow, not product totals. A company may appear in multiple workflows. Optum's ○ indicates that a qualifying conversational interface was </a:t>
-            </a:r>
-            <a:pPr indent="0" marL="0">
-              <a:buNone/>
-            </a:pPr>
-            <a:r>
-              <a:rPr lang="en-US" sz="900" i="1" dirty="0">
-                <a:solidFill>
-                  <a:schemeClr val="tx1"/>
-                </a:solidFill>
-              </a:rPr>
-              <a:t>not publicly established in this review</a:t>
-            </a:r>
-            <a:pPr indent="0" marL="0">
-              <a:buNone/>
-            </a:pPr>
-            <a:r>
-              <a:rPr lang="en-US" sz="900" dirty="0">
-                <a:solidFill>
-                  <a:schemeClr val="tx1"/>
-                </a:solidFill>
-              </a:rPr>
-              <a:t>, not that the capability is absent. These are selected screened companies, not market-wide adoption rates.</a:t>
-            </a:r>
-            <a:endParaRPr lang="en-US" sz="900" dirty="0"/>
-          </a:p>
-        </p:txBody>
-      </p:sp>
-      <p:sp>
-        <p:nvSpPr>
-          <p:cNvPr id="6" name="slide 4 — india reconciliation"/>
+              <a:t>Public product marketing and announcements reviewed as of October 13, 2026. The findings describe selected screened inventories—not a market census, adoption rates, verified product performance or undisclosed capabilities.</a:t>
+            </a:r>
+            <a:endParaRPr lang="en-US" sz="1000" dirty="0"/>
+          </a:p>
+        </p:txBody>
+      </p:sp>
+      <p:sp>
+        <p:nvSpPr>
+          <p:cNvPr id="6" name="slide 2 — evidence boundary"/>
           <p:cNvSpPr/>
           <p:nvPr/>
         </p:nvSpPr>
         <p:spPr>
           <a:xfrm>
-            <a:off x="4294632" y="749808"/>
-            <a:ext cx="3599688" cy="1627632"/>
+            <a:off x="4300728" y="822960"/>
+            <a:ext cx="3587496" cy="2171700"/>
           </a:xfrm>
           <a:prstGeom prst="rect">
             <a:avLst/>
@@ -5569,8 +5587,8 @@
         </p:nvSpPr>
         <p:spPr>
           <a:xfrm>
-            <a:off x="4459224" y="877824"/>
-            <a:ext cx="3270504" cy="201168"/>
+            <a:off x="4483608" y="969264"/>
+            <a:ext cx="3221736" cy="219456"/>
           </a:xfrm>
           <a:prstGeom prst="rect">
             <a:avLst/>
@@ -5586,14 +5604,14 @@
               <a:buNone/>
             </a:pPr>
             <a:r>
-              <a:rPr lang="en-US" sz="900" b="1" spc="100" kern="0" dirty="0">
+              <a:rPr lang="en-US" sz="1000" b="1" spc="100" kern="0" dirty="0">
                 <a:solidFill>
                   <a:schemeClr val="accent2"/>
                 </a:solidFill>
               </a:rPr>
-              <a:t>SLIDE 4 — INDIA RECONCILIATION</a:t>
-            </a:r>
-            <a:endParaRPr lang="en-US" sz="900" dirty="0"/>
+              <a:t>SLIDE 2 — EVIDENCE BOUNDARY</a:t>
+            </a:r>
+            <a:endParaRPr lang="en-US" sz="1000" dirty="0"/>
           </a:p>
         </p:txBody>
       </p:sp>
@@ -5605,8 +5623,8 @@
         </p:nvSpPr>
         <p:spPr>
           <a:xfrm>
-            <a:off x="4459224" y="1133856"/>
-            <a:ext cx="3270504" cy="1170432"/>
+            <a:off x="4483608" y="1243584"/>
+            <a:ext cx="3221736" cy="1677924"/>
           </a:xfrm>
           <a:prstGeom prst="rect">
             <a:avLst/>
@@ -5622,27 +5640,27 @@
               <a:buNone/>
             </a:pPr>
             <a:r>
-              <a:rPr lang="en-US" sz="900" dirty="0">
+              <a:rPr lang="en-US" sz="1000" dirty="0">
                 <a:solidFill>
                   <a:schemeClr val="tx1"/>
                 </a:solidFill>
               </a:rPr>
-              <a:t>Of 37 screened companies, 36 qualify as direct/specialized comparators in at least one of the five decision workflows; excluding four companies already represented in the qualifying U.S. chat cohort leaves 32. Three additional chat-marketing companies qualify: Axtria, Doceree and Genpact. Company presence in an India screen does not prove the specific product is available or deployed in India.</a:t>
-            </a:r>
-            <a:endParaRPr lang="en-US" sz="900" dirty="0"/>
-          </a:p>
-        </p:txBody>
-      </p:sp>
-      <p:sp>
-        <p:nvSpPr>
-          <p:cNvPr id="9" name="slide 4 — evidence boundary"/>
+              <a:t>Dates reflect selected public announcements or releases, not necessarily first feature availability. The timeline illustrates a research catalyst, not measured market-wide growth. AI-enabled or agentic launches are not automatically qualifying conversational products; the Norstella example is excluded from the final conversational count.</a:t>
+            </a:r>
+            <a:endParaRPr lang="en-US" sz="1000" dirty="0"/>
+          </a:p>
+        </p:txBody>
+      </p:sp>
+      <p:sp>
+        <p:nvSpPr>
+          <p:cNvPr id="9" name="slide 3 — methodology note"/>
           <p:cNvSpPr/>
           <p:nvPr/>
         </p:nvSpPr>
         <p:spPr>
           <a:xfrm>
-            <a:off x="8040624" y="749808"/>
-            <a:ext cx="3599688" cy="1627632"/>
+            <a:off x="8052816" y="822960"/>
+            <a:ext cx="3587496" cy="2171700"/>
           </a:xfrm>
           <a:prstGeom prst="rect">
             <a:avLst/>
@@ -5668,8 +5686,8 @@
         </p:nvSpPr>
         <p:spPr>
           <a:xfrm>
-            <a:off x="8205216" y="877824"/>
-            <a:ext cx="3270504" cy="201168"/>
+            <a:off x="8235696" y="969264"/>
+            <a:ext cx="3221736" cy="219456"/>
           </a:xfrm>
           <a:prstGeom prst="rect">
             <a:avLst/>
@@ -5685,14 +5703,14 @@
               <a:buNone/>
             </a:pPr>
             <a:r>
-              <a:rPr lang="en-US" sz="900" b="1" spc="100" kern="0" dirty="0">
+              <a:rPr lang="en-US" sz="1000" b="1" spc="100" kern="0" dirty="0">
                 <a:solidFill>
                   <a:schemeClr val="accent2"/>
                 </a:solidFill>
               </a:rPr>
-              <a:t>SLIDE 4 — EVIDENCE BOUNDARY</a:t>
-            </a:r>
-            <a:endParaRPr lang="en-US" sz="900" dirty="0"/>
+              <a:t>SLIDE 3 — METHODOLOGY NOTE</a:t>
+            </a:r>
+            <a:endParaRPr lang="en-US" sz="1000" dirty="0"/>
           </a:p>
         </p:txBody>
       </p:sp>
@@ -5704,8 +5722,8 @@
         </p:nvSpPr>
         <p:spPr>
           <a:xfrm>
-            <a:off x="8205216" y="1133856"/>
-            <a:ext cx="3270504" cy="1170432"/>
+            <a:off x="8235696" y="1243584"/>
+            <a:ext cx="3221736" cy="1677924"/>
           </a:xfrm>
           <a:prstGeom prst="rect">
             <a:avLst/>
@@ -5721,27 +5739,71 @@
               <a:buNone/>
             </a:pPr>
             <a:r>
-              <a:rPr lang="en-US" sz="900" dirty="0">
+              <a:rPr lang="en-US" sz="1000" dirty="0">
                 <a:solidFill>
                   <a:schemeClr val="tx1"/>
                 </a:solidFill>
               </a:rPr>
-              <a:t>Selected country/region screens differ in research depth and company composition and are not representative national market samples. The Nordics screen groups Denmark, Finland, Norway and Sweden. A multinational may appear in multiple country screens; the counts are not additive across countries. A globally marketed product does not establish locally verified use. Percentages show shares within screened comparable companies, not regional adoption, customer penetration or product deployment rates.</a:t>
-            </a:r>
-            <a:endParaRPr lang="en-US" sz="900" dirty="0"/>
-          </a:p>
-        </p:txBody>
-      </p:sp>
-      <p:sp>
-        <p:nvSpPr>
-          <p:cNvPr id="12" name="slide 5 — evidence boundary"/>
+              <a:t>Comparable competitors include </a:t>
+            </a:r>
+            <a:pPr indent="0" marL="0">
+              <a:buNone/>
+            </a:pPr>
+            <a:r>
+              <a:rPr lang="en-US" sz="1000" b="1" dirty="0">
+                <a:solidFill>
+                  <a:schemeClr val="tx1"/>
+                </a:solidFill>
+              </a:rPr>
+              <a:t>direct and specialized/partial offering-level competitors</a:t>
+            </a:r>
+            <a:pPr indent="0" marL="0">
+              <a:buNone/>
+            </a:pPr>
+            <a:r>
+              <a:rPr lang="en-US" sz="1000" dirty="0">
+                <a:solidFill>
+                  <a:schemeClr val="tx1"/>
+                </a:solidFill>
+              </a:rPr>
+              <a:t> serving similar customer tasks; adjacent participants are excluded. Counts represent distinct company groups per workflow, not product totals. A company may appear in multiple workflows. Optum's ○ indicates that a qualifying conversational interface was </a:t>
+            </a:r>
+            <a:pPr indent="0" marL="0">
+              <a:buNone/>
+            </a:pPr>
+            <a:r>
+              <a:rPr lang="en-US" sz="1000" i="1" dirty="0">
+                <a:solidFill>
+                  <a:schemeClr val="tx1"/>
+                </a:solidFill>
+              </a:rPr>
+              <a:t>not publicly established in this review</a:t>
+            </a:r>
+            <a:pPr indent="0" marL="0">
+              <a:buNone/>
+            </a:pPr>
+            <a:r>
+              <a:rPr lang="en-US" sz="1000" dirty="0">
+                <a:solidFill>
+                  <a:schemeClr val="tx1"/>
+                </a:solidFill>
+              </a:rPr>
+              <a:t>, not that the capability is absent. These are selected screened companies, not market-wide adoption rates.</a:t>
+            </a:r>
+            <a:endParaRPr lang="en-US" sz="1000" dirty="0"/>
+          </a:p>
+        </p:txBody>
+      </p:sp>
+      <p:sp>
+        <p:nvSpPr>
+          <p:cNvPr id="12" name="slide 4 — india reconciliation"/>
           <p:cNvSpPr/>
           <p:nvPr/>
         </p:nvSpPr>
         <p:spPr>
           <a:xfrm>
-            <a:off x="548640" y="2523744"/>
-            <a:ext cx="3599688" cy="1209294"/>
+            <a:off x="548640" y="3159252"/>
+            <a:ext cx="3587496" cy="2171700"/>
           </a:xfrm>
           <a:prstGeom prst="rect">
             <a:avLst/>
@@ -5767,8 +5829,8 @@
         </p:nvSpPr>
         <p:spPr>
           <a:xfrm>
-            <a:off x="713232" y="2651760"/>
-            <a:ext cx="3270504" cy="201168"/>
+            <a:off x="731520" y="3305556"/>
+            <a:ext cx="3221736" cy="219456"/>
           </a:xfrm>
           <a:prstGeom prst="rect">
             <a:avLst/>
@@ -5784,14 +5846,14 @@
               <a:buNone/>
             </a:pPr>
             <a:r>
-              <a:rPr lang="en-US" sz="900" b="1" spc="100" kern="0" dirty="0">
+              <a:rPr lang="en-US" sz="1000" b="1" spc="100" kern="0" dirty="0">
                 <a:solidFill>
                   <a:schemeClr val="accent2"/>
                 </a:solidFill>
               </a:rPr>
-              <a:t>SLIDE 5 — EVIDENCE BOUNDARY</a:t>
-            </a:r>
-            <a:endParaRPr lang="en-US" sz="900" dirty="0"/>
+              <a:t>SLIDE 4 — INDIA RECONCILIATION</a:t>
+            </a:r>
+            <a:endParaRPr lang="en-US" sz="1000" dirty="0"/>
           </a:p>
         </p:txBody>
       </p:sp>
@@ -5803,8 +5865,8 @@
         </p:nvSpPr>
         <p:spPr>
           <a:xfrm>
-            <a:off x="713232" y="2907792"/>
-            <a:ext cx="3270504" cy="752094"/>
+            <a:off x="731520" y="3579876"/>
+            <a:ext cx="3221736" cy="1677924"/>
           </a:xfrm>
           <a:prstGeom prst="rect">
             <a:avLst/>
@@ -5820,27 +5882,27 @@
               <a:buNone/>
             </a:pPr>
             <a:r>
-              <a:rPr lang="en-US" sz="900" dirty="0">
+              <a:rPr lang="en-US" sz="1000" dirty="0">
                 <a:solidFill>
                   <a:schemeClr val="tx1"/>
                 </a:solidFill>
               </a:rPr>
-              <a:t>Scope: Six qualifying U.S. conversational offerings plus two selected international examples. Optum offerings are task-level comparators, not established conversational equivalents. Descriptions reflect public marketing, not independently verified performance or data access.</a:t>
-            </a:r>
-            <a:endParaRPr lang="en-US" sz="900" dirty="0"/>
-          </a:p>
-        </p:txBody>
-      </p:sp>
-      <p:sp>
-        <p:nvSpPr>
-          <p:cNvPr id="15" name="slide 6 — evidence boundary"/>
+              <a:t>Of 37 screened companies, 36 qualify as direct/specialized comparators in at least one of the five decision workflows; excluding four companies already represented in the qualifying U.S. chat cohort leaves 32. Three additional chat-marketing companies qualify: Axtria, Doceree and Genpact. Company presence in an India screen does not prove the specific product is available or deployed in India.</a:t>
+            </a:r>
+            <a:endParaRPr lang="en-US" sz="1000" dirty="0"/>
+          </a:p>
+        </p:txBody>
+      </p:sp>
+      <p:sp>
+        <p:nvSpPr>
+          <p:cNvPr id="15" name="slide 4 — evidence boundary"/>
           <p:cNvSpPr/>
           <p:nvPr/>
         </p:nvSpPr>
         <p:spPr>
           <a:xfrm>
-            <a:off x="4294632" y="2523744"/>
-            <a:ext cx="3599688" cy="1209294"/>
+            <a:off x="4300728" y="3159252"/>
+            <a:ext cx="3587496" cy="2171700"/>
           </a:xfrm>
           <a:prstGeom prst="rect">
             <a:avLst/>
@@ -5866,8 +5928,8 @@
         </p:nvSpPr>
         <p:spPr>
           <a:xfrm>
-            <a:off x="4459224" y="2651760"/>
-            <a:ext cx="3270504" cy="201168"/>
+            <a:off x="4483608" y="3305556"/>
+            <a:ext cx="3221736" cy="219456"/>
           </a:xfrm>
           <a:prstGeom prst="rect">
             <a:avLst/>
@@ -5883,14 +5945,14 @@
               <a:buNone/>
             </a:pPr>
             <a:r>
-              <a:rPr lang="en-US" sz="900" b="1" spc="100" kern="0" dirty="0">
+              <a:rPr lang="en-US" sz="1000" b="1" spc="100" kern="0" dirty="0">
                 <a:solidFill>
                   <a:schemeClr val="accent2"/>
                 </a:solidFill>
               </a:rPr>
-              <a:t>SLIDE 6 — EVIDENCE BOUNDARY</a:t>
-            </a:r>
-            <a:endParaRPr lang="en-US" sz="900" dirty="0"/>
+              <a:t>SLIDE 4 — EVIDENCE BOUNDARY</a:t>
+            </a:r>
+            <a:endParaRPr lang="en-US" sz="1000" dirty="0"/>
           </a:p>
         </p:txBody>
       </p:sp>
@@ -5902,8 +5964,8 @@
         </p:nvSpPr>
         <p:spPr>
           <a:xfrm>
-            <a:off x="4459224" y="2907792"/>
-            <a:ext cx="3270504" cy="752094"/>
+            <a:off x="4483608" y="3579876"/>
+            <a:ext cx="3221736" cy="1677924"/>
           </a:xfrm>
           <a:prstGeom prst="rect">
             <a:avLst/>
@@ -5919,27 +5981,27 @@
               <a:buNone/>
             </a:pPr>
             <a:r>
-              <a:rPr lang="en-US" sz="900" dirty="0">
+              <a:rPr lang="en-US" sz="1000" dirty="0">
                 <a:solidFill>
                   <a:schemeClr val="tx1"/>
                 </a:solidFill>
               </a:rPr>
-              <a:t>Scope: Four qualifying U.S. conversational offerings plus two selected international examples. Product descriptions are based on public marketing; study-grade reliability, data entitlements and actual deployment are not independently established.</a:t>
-            </a:r>
-            <a:endParaRPr lang="en-US" sz="900" dirty="0"/>
-          </a:p>
-        </p:txBody>
-      </p:sp>
-      <p:sp>
-        <p:nvSpPr>
-          <p:cNvPr id="18" name="slide 7 — evidence boundary"/>
+              <a:t>Selected country/region screens differ in research depth and company composition and are not representative national market samples. The Nordics screen groups Denmark, Finland, Norway and Sweden. A multinational may appear in multiple country screens; the counts are not additive across countries. A globally marketed product does not establish locally verified use. Percentages show shares within screened comparable companies, not regional adoption, customer penetration or product deployment rates.</a:t>
+            </a:r>
+            <a:endParaRPr lang="en-US" sz="1000" dirty="0"/>
+          </a:p>
+        </p:txBody>
+      </p:sp>
+      <p:sp>
+        <p:nvSpPr>
+          <p:cNvPr id="18" name="slide 5 — evidence boundary"/>
           <p:cNvSpPr/>
           <p:nvPr/>
         </p:nvSpPr>
         <p:spPr>
           <a:xfrm>
-            <a:off x="8040624" y="2523744"/>
-            <a:ext cx="3599688" cy="1209294"/>
+            <a:off x="8052816" y="3159252"/>
+            <a:ext cx="3587496" cy="2171700"/>
           </a:xfrm>
           <a:prstGeom prst="rect">
             <a:avLst/>
@@ -5965,8 +6027,8 @@
         </p:nvSpPr>
         <p:spPr>
           <a:xfrm>
-            <a:off x="8205216" y="2651760"/>
-            <a:ext cx="3270504" cy="201168"/>
+            <a:off x="8235696" y="3305556"/>
+            <a:ext cx="3221736" cy="219456"/>
           </a:xfrm>
           <a:prstGeom prst="rect">
             <a:avLst/>
@@ -5982,14 +6044,14 @@
               <a:buNone/>
             </a:pPr>
             <a:r>
-              <a:rPr lang="en-US" sz="900" b="1" spc="100" kern="0" dirty="0">
+              <a:rPr lang="en-US" sz="1000" b="1" spc="100" kern="0" dirty="0">
                 <a:solidFill>
                   <a:schemeClr val="accent2"/>
                 </a:solidFill>
               </a:rPr>
-              <a:t>SLIDE 7 — EVIDENCE BOUNDARY</a:t>
-            </a:r>
-            <a:endParaRPr lang="en-US" sz="900" dirty="0"/>
+              <a:t>SLIDE 5 — EVIDENCE BOUNDARY</a:t>
+            </a:r>
+            <a:endParaRPr lang="en-US" sz="1000" dirty="0"/>
           </a:p>
         </p:txBody>
       </p:sp>
@@ -6001,8 +6063,8 @@
         </p:nvSpPr>
         <p:spPr>
           <a:xfrm>
-            <a:off x="8205216" y="2907792"/>
-            <a:ext cx="3270504" cy="752094"/>
+            <a:off x="8235696" y="3579876"/>
+            <a:ext cx="3221736" cy="1677924"/>
           </a:xfrm>
           <a:prstGeom prst="rect">
             <a:avLst/>
@@ -6018,27 +6080,165 @@
               <a:buNone/>
             </a:pPr>
             <a:r>
-              <a:rPr lang="en-US" sz="900" dirty="0">
+              <a:rPr lang="en-US" sz="1000" dirty="0">
                 <a:solidFill>
                   <a:schemeClr val="tx1"/>
                 </a:solidFill>
               </a:rPr>
-              <a:t>Scope: All four qualifying U.S. commercial conversational offerings plus four selected international examples. Customer tasks are not interchangeable; Optum comparisons are based on public offerings, not feature-for-feature validation. International examples are illustrative, not a geographic prevalence comparison.</a:t>
-            </a:r>
-            <a:endParaRPr lang="en-US" sz="900" dirty="0"/>
-          </a:p>
-        </p:txBody>
-      </p:sp>
-      <p:sp>
-        <p:nvSpPr>
-          <p:cNvPr id="21" name="slide 8 — evidence boundary"/>
+              <a:t>Scope: Six qualifying U.S. conversational offerings plus two selected international examples. Optum offerings are task-level comparators, not established conversational equivalents. Descriptions reflect public marketing, not independently verified performance or data access.</a:t>
+            </a:r>
+            <a:endParaRPr lang="en-US" sz="1000" dirty="0"/>
+          </a:p>
+        </p:txBody>
+      </p:sp>
+      <p:sp>
+        <p:nvSpPr>
+          <p:cNvPr id="21" name="Text 2"/>
           <p:cNvSpPr/>
-          <p:nvPr/>
-        </p:nvSpPr>
-        <p:spPr>
-          <a:xfrm>
-            <a:off x="548640" y="3879342"/>
-            <a:ext cx="3599688" cy="1767078"/>
+          <p:nvPr>
+            <p:ph idx="103" type="title" hasCustomPrompt="1"/>
+          </p:nvPr>
+        </p:nvSpPr>
+        <p:spPr>
+          <a:xfrm>
+            <a:off x="548640" y="640080"/>
+            <a:ext cx="11091672" cy="749808"/>
+          </a:xfrm>
+          <a:prstGeom prst="rect">
+            <a:avLst/>
+          </a:prstGeom>
+          <a:noFill/>
+          <a:ln/>
+        </p:spPr>
+        <p:txBody>
+          <a:bodyPr wrap="square" lIns="0" tIns="0" rIns="0" bIns="0" rtlCol="0" anchor="t"/>
+          <a:lstStyle/>
+          <a:p>
+            <a:pPr algn="l" indent="0" marL="0">
+              <a:buNone/>
+            </a:pPr>
+            <a:endParaRPr lang="en-US" sz="2200" dirty="0"/>
+          </a:p>
+        </p:txBody>
+      </p:sp>
+      <p:sp>
+        <p:nvSpPr>
+          <p:cNvPr id="25" name="Slide Number Placeholder 0"/>
+          <p:cNvSpPr>
+            <a:spLocks noGrp="1"/>
+          </p:cNvSpPr>
+          <p:nvPr>
+            <p:ph type="sldNum" sz="quarter" idx="4294967295"/>
+          </p:nvPr>
+        </p:nvSpPr>
+        <p:spPr>
+          <a:xfrm>
+            <a:off x="10725912" y="6309360"/>
+            <a:ext cx="914400" cy="201168"/>
+          </a:xfrm>
+          <a:prstGeom prst="rect">
+            <a:avLst/>
+          </a:prstGeom>
+          <a:extLst>
+            <a:ext uri="{C572A759-6A51-4108-AA02-DFA0A04FC94B}">
+              <ma14:wrappingTextBoxFlag xmlns:ma14="http://schemas.microsoft.com/office/mac/drawingml/2011/main" val="0"/>
+            </a:ext>
+          </a:extLst>
+        </p:spPr>
+        <p:txBody>
+          <a:bodyPr lIns="0" tIns="0" rIns="0" bIns="0"/>
+          <a:lstStyle>
+            <a:lvl1pPr>
+              <a:defRPr sz="900">
+                <a:solidFill>
+                  <a:schemeClr val="accent4"/>
+                </a:solidFill>
+              </a:defRPr>
+            </a:lvl1pPr>
+          </a:lstStyle>
+          <a:p>
+            <a:pPr algn="r"/>
+            <a:fld id="{F7021451-1387-4CA6-816F-3879F97B5CBC}" type="slidenum">
+              <a:rPr b="0" lang="en-US"/>
+              <a:t>11</a:t>
+            </a:fld>
+            <a:endParaRPr lang="en-US"/>
+          </a:p>
+        </p:txBody>
+      </p:sp>
+    </p:spTree>
+  </p:cSld>
+  <p:clrMapOvr>
+    <a:masterClrMapping/>
+  </p:clrMapOvr>
+</p:sld>
+</file>
+
+<file path=ppt/slides/slide12.xml><?xml version="1.0" encoding="utf-8"?>
+<p:sld xmlns:a="http://schemas.openxmlformats.org/drawingml/2006/main" xmlns:r="http://schemas.openxmlformats.org/officeDocument/2006/relationships" xmlns:p="http://schemas.openxmlformats.org/presentationml/2006/main">
+  <p:cSld name="Slide 12">
+    <p:spTree>
+      <p:nvGrpSpPr>
+        <p:cNvPr id="1" name=""/>
+        <p:cNvGrpSpPr/>
+        <p:nvPr/>
+      </p:nvGrpSpPr>
+      <p:grpSpPr>
+        <a:xfrm>
+          <a:off x="0" y="0"/>
+          <a:ext cx="0" cy="0"/>
+          <a:chOff x="0" y="0"/>
+          <a:chExt cx="0" cy="0"/>
+        </a:xfrm>
+      </p:grpSpPr>
+      <p:sp>
+        <p:nvSpPr>
+          <p:cNvPr id="2" name="Text 2"/>
+          <p:cNvSpPr/>
+          <p:nvPr>
+            <p:ph idx="102" type="body" hasCustomPrompt="1"/>
+          </p:nvPr>
+        </p:nvSpPr>
+        <p:spPr>
+          <a:xfrm>
+            <a:off x="548640" y="384048"/>
+            <a:ext cx="8229600" cy="219456"/>
+          </a:xfrm>
+          <a:prstGeom prst="rect">
+            <a:avLst/>
+          </a:prstGeom>
+          <a:noFill/>
+          <a:ln/>
+        </p:spPr>
+        <p:txBody>
+          <a:bodyPr wrap="square" lIns="0" tIns="0" rIns="0" bIns="0" rtlCol="0" anchor="t"/>
+          <a:lstStyle/>
+          <a:p>
+            <a:pPr indent="0" marL="0">
+              <a:buNone/>
+            </a:pPr>
+            <a:r>
+              <a:rPr lang="en-US" sz="1000" b="1" spc="100" kern="0" dirty="0">
+                <a:solidFill>
+                  <a:schemeClr val="accent2"/>
+                </a:solidFill>
+              </a:rPr>
+              <a:t>METHODOLOGY NOTE</a:t>
+            </a:r>
+            <a:endParaRPr lang="en-US" sz="1000" dirty="0"/>
+          </a:p>
+        </p:txBody>
+      </p:sp>
+      <p:sp>
+        <p:nvSpPr>
+          <p:cNvPr id="3" name="slide 6 — evidence boundary"/>
+          <p:cNvSpPr/>
+          <p:nvPr/>
+        </p:nvSpPr>
+        <p:spPr>
+          <a:xfrm>
+            <a:off x="548640" y="822960"/>
+            <a:ext cx="3587496" cy="1706880"/>
           </a:xfrm>
           <a:prstGeom prst="rect">
             <a:avLst/>
@@ -6058,14 +6258,14 @@
       </p:sp>
       <p:sp>
         <p:nvSpPr>
-          <p:cNvPr id="22" name="label"/>
+          <p:cNvPr id="4" name="label"/>
           <p:cNvSpPr txBox="1"/>
           <p:nvPr/>
         </p:nvSpPr>
         <p:spPr>
           <a:xfrm>
-            <a:off x="713232" y="4007358"/>
-            <a:ext cx="3270504" cy="201168"/>
+            <a:off x="731520" y="969264"/>
+            <a:ext cx="3221736" cy="219456"/>
           </a:xfrm>
           <a:prstGeom prst="rect">
             <a:avLst/>
@@ -6081,27 +6281,27 @@
               <a:buNone/>
             </a:pPr>
             <a:r>
-              <a:rPr lang="en-US" sz="900" b="1" spc="100" kern="0" dirty="0">
+              <a:rPr lang="en-US" sz="1000" b="1" spc="100" kern="0" dirty="0">
                 <a:solidFill>
                   <a:schemeClr val="accent2"/>
                 </a:solidFill>
               </a:rPr>
-              <a:t>SLIDE 8 — EVIDENCE BOUNDARY</a:t>
-            </a:r>
-            <a:endParaRPr lang="en-US" sz="900" dirty="0"/>
-          </a:p>
-        </p:txBody>
-      </p:sp>
-      <p:sp>
-        <p:nvSpPr>
-          <p:cNvPr id="23" name="Text 21"/>
+              <a:t>SLIDE 6 — EVIDENCE BOUNDARY</a:t>
+            </a:r>
+            <a:endParaRPr lang="en-US" sz="1000" dirty="0"/>
+          </a:p>
+        </p:txBody>
+      </p:sp>
+      <p:sp>
+        <p:nvSpPr>
+          <p:cNvPr id="5" name="Text 3"/>
           <p:cNvSpPr txBox="1"/>
           <p:nvPr/>
         </p:nvSpPr>
         <p:spPr>
           <a:xfrm>
-            <a:off x="713232" y="4263390"/>
-            <a:ext cx="3270504" cy="1309878"/>
+            <a:off x="731520" y="1243584"/>
+            <a:ext cx="3221736" cy="1213104"/>
           </a:xfrm>
           <a:prstGeom prst="rect">
             <a:avLst/>
@@ -6117,27 +6317,27 @@
               <a:buNone/>
             </a:pPr>
             <a:r>
-              <a:rPr lang="en-US" sz="900" dirty="0">
+              <a:rPr lang="en-US" sz="1000" dirty="0">
                 <a:solidFill>
                   <a:schemeClr val="tx1"/>
                 </a:solidFill>
               </a:rPr>
-              <a:t>Three qualifying U.S. offerings plus one selected Spanish example. The examples span distinct tasks; scientific research, medical education, document assistance and pharmacovigilance are not interchangeable. Optum comparisons reflect publicly marketed capabilities, not verified conversational equivalence.</a:t>
-            </a:r>
-            <a:endParaRPr lang="en-US" sz="900" dirty="0"/>
-          </a:p>
-        </p:txBody>
-      </p:sp>
-      <p:sp>
-        <p:nvSpPr>
-          <p:cNvPr id="24" name="slide 9 — evidence boundary"/>
+              <a:t>Scope: Four qualifying U.S. conversational offerings plus two selected international examples. Product descriptions are based on public marketing; study-grade reliability, data entitlements and actual deployment are not independently established.</a:t>
+            </a:r>
+            <a:endParaRPr lang="en-US" sz="1000" dirty="0"/>
+          </a:p>
+        </p:txBody>
+      </p:sp>
+      <p:sp>
+        <p:nvSpPr>
+          <p:cNvPr id="6" name="slide 7 — evidence boundary"/>
           <p:cNvSpPr/>
           <p:nvPr/>
         </p:nvSpPr>
         <p:spPr>
           <a:xfrm>
-            <a:off x="4294632" y="3879342"/>
-            <a:ext cx="3599688" cy="1767078"/>
+            <a:off x="4300728" y="822960"/>
+            <a:ext cx="3587496" cy="1706880"/>
           </a:xfrm>
           <a:prstGeom prst="rect">
             <a:avLst/>
@@ -6157,14 +6357,14 @@
       </p:sp>
       <p:sp>
         <p:nvSpPr>
-          <p:cNvPr id="25" name="label"/>
+          <p:cNvPr id="7" name="label"/>
           <p:cNvSpPr txBox="1"/>
           <p:nvPr/>
         </p:nvSpPr>
         <p:spPr>
           <a:xfrm>
-            <a:off x="4459224" y="4007358"/>
-            <a:ext cx="3270504" cy="201168"/>
+            <a:off x="4483608" y="969264"/>
+            <a:ext cx="3221736" cy="219456"/>
           </a:xfrm>
           <a:prstGeom prst="rect">
             <a:avLst/>
@@ -6180,27 +6380,27 @@
               <a:buNone/>
             </a:pPr>
             <a:r>
-              <a:rPr lang="en-US" sz="900" b="1" spc="100" kern="0" dirty="0">
+              <a:rPr lang="en-US" sz="1000" b="1" spc="100" kern="0" dirty="0">
                 <a:solidFill>
                   <a:schemeClr val="accent2"/>
                 </a:solidFill>
               </a:rPr>
-              <a:t>SLIDE 9 — EVIDENCE BOUNDARY</a:t>
-            </a:r>
-            <a:endParaRPr lang="en-US" sz="900" dirty="0"/>
-          </a:p>
-        </p:txBody>
-      </p:sp>
-      <p:sp>
-        <p:nvSpPr>
-          <p:cNvPr id="26" name="Text 24"/>
+              <a:t>SLIDE 7 — EVIDENCE BOUNDARY</a:t>
+            </a:r>
+            <a:endParaRPr lang="en-US" sz="1000" dirty="0"/>
+          </a:p>
+        </p:txBody>
+      </p:sp>
+      <p:sp>
+        <p:nvSpPr>
+          <p:cNvPr id="8" name="Text 6"/>
           <p:cNvSpPr txBox="1"/>
           <p:nvPr/>
         </p:nvSpPr>
         <p:spPr>
           <a:xfrm>
-            <a:off x="4459224" y="4263390"/>
-            <a:ext cx="3270504" cy="1309878"/>
+            <a:off x="4483608" y="1243584"/>
+            <a:ext cx="3221736" cy="1213104"/>
           </a:xfrm>
           <a:prstGeom prst="rect">
             <a:avLst/>
@@ -6216,27 +6416,27 @@
               <a:buNone/>
             </a:pPr>
             <a:r>
-              <a:rPr lang="en-US" sz="900" dirty="0">
+              <a:rPr lang="en-US" sz="1000" dirty="0">
                 <a:solidFill>
                   <a:schemeClr val="tx1"/>
                 </a:solidFill>
               </a:rPr>
-              <a:t>Clinical trials — one qualifying U.S. offering and one selected Chinese example. Market access — one qualifying U.S. offering. No additional qualifying international market-access offering was identified in the selected inventory. The Optum comparisons are based on customer-task overlap, not identical product functionality.</a:t>
-            </a:r>
-            <a:endParaRPr lang="en-US" sz="900" dirty="0"/>
-          </a:p>
-        </p:txBody>
-      </p:sp>
-      <p:sp>
-        <p:nvSpPr>
-          <p:cNvPr id="27" name="slide 10 — evidence boundary"/>
+              <a:t>Scope: All four qualifying U.S. commercial conversational offerings plus four selected international examples. Customer tasks are not interchangeable; Optum comparisons are based on public offerings, not feature-for-feature validation. International examples are illustrative, not a geographic prevalence comparison.</a:t>
+            </a:r>
+            <a:endParaRPr lang="en-US" sz="1000" dirty="0"/>
+          </a:p>
+        </p:txBody>
+      </p:sp>
+      <p:sp>
+        <p:nvSpPr>
+          <p:cNvPr id="9" name="slide 8 — evidence boundary"/>
           <p:cNvSpPr/>
           <p:nvPr/>
         </p:nvSpPr>
         <p:spPr>
           <a:xfrm>
-            <a:off x="8040624" y="3879342"/>
-            <a:ext cx="3599688" cy="1767078"/>
+            <a:off x="8052816" y="822960"/>
+            <a:ext cx="3587496" cy="1706880"/>
           </a:xfrm>
           <a:prstGeom prst="rect">
             <a:avLst/>
@@ -6256,14 +6456,14 @@
       </p:sp>
       <p:sp>
         <p:nvSpPr>
-          <p:cNvPr id="28" name="label"/>
+          <p:cNvPr id="10" name="label"/>
           <p:cNvSpPr txBox="1"/>
           <p:nvPr/>
         </p:nvSpPr>
         <p:spPr>
           <a:xfrm>
-            <a:off x="8205216" y="4007358"/>
-            <a:ext cx="3270504" cy="201168"/>
+            <a:off x="8235696" y="969264"/>
+            <a:ext cx="3221736" cy="219456"/>
           </a:xfrm>
           <a:prstGeom prst="rect">
             <a:avLst/>
@@ -6279,27 +6479,225 @@
               <a:buNone/>
             </a:pPr>
             <a:r>
-              <a:rPr lang="en-US" sz="900" b="1" spc="100" kern="0" dirty="0">
+              <a:rPr lang="en-US" sz="1000" b="1" spc="100" kern="0" dirty="0">
                 <a:solidFill>
                   <a:schemeClr val="accent2"/>
                 </a:solidFill>
               </a:rPr>
+              <a:t>SLIDE 8 — EVIDENCE BOUNDARY</a:t>
+            </a:r>
+            <a:endParaRPr lang="en-US" sz="1000" dirty="0"/>
+          </a:p>
+        </p:txBody>
+      </p:sp>
+      <p:sp>
+        <p:nvSpPr>
+          <p:cNvPr id="11" name="Text 9"/>
+          <p:cNvSpPr txBox="1"/>
+          <p:nvPr/>
+        </p:nvSpPr>
+        <p:spPr>
+          <a:xfrm>
+            <a:off x="8235696" y="1243584"/>
+            <a:ext cx="3221736" cy="1213104"/>
+          </a:xfrm>
+          <a:prstGeom prst="rect">
+            <a:avLst/>
+          </a:prstGeom>
+          <a:noFill/>
+          <a:ln/>
+        </p:spPr>
+        <p:txBody>
+          <a:bodyPr wrap="square" lIns="0" tIns="0" rIns="0" bIns="0" rtlCol="0" anchor="t"/>
+          <a:lstStyle/>
+          <a:p>
+            <a:pPr indent="0" marL="0">
+              <a:buNone/>
+            </a:pPr>
+            <a:r>
+              <a:rPr lang="en-US" sz="1000" dirty="0">
+                <a:solidFill>
+                  <a:schemeClr val="tx1"/>
+                </a:solidFill>
+              </a:rPr>
+              <a:t>Three qualifying U.S. offerings plus one selected Spanish example. The examples span distinct tasks; scientific research, medical education, document assistance and pharmacovigilance are not interchangeable. Optum comparisons reflect publicly marketed capabilities, not verified conversational equivalence.</a:t>
+            </a:r>
+            <a:endParaRPr lang="en-US" sz="1000" dirty="0"/>
+          </a:p>
+        </p:txBody>
+      </p:sp>
+      <p:sp>
+        <p:nvSpPr>
+          <p:cNvPr id="12" name="slide 9 — evidence boundary"/>
+          <p:cNvSpPr/>
+          <p:nvPr/>
+        </p:nvSpPr>
+        <p:spPr>
+          <a:xfrm>
+            <a:off x="548640" y="2694432"/>
+            <a:ext cx="3587496" cy="2326640"/>
+          </a:xfrm>
+          <a:prstGeom prst="rect">
+            <a:avLst/>
+          </a:prstGeom>
+          <a:solidFill>
+            <a:schemeClr val="bg1"/>
+          </a:solidFill>
+          <a:ln/>
+          <a:effectLst>
+            <a:outerShdw sx="100000" sy="100000" kx="0" ky="0" algn="bl" rotWithShape="0" blurRad="101600" dist="25400" dir="5400000">
+              <a:srgbClr val="000000">
+                <a:alpha val="10000"/>
+              </a:srgbClr>
+            </a:outerShdw>
+          </a:effectLst>
+        </p:spPr>
+      </p:sp>
+      <p:sp>
+        <p:nvSpPr>
+          <p:cNvPr id="13" name="label"/>
+          <p:cNvSpPr txBox="1"/>
+          <p:nvPr/>
+        </p:nvSpPr>
+        <p:spPr>
+          <a:xfrm>
+            <a:off x="731520" y="2840736"/>
+            <a:ext cx="3221736" cy="219456"/>
+          </a:xfrm>
+          <a:prstGeom prst="rect">
+            <a:avLst/>
+          </a:prstGeom>
+          <a:noFill/>
+          <a:ln/>
+        </p:spPr>
+        <p:txBody>
+          <a:bodyPr wrap="square" lIns="0" tIns="0" rIns="0" bIns="0" rtlCol="0" anchor="t"/>
+          <a:lstStyle/>
+          <a:p>
+            <a:pPr indent="0" marL="0">
+              <a:buNone/>
+            </a:pPr>
+            <a:r>
+              <a:rPr lang="en-US" sz="1000" b="1" spc="100" kern="0" dirty="0">
+                <a:solidFill>
+                  <a:schemeClr val="accent2"/>
+                </a:solidFill>
+              </a:rPr>
+              <a:t>SLIDE 9 — EVIDENCE BOUNDARY</a:t>
+            </a:r>
+            <a:endParaRPr lang="en-US" sz="1000" dirty="0"/>
+          </a:p>
+        </p:txBody>
+      </p:sp>
+      <p:sp>
+        <p:nvSpPr>
+          <p:cNvPr id="14" name="Text 12"/>
+          <p:cNvSpPr txBox="1"/>
+          <p:nvPr/>
+        </p:nvSpPr>
+        <p:spPr>
+          <a:xfrm>
+            <a:off x="731520" y="3115056"/>
+            <a:ext cx="3221736" cy="1832864"/>
+          </a:xfrm>
+          <a:prstGeom prst="rect">
+            <a:avLst/>
+          </a:prstGeom>
+          <a:noFill/>
+          <a:ln/>
+        </p:spPr>
+        <p:txBody>
+          <a:bodyPr wrap="square" lIns="0" tIns="0" rIns="0" bIns="0" rtlCol="0" anchor="t"/>
+          <a:lstStyle/>
+          <a:p>
+            <a:pPr indent="0" marL="0">
+              <a:buNone/>
+            </a:pPr>
+            <a:r>
+              <a:rPr lang="en-US" sz="1000" dirty="0">
+                <a:solidFill>
+                  <a:schemeClr val="tx1"/>
+                </a:solidFill>
+              </a:rPr>
+              <a:t>Clinical trials — one qualifying U.S. offering and one selected Chinese example. Market access — one qualifying U.S. offering. No additional qualifying international market-access offering was identified in the selected inventory. The Optum comparisons are based on customer-task overlap, not identical product functionality.</a:t>
+            </a:r>
+            <a:endParaRPr lang="en-US" sz="1000" dirty="0"/>
+          </a:p>
+        </p:txBody>
+      </p:sp>
+      <p:sp>
+        <p:nvSpPr>
+          <p:cNvPr id="15" name="slide 10 — evidence boundary"/>
+          <p:cNvSpPr/>
+          <p:nvPr/>
+        </p:nvSpPr>
+        <p:spPr>
+          <a:xfrm>
+            <a:off x="4300728" y="2694432"/>
+            <a:ext cx="3587496" cy="2326640"/>
+          </a:xfrm>
+          <a:prstGeom prst="rect">
+            <a:avLst/>
+          </a:prstGeom>
+          <a:solidFill>
+            <a:schemeClr val="bg1"/>
+          </a:solidFill>
+          <a:ln/>
+          <a:effectLst>
+            <a:outerShdw sx="100000" sy="100000" kx="0" ky="0" algn="bl" rotWithShape="0" blurRad="101600" dist="25400" dir="5400000">
+              <a:srgbClr val="000000">
+                <a:alpha val="10000"/>
+              </a:srgbClr>
+            </a:outerShdw>
+          </a:effectLst>
+        </p:spPr>
+      </p:sp>
+      <p:sp>
+        <p:nvSpPr>
+          <p:cNvPr id="16" name="label"/>
+          <p:cNvSpPr txBox="1"/>
+          <p:nvPr/>
+        </p:nvSpPr>
+        <p:spPr>
+          <a:xfrm>
+            <a:off x="4483608" y="2840736"/>
+            <a:ext cx="3221736" cy="219456"/>
+          </a:xfrm>
+          <a:prstGeom prst="rect">
+            <a:avLst/>
+          </a:prstGeom>
+          <a:noFill/>
+          <a:ln/>
+        </p:spPr>
+        <p:txBody>
+          <a:bodyPr wrap="square" lIns="0" tIns="0" rIns="0" bIns="0" rtlCol="0" anchor="t"/>
+          <a:lstStyle/>
+          <a:p>
+            <a:pPr indent="0" marL="0">
+              <a:buNone/>
+            </a:pPr>
+            <a:r>
+              <a:rPr lang="en-US" sz="1000" b="1" spc="100" kern="0" dirty="0">
+                <a:solidFill>
+                  <a:schemeClr val="accent2"/>
+                </a:solidFill>
+              </a:rPr>
               <a:t>SLIDE 10 — EVIDENCE BOUNDARY</a:t>
             </a:r>
-            <a:endParaRPr lang="en-US" sz="900" dirty="0"/>
-          </a:p>
-        </p:txBody>
-      </p:sp>
-      <p:sp>
-        <p:nvSpPr>
-          <p:cNvPr id="29" name="Text 27"/>
+            <a:endParaRPr lang="en-US" sz="1000" dirty="0"/>
+          </a:p>
+        </p:txBody>
+      </p:sp>
+      <p:sp>
+        <p:nvSpPr>
+          <p:cNvPr id="17" name="Text 15"/>
           <p:cNvSpPr txBox="1"/>
           <p:nvPr/>
         </p:nvSpPr>
         <p:spPr>
           <a:xfrm>
-            <a:off x="8205216" y="4263390"/>
-            <a:ext cx="3270504" cy="1309878"/>
+            <a:off x="4483608" y="3115056"/>
+            <a:ext cx="3221736" cy="1832864"/>
           </a:xfrm>
           <a:prstGeom prst="rect">
             <a:avLst/>
@@ -6315,20 +6713,20 @@
               <a:buNone/>
             </a:pPr>
             <a:r>
-              <a:rPr lang="en-US" sz="900" dirty="0">
+              <a:rPr lang="en-US" sz="1000" dirty="0">
                 <a:solidFill>
                   <a:schemeClr val="tx1"/>
                 </a:solidFill>
               </a:rPr>
               <a:t>These are selected publicly documented developments, not an exhaustive assessment of AI suppliers. The three approaches are neither mutually exclusive nor predictions of future competition. They do not establish that AI suppliers caused the recent RWE launch cluster, are displacing established vendors, or expose an Optum capability gap. Not all supplier offerings qualify as conversational products; they are not additions to the deck's product counts. North for Pharma was described as planned; Explore Assistant's general commercial availability was not established in our review.</a:t>
             </a:r>
-            <a:endParaRPr lang="en-US" sz="900" dirty="0"/>
-          </a:p>
-        </p:txBody>
-      </p:sp>
-      <p:sp>
-        <p:nvSpPr>
-          <p:cNvPr id="30" name="Text 2"/>
+            <a:endParaRPr lang="en-US" sz="1000" dirty="0"/>
+          </a:p>
+        </p:txBody>
+      </p:sp>
+      <p:sp>
+        <p:nvSpPr>
+          <p:cNvPr id="18" name="Text 2"/>
           <p:cNvSpPr/>
           <p:nvPr>
             <p:ph idx="103" type="title" hasCustomPrompt="1"/>
@@ -6395,7 +6793,7 @@
             <a:pPr algn="r"/>
             <a:fld id="{F7021451-1387-4CA6-816F-3879F97B5CBC}" type="slidenum">
               <a:rPr b="0" lang="en-US"/>
-              <a:t>11</a:t>
+              <a:t>12</a:t>
             </a:fld>
             <a:endParaRPr lang="en-US"/>
           </a:p>
@@ -7318,8 +7716,8 @@
         </p:nvSpPr>
         <p:spPr>
           <a:xfrm>
-            <a:off x="548640" y="3931920"/>
-            <a:ext cx="5454396" cy="1645920"/>
+            <a:off x="548640" y="4114800"/>
+            <a:ext cx="5454396" cy="1920240"/>
           </a:xfrm>
           <a:prstGeom prst="rect">
             <a:avLst/>
@@ -7345,7 +7743,7 @@
         </p:nvSpPr>
         <p:spPr>
           <a:xfrm>
-            <a:off x="749808" y="4218432"/>
+            <a:off x="749808" y="4538472"/>
             <a:ext cx="5052060" cy="256032"/>
           </a:xfrm>
           <a:prstGeom prst="rect">
@@ -7381,7 +7779,7 @@
         </p:nvSpPr>
         <p:spPr>
           <a:xfrm>
-            <a:off x="749808" y="4547616"/>
+            <a:off x="749808" y="4867656"/>
             <a:ext cx="5052060" cy="612648"/>
           </a:xfrm>
           <a:prstGeom prst="rect">
@@ -7417,8 +7815,8 @@
         </p:nvSpPr>
         <p:spPr>
           <a:xfrm>
-            <a:off x="6185916" y="3931920"/>
-            <a:ext cx="5454396" cy="1645920"/>
+            <a:off x="6185916" y="4114800"/>
+            <a:ext cx="5454396" cy="1920240"/>
           </a:xfrm>
           <a:prstGeom prst="rect">
             <a:avLst/>
@@ -7444,7 +7842,7 @@
         </p:nvSpPr>
         <p:spPr>
           <a:xfrm>
-            <a:off x="6387084" y="4218432"/>
+            <a:off x="6387084" y="4538472"/>
             <a:ext cx="5052060" cy="256032"/>
           </a:xfrm>
           <a:prstGeom prst="rect">
@@ -7480,7 +7878,7 @@
         </p:nvSpPr>
         <p:spPr>
           <a:xfrm>
-            <a:off x="6387084" y="4547616"/>
+            <a:off x="6387084" y="4867656"/>
             <a:ext cx="5052060" cy="798576"/>
           </a:xfrm>
           <a:prstGeom prst="rect">
@@ -7505,42 +7903,6 @@
               <a:t>Expand beyond RWE to assess publicly-marketed conversational AI across five Optum LS-aligned domains, prioritizing the U.S. competitive landscape and using selected international offerings for context.</a:t>
             </a:r>
             <a:endParaRPr lang="en-US" sz="1200" dirty="0"/>
-          </a:p>
-        </p:txBody>
-      </p:sp>
-      <p:sp>
-        <p:nvSpPr>
-          <p:cNvPr id="28" name="evidence boundary"/>
-          <p:cNvSpPr txBox="1"/>
-          <p:nvPr/>
-        </p:nvSpPr>
-        <p:spPr>
-          <a:xfrm>
-            <a:off x="548640" y="5705856"/>
-            <a:ext cx="11091672" cy="384048"/>
-          </a:xfrm>
-          <a:prstGeom prst="rect">
-            <a:avLst/>
-          </a:prstGeom>
-          <a:noFill/>
-          <a:ln/>
-        </p:spPr>
-        <p:txBody>
-          <a:bodyPr wrap="square" lIns="0" tIns="0" rIns="0" bIns="0" rtlCol="0" anchor="t"/>
-          <a:lstStyle/>
-          <a:p>
-            <a:pPr indent="0" marL="0">
-              <a:buNone/>
-            </a:pPr>
-            <a:r>
-              <a:rPr lang="en-US" sz="900" i="1" dirty="0">
-                <a:solidFill>
-                  <a:schemeClr val="accent4"/>
-                </a:solidFill>
-              </a:rPr>
-              <a:t>Evidence boundary: Dates reflect selected public announcements or releases, not necessarily first feature availability. The timeline illustrates a research catalyst, not measured market-wide growth. AI-enabled or agentic launches are not automatically qualifying conversational products; the Norstella example is excluded from the final conversational count.</a:t>
-            </a:r>
-            <a:endParaRPr lang="en-US" sz="900" dirty="0"/>
           </a:p>
         </p:txBody>
       </p:sp>
@@ -7699,7 +8061,7 @@
         <p:spPr>
           <a:xfrm>
             <a:off x="548640" y="1517904"/>
-            <a:ext cx="3319272" cy="548640"/>
+            <a:ext cx="5180076" cy="548640"/>
           </a:xfrm>
           <a:prstGeom prst="rect">
             <a:avLst/>
@@ -7718,8 +8080,8 @@
         </p:nvSpPr>
         <p:spPr>
           <a:xfrm>
-            <a:off x="731520" y="1517904"/>
-            <a:ext cx="548640" cy="548640"/>
+            <a:off x="2050542" y="1517904"/>
+            <a:ext cx="420624" cy="548640"/>
           </a:xfrm>
           <a:prstGeom prst="rect">
             <a:avLst/>
@@ -7731,7 +8093,7 @@
           <a:bodyPr wrap="square" lIns="0" tIns="0" rIns="0" bIns="0" rtlCol="0" anchor="ctr"/>
           <a:lstStyle/>
           <a:p>
-            <a:pPr indent="0" marL="0">
+            <a:pPr algn="r" indent="0" marL="0">
               <a:buNone/>
             </a:pPr>
             <a:r>
@@ -7754,8 +8116,8 @@
         </p:nvSpPr>
         <p:spPr>
           <a:xfrm>
-            <a:off x="1325880" y="1517904"/>
-            <a:ext cx="2432304" cy="548640"/>
+            <a:off x="2580894" y="1517904"/>
+            <a:ext cx="1645920" cy="548640"/>
           </a:xfrm>
           <a:prstGeom prst="rect">
             <a:avLst/>
@@ -7771,14 +8133,14 @@
               <a:buNone/>
             </a:pPr>
             <a:r>
-              <a:rPr lang="en-US" sz="1050" b="1" dirty="0">
+              <a:rPr lang="en-US" sz="1100" b="1" dirty="0">
                 <a:solidFill>
                   <a:schemeClr val="accent1"/>
                 </a:solidFill>
               </a:rPr>
-              <a:t>competitor groups initially screened</a:t>
-            </a:r>
-            <a:endParaRPr lang="en-US" sz="1050" dirty="0"/>
+              <a:t>competitors screened</a:t>
+            </a:r>
+            <a:endParaRPr lang="en-US" sz="1100" dirty="0"/>
           </a:p>
         </p:txBody>
       </p:sp>
@@ -7790,8 +8152,8 @@
         </p:nvSpPr>
         <p:spPr>
           <a:xfrm>
-            <a:off x="3995928" y="1673352"/>
-            <a:ext cx="310896" cy="237744"/>
+            <a:off x="5911596" y="1673352"/>
+            <a:ext cx="365760" cy="237744"/>
           </a:xfrm>
           <a:prstGeom prst="rightArrow">
             <a:avLst/>
@@ -7804,14 +8166,14 @@
       </p:sp>
       <p:sp>
         <p:nvSpPr>
-          <p:cNvPr id="8" name="kpi tile 15"/>
+          <p:cNvPr id="8" name="kpi tile 17"/>
           <p:cNvSpPr/>
           <p:nvPr/>
         </p:nvSpPr>
         <p:spPr>
           <a:xfrm>
-            <a:off x="4434840" y="1517904"/>
-            <a:ext cx="3319272" cy="548640"/>
+            <a:off x="6460236" y="1517904"/>
+            <a:ext cx="5180076" cy="548640"/>
           </a:xfrm>
           <a:prstGeom prst="rect">
             <a:avLst/>
@@ -7830,8 +8192,8 @@
         </p:nvSpPr>
         <p:spPr>
           <a:xfrm>
-            <a:off x="4617720" y="1517904"/>
-            <a:ext cx="548640" cy="548640"/>
+            <a:off x="7184898" y="1517904"/>
+            <a:ext cx="420624" cy="548640"/>
           </a:xfrm>
           <a:prstGeom prst="rect">
             <a:avLst/>
@@ -7843,16 +8205,16 @@
           <a:bodyPr wrap="square" lIns="0" tIns="0" rIns="0" bIns="0" rtlCol="0" anchor="ctr"/>
           <a:lstStyle/>
           <a:p>
-            <a:pPr indent="0" marL="0">
+            <a:pPr algn="r" indent="0" marL="0">
               <a:buNone/>
             </a:pPr>
             <a:r>
               <a:rPr lang="en-US" sz="2600" b="1" dirty="0">
                 <a:solidFill>
-                  <a:schemeClr val="accent1"/>
-                </a:solidFill>
-              </a:rPr>
-              <a:t>15</a:t>
+                  <a:schemeClr val="accent2"/>
+                </a:solidFill>
+              </a:rPr>
+              <a:t>17</a:t>
             </a:r>
             <a:endParaRPr lang="en-US" sz="2600" dirty="0"/>
           </a:p>
@@ -7866,8 +8228,8 @@
         </p:nvSpPr>
         <p:spPr>
           <a:xfrm>
-            <a:off x="5212080" y="1517904"/>
-            <a:ext cx="2432304" cy="548640"/>
+            <a:off x="7715250" y="1517904"/>
+            <a:ext cx="3200400" cy="548640"/>
           </a:xfrm>
           <a:prstGeom prst="rect">
             <a:avLst/>
@@ -7883,132 +8245,20 @@
               <a:buNone/>
             </a:pPr>
             <a:r>
-              <a:rPr lang="en-US" sz="1050" b="1" dirty="0">
+              <a:rPr lang="en-US" sz="1100" b="1" dirty="0">
                 <a:solidFill>
                   <a:schemeClr val="accent1"/>
                 </a:solidFill>
               </a:rPr>
-              <a:t>distinct groups marketing qualifying conversational AI</a:t>
-            </a:r>
-            <a:endParaRPr lang="en-US" sz="1050" dirty="0"/>
-          </a:p>
-        </p:txBody>
-      </p:sp>
-      <p:sp>
-        <p:nvSpPr>
-          <p:cNvPr id="11" name="flow arrow"/>
-          <p:cNvSpPr/>
-          <p:nvPr/>
-        </p:nvSpPr>
-        <p:spPr>
-          <a:xfrm>
-            <a:off x="7882128" y="1673352"/>
-            <a:ext cx="310896" cy="237744"/>
-          </a:xfrm>
-          <a:prstGeom prst="rightArrow">
-            <a:avLst/>
-          </a:prstGeom>
-          <a:solidFill>
-            <a:schemeClr val="accent4"/>
-          </a:solidFill>
-          <a:ln/>
-        </p:spPr>
-      </p:sp>
-      <p:sp>
-        <p:nvSpPr>
-          <p:cNvPr id="12" name="kpi tile 19"/>
-          <p:cNvSpPr/>
-          <p:nvPr/>
-        </p:nvSpPr>
-        <p:spPr>
-          <a:xfrm>
-            <a:off x="8321040" y="1517904"/>
-            <a:ext cx="3319272" cy="548640"/>
-          </a:xfrm>
-          <a:prstGeom prst="rect">
-            <a:avLst/>
-          </a:prstGeom>
-          <a:solidFill>
-            <a:schemeClr val="accent5"/>
-          </a:solidFill>
-          <a:ln/>
-        </p:spPr>
-      </p:sp>
-      <p:sp>
-        <p:nvSpPr>
-          <p:cNvPr id="13" name="Text 11"/>
-          <p:cNvSpPr txBox="1"/>
-          <p:nvPr/>
-        </p:nvSpPr>
-        <p:spPr>
-          <a:xfrm>
-            <a:off x="8503920" y="1517904"/>
-            <a:ext cx="548640" cy="548640"/>
-          </a:xfrm>
-          <a:prstGeom prst="rect">
-            <a:avLst/>
-          </a:prstGeom>
-          <a:noFill/>
-          <a:ln/>
-        </p:spPr>
-        <p:txBody>
-          <a:bodyPr wrap="square" lIns="0" tIns="0" rIns="0" bIns="0" rtlCol="0" anchor="ctr"/>
-          <a:lstStyle/>
-          <a:p>
-            <a:pPr indent="0" marL="0">
-              <a:buNone/>
-            </a:pPr>
-            <a:r>
-              <a:rPr lang="en-US" sz="2600" b="1" dirty="0">
-                <a:solidFill>
-                  <a:schemeClr val="accent2"/>
-                </a:solidFill>
-              </a:rPr>
-              <a:t>19</a:t>
-            </a:r>
-            <a:endParaRPr lang="en-US" sz="2600" dirty="0"/>
-          </a:p>
-        </p:txBody>
-      </p:sp>
-      <p:sp>
-        <p:nvSpPr>
-          <p:cNvPr id="14" name="Text 12"/>
-          <p:cNvSpPr txBox="1"/>
-          <p:nvPr/>
-        </p:nvSpPr>
-        <p:spPr>
-          <a:xfrm>
-            <a:off x="9098280" y="1517904"/>
-            <a:ext cx="2432304" cy="548640"/>
-          </a:xfrm>
-          <a:prstGeom prst="rect">
-            <a:avLst/>
-          </a:prstGeom>
-          <a:noFill/>
-          <a:ln/>
-        </p:spPr>
-        <p:txBody>
-          <a:bodyPr wrap="square" lIns="0" tIns="0" rIns="0" bIns="0" rtlCol="0" anchor="ctr"/>
-          <a:lstStyle/>
-          <a:p>
-            <a:pPr indent="0" marL="0">
-              <a:buNone/>
-            </a:pPr>
-            <a:r>
-              <a:rPr lang="en-US" sz="1050" b="1" dirty="0">
-                <a:solidFill>
-                  <a:schemeClr val="accent1"/>
-                </a:solidFill>
-              </a:rPr>
-              <a:t>qualifying conversational AI offerings across five decision workflows</a:t>
-            </a:r>
-            <a:endParaRPr lang="en-US" sz="1050" dirty="0"/>
-          </a:p>
-        </p:txBody>
-      </p:sp>
-      <p:sp>
-        <p:nvSpPr>
-          <p:cNvPr id="15" name="label"/>
+              <a:t>competitors who market conversational AI</a:t>
+            </a:r>
+            <a:endParaRPr lang="en-US" sz="1100" dirty="0"/>
+          </a:p>
+        </p:txBody>
+      </p:sp>
+      <p:sp>
+        <p:nvSpPr>
+          <p:cNvPr id="11" name="label"/>
           <p:cNvSpPr txBox="1"/>
           <p:nvPr/>
         </p:nvSpPr>
@@ -8044,7 +8294,7 @@
       </p:sp>
       <p:sp>
         <p:nvSpPr>
-          <p:cNvPr id="16" name="table header"/>
+          <p:cNvPr id="12" name="table header"/>
           <p:cNvSpPr/>
           <p:nvPr/>
         </p:nvSpPr>
@@ -8064,184 +8314,184 @@
       </p:sp>
       <p:sp>
         <p:nvSpPr>
+          <p:cNvPr id="13" name="Text 11"/>
+          <p:cNvSpPr txBox="1"/>
+          <p:nvPr/>
+        </p:nvSpPr>
+        <p:spPr>
+          <a:xfrm>
+            <a:off x="960120" y="2468880"/>
+            <a:ext cx="2423160" cy="457200"/>
+          </a:xfrm>
+          <a:prstGeom prst="rect">
+            <a:avLst/>
+          </a:prstGeom>
+          <a:noFill/>
+          <a:ln/>
+        </p:spPr>
+        <p:txBody>
+          <a:bodyPr wrap="square" lIns="0" tIns="0" rIns="0" bIns="0" rtlCol="0" anchor="ctr"/>
+          <a:lstStyle/>
+          <a:p>
+            <a:pPr algn="ctr" indent="0" marL="0">
+              <a:buNone/>
+            </a:pPr>
+            <a:r>
+              <a:rPr lang="en-US" sz="900" b="1" dirty="0">
+                <a:solidFill>
+                  <a:schemeClr val="bg1"/>
+                </a:solidFill>
+              </a:rPr>
+              <a:t>Competitors marketing conversational AI /</a:t>
+            </a:r>
+            <a:endParaRPr lang="en-US" sz="900" dirty="0"/>
+          </a:p>
+          <a:p>
+            <a:pPr algn="ctr" indent="0" marL="0">
+              <a:buNone/>
+            </a:pPr>
+            <a:r>
+              <a:rPr lang="en-US" sz="900" b="1" dirty="0">
+                <a:solidFill>
+                  <a:schemeClr val="bg1"/>
+                </a:solidFill>
+              </a:rPr>
+              <a:t>Total comparable competitors</a:t>
+            </a:r>
+            <a:endParaRPr lang="en-US" sz="900" dirty="0"/>
+          </a:p>
+        </p:txBody>
+      </p:sp>
+      <p:sp>
+        <p:nvSpPr>
+          <p:cNvPr id="14" name="Text 12"/>
+          <p:cNvSpPr txBox="1"/>
+          <p:nvPr/>
+        </p:nvSpPr>
+        <p:spPr>
+          <a:xfrm>
+            <a:off x="3474720" y="2468880"/>
+            <a:ext cx="1965960" cy="457200"/>
+          </a:xfrm>
+          <a:prstGeom prst="rect">
+            <a:avLst/>
+          </a:prstGeom>
+          <a:noFill/>
+          <a:ln/>
+        </p:spPr>
+        <p:txBody>
+          <a:bodyPr wrap="square" lIns="0" tIns="0" rIns="0" bIns="0" rtlCol="0" anchor="ctr"/>
+          <a:lstStyle/>
+          <a:p>
+            <a:pPr algn="ctr" indent="0" marL="0">
+              <a:buNone/>
+            </a:pPr>
+            <a:r>
+              <a:rPr lang="en-US" sz="900" b="1" dirty="0">
+                <a:solidFill>
+                  <a:schemeClr val="bg1"/>
+                </a:solidFill>
+              </a:rPr>
+              <a:t>Domain</a:t>
+            </a:r>
+            <a:endParaRPr lang="en-US" sz="900" dirty="0"/>
+          </a:p>
+        </p:txBody>
+      </p:sp>
+      <p:sp>
+        <p:nvSpPr>
+          <p:cNvPr id="15" name="Text 13"/>
+          <p:cNvSpPr txBox="1"/>
+          <p:nvPr/>
+        </p:nvSpPr>
+        <p:spPr>
+          <a:xfrm>
+            <a:off x="5486400" y="2468880"/>
+            <a:ext cx="2880360" cy="457200"/>
+          </a:xfrm>
+          <a:prstGeom prst="rect">
+            <a:avLst/>
+          </a:prstGeom>
+          <a:noFill/>
+          <a:ln/>
+        </p:spPr>
+        <p:txBody>
+          <a:bodyPr wrap="square" lIns="0" tIns="0" rIns="0" bIns="0" rtlCol="0" anchor="ctr"/>
+          <a:lstStyle/>
+          <a:p>
+            <a:pPr algn="ctr" indent="0" marL="0">
+              <a:buNone/>
+            </a:pPr>
+            <a:r>
+              <a:rPr lang="en-US" sz="900" b="1" dirty="0">
+                <a:solidFill>
+                  <a:schemeClr val="bg1"/>
+                </a:solidFill>
+              </a:rPr>
+              <a:t>Conversational AI offerings</a:t>
+            </a:r>
+            <a:endParaRPr lang="en-US" sz="900" dirty="0"/>
+          </a:p>
+        </p:txBody>
+      </p:sp>
+      <p:sp>
+        <p:nvSpPr>
+          <p:cNvPr id="16" name="Text 14"/>
+          <p:cNvSpPr txBox="1"/>
+          <p:nvPr/>
+        </p:nvSpPr>
+        <p:spPr>
+          <a:xfrm>
+            <a:off x="8503920" y="2468880"/>
+            <a:ext cx="2103120" cy="457200"/>
+          </a:xfrm>
+          <a:prstGeom prst="rect">
+            <a:avLst/>
+          </a:prstGeom>
+          <a:noFill/>
+          <a:ln/>
+        </p:spPr>
+        <p:txBody>
+          <a:bodyPr wrap="square" lIns="0" tIns="0" rIns="0" bIns="0" rtlCol="0" anchor="ctr"/>
+          <a:lstStyle/>
+          <a:p>
+            <a:pPr algn="ctr" indent="0" marL="0">
+              <a:buNone/>
+            </a:pPr>
+            <a:r>
+              <a:rPr lang="en-US" sz="900" b="1" dirty="0">
+                <a:solidFill>
+                  <a:schemeClr val="bg1"/>
+                </a:solidFill>
+              </a:rPr>
+              <a:t>Relevant Optum LS</a:t>
+            </a:r>
+            <a:endParaRPr lang="en-US" sz="900" dirty="0"/>
+          </a:p>
+          <a:p>
+            <a:pPr algn="ctr" indent="0" marL="0">
+              <a:buNone/>
+            </a:pPr>
+            <a:r>
+              <a:rPr lang="en-US" sz="900" b="1" dirty="0">
+                <a:solidFill>
+                  <a:schemeClr val="bg1"/>
+                </a:solidFill>
+              </a:rPr>
+              <a:t>offerings</a:t>
+            </a:r>
+            <a:endParaRPr lang="en-US" sz="900" dirty="0"/>
+          </a:p>
+        </p:txBody>
+      </p:sp>
+      <p:sp>
+        <p:nvSpPr>
           <p:cNvPr id="17" name="Text 15"/>
           <p:cNvSpPr txBox="1"/>
           <p:nvPr/>
         </p:nvSpPr>
         <p:spPr>
           <a:xfrm>
-            <a:off x="960120" y="2468880"/>
-            <a:ext cx="2423160" cy="457200"/>
-          </a:xfrm>
-          <a:prstGeom prst="rect">
-            <a:avLst/>
-          </a:prstGeom>
-          <a:noFill/>
-          <a:ln/>
-        </p:spPr>
-        <p:txBody>
-          <a:bodyPr wrap="square" lIns="0" tIns="0" rIns="0" bIns="0" rtlCol="0" anchor="ctr"/>
-          <a:lstStyle/>
-          <a:p>
-            <a:pPr algn="ctr" indent="0" marL="0">
-              <a:buNone/>
-            </a:pPr>
-            <a:r>
-              <a:rPr lang="en-US" sz="900" b="1" dirty="0">
-                <a:solidFill>
-                  <a:schemeClr val="bg1"/>
-                </a:solidFill>
-              </a:rPr>
-              <a:t>Competitors marketing conversational AI /</a:t>
-            </a:r>
-            <a:endParaRPr lang="en-US" sz="900" dirty="0"/>
-          </a:p>
-          <a:p>
-            <a:pPr algn="ctr" indent="0" marL="0">
-              <a:buNone/>
-            </a:pPr>
-            <a:r>
-              <a:rPr lang="en-US" sz="900" b="1" dirty="0">
-                <a:solidFill>
-                  <a:schemeClr val="bg1"/>
-                </a:solidFill>
-              </a:rPr>
-              <a:t>Total comparable competitors</a:t>
-            </a:r>
-            <a:endParaRPr lang="en-US" sz="900" dirty="0"/>
-          </a:p>
-        </p:txBody>
-      </p:sp>
-      <p:sp>
-        <p:nvSpPr>
-          <p:cNvPr id="18" name="Text 16"/>
-          <p:cNvSpPr txBox="1"/>
-          <p:nvPr/>
-        </p:nvSpPr>
-        <p:spPr>
-          <a:xfrm>
-            <a:off x="3474720" y="2468880"/>
-            <a:ext cx="1965960" cy="457200"/>
-          </a:xfrm>
-          <a:prstGeom prst="rect">
-            <a:avLst/>
-          </a:prstGeom>
-          <a:noFill/>
-          <a:ln/>
-        </p:spPr>
-        <p:txBody>
-          <a:bodyPr wrap="square" lIns="0" tIns="0" rIns="0" bIns="0" rtlCol="0" anchor="ctr"/>
-          <a:lstStyle/>
-          <a:p>
-            <a:pPr algn="ctr" indent="0" marL="0">
-              <a:buNone/>
-            </a:pPr>
-            <a:r>
-              <a:rPr lang="en-US" sz="900" b="1" dirty="0">
-                <a:solidFill>
-                  <a:schemeClr val="bg1"/>
-                </a:solidFill>
-              </a:rPr>
-              <a:t>Domain</a:t>
-            </a:r>
-            <a:endParaRPr lang="en-US" sz="900" dirty="0"/>
-          </a:p>
-        </p:txBody>
-      </p:sp>
-      <p:sp>
-        <p:nvSpPr>
-          <p:cNvPr id="19" name="Text 17"/>
-          <p:cNvSpPr txBox="1"/>
-          <p:nvPr/>
-        </p:nvSpPr>
-        <p:spPr>
-          <a:xfrm>
-            <a:off x="5486400" y="2468880"/>
-            <a:ext cx="2880360" cy="457200"/>
-          </a:xfrm>
-          <a:prstGeom prst="rect">
-            <a:avLst/>
-          </a:prstGeom>
-          <a:noFill/>
-          <a:ln/>
-        </p:spPr>
-        <p:txBody>
-          <a:bodyPr wrap="square" lIns="0" tIns="0" rIns="0" bIns="0" rtlCol="0" anchor="ctr"/>
-          <a:lstStyle/>
-          <a:p>
-            <a:pPr algn="ctr" indent="0" marL="0">
-              <a:buNone/>
-            </a:pPr>
-            <a:r>
-              <a:rPr lang="en-US" sz="900" b="1" dirty="0">
-                <a:solidFill>
-                  <a:schemeClr val="bg1"/>
-                </a:solidFill>
-              </a:rPr>
-              <a:t>Conversational AI offerings</a:t>
-            </a:r>
-            <a:endParaRPr lang="en-US" sz="900" dirty="0"/>
-          </a:p>
-        </p:txBody>
-      </p:sp>
-      <p:sp>
-        <p:nvSpPr>
-          <p:cNvPr id="20" name="Text 18"/>
-          <p:cNvSpPr txBox="1"/>
-          <p:nvPr/>
-        </p:nvSpPr>
-        <p:spPr>
-          <a:xfrm>
-            <a:off x="8503920" y="2468880"/>
-            <a:ext cx="2103120" cy="457200"/>
-          </a:xfrm>
-          <a:prstGeom prst="rect">
-            <a:avLst/>
-          </a:prstGeom>
-          <a:noFill/>
-          <a:ln/>
-        </p:spPr>
-        <p:txBody>
-          <a:bodyPr wrap="square" lIns="0" tIns="0" rIns="0" bIns="0" rtlCol="0" anchor="ctr"/>
-          <a:lstStyle/>
-          <a:p>
-            <a:pPr algn="ctr" indent="0" marL="0">
-              <a:buNone/>
-            </a:pPr>
-            <a:r>
-              <a:rPr lang="en-US" sz="900" b="1" dirty="0">
-                <a:solidFill>
-                  <a:schemeClr val="bg1"/>
-                </a:solidFill>
-              </a:rPr>
-              <a:t>Relevant Optum LS</a:t>
-            </a:r>
-            <a:endParaRPr lang="en-US" sz="900" dirty="0"/>
-          </a:p>
-          <a:p>
-            <a:pPr algn="ctr" indent="0" marL="0">
-              <a:buNone/>
-            </a:pPr>
-            <a:r>
-              <a:rPr lang="en-US" sz="900" b="1" dirty="0">
-                <a:solidFill>
-                  <a:schemeClr val="bg1"/>
-                </a:solidFill>
-              </a:rPr>
-              <a:t>offerings</a:t>
-            </a:r>
-            <a:endParaRPr lang="en-US" sz="900" dirty="0"/>
-          </a:p>
-        </p:txBody>
-      </p:sp>
-      <p:sp>
-        <p:nvSpPr>
-          <p:cNvPr id="21" name="Text 19"/>
-          <p:cNvSpPr txBox="1"/>
-          <p:nvPr/>
-        </p:nvSpPr>
-        <p:spPr>
-          <a:xfrm>
             <a:off x="10652760" y="2468880"/>
             <a:ext cx="987552" cy="457200"/>
           </a:xfrm>
@@ -8286,7 +8536,7 @@
       </p:sp>
       <p:graphicFrame>
         <p:nvGraphicFramePr>
-          <p:cNvPr id="22" name="competitor coverage chart" descr=""/>
+          <p:cNvPr id="18" name="competitor coverage chart" descr=""/>
           <p:cNvGraphicFramePr/>
           <p:nvPr/>
         </p:nvGraphicFramePr>
@@ -8302,7 +8552,7 @@
       </p:graphicFrame>
       <p:sp>
         <p:nvSpPr>
-          <p:cNvPr id="23" name="fraction RWE"/>
+          <p:cNvPr id="19" name="fraction RWE"/>
           <p:cNvSpPr txBox="1"/>
           <p:nvPr/>
         </p:nvSpPr>
@@ -8327,7 +8577,7 @@
             <a:r>
               <a:rPr lang="en-US" sz="1000" b="1" dirty="0">
                 <a:solidFill>
-                  <a:schemeClr val="accent1"/>
+                  <a:schemeClr val="accent2"/>
                 </a:solidFill>
               </a:rPr>
               <a:t>9</a:t>
@@ -8349,7 +8599,7 @@
       </p:sp>
       <p:sp>
         <p:nvSpPr>
-          <p:cNvPr id="24" name="workflow chip RWE"/>
+          <p:cNvPr id="20" name="workflow chip RWE"/>
           <p:cNvSpPr/>
           <p:nvPr/>
         </p:nvSpPr>
@@ -8376,7 +8626,7 @@
       </p:sp>
       <p:sp>
         <p:nvSpPr>
-          <p:cNvPr id="25" name="Text 22"/>
+          <p:cNvPr id="21" name="Text 18"/>
           <p:cNvSpPr txBox="1"/>
           <p:nvPr/>
         </p:nvSpPr>
@@ -8412,7 +8662,7 @@
       </p:sp>
       <p:sp>
         <p:nvSpPr>
-          <p:cNvPr id="26" name="Text 23"/>
+          <p:cNvPr id="22" name="Text 19"/>
           <p:cNvSpPr txBox="1"/>
           <p:nvPr/>
         </p:nvSpPr>
@@ -8440,7 +8690,7 @@
                   <a:schemeClr val="tx1"/>
                 </a:solidFill>
               </a:rPr>
-              <a:t>Komodo Marmot and MapAI; Truveta Intelligence; Flatiron Telescope; Tempus Lens</a:t>
+              <a:t>Komodo Marmot and MapAI; Truveta Intelligence; Flatiron Telescope; Tempus Lens; and more</a:t>
             </a:r>
             <a:endParaRPr lang="en-US" sz="900" dirty="0"/>
           </a:p>
@@ -8448,7 +8698,7 @@
       </p:sp>
       <p:sp>
         <p:nvSpPr>
-          <p:cNvPr id="27" name="Text 24"/>
+          <p:cNvPr id="23" name="Text 20"/>
           <p:cNvSpPr txBox="1"/>
           <p:nvPr/>
         </p:nvSpPr>
@@ -8484,7 +8734,7 @@
       </p:sp>
       <p:sp>
         <p:nvSpPr>
-          <p:cNvPr id="28" name="chat status RWE"/>
+          <p:cNvPr id="24" name="chat status RWE"/>
           <p:cNvSpPr/>
           <p:nvPr/>
         </p:nvSpPr>
@@ -8506,7 +8756,7 @@
       </p:sp>
       <p:sp>
         <p:nvSpPr>
-          <p:cNvPr id="29" name="Shape 26"/>
+          <p:cNvPr id="25" name="Shape 22"/>
           <p:cNvSpPr/>
           <p:nvPr/>
         </p:nvSpPr>
@@ -8529,7 +8779,7 @@
       </p:sp>
       <p:sp>
         <p:nvSpPr>
-          <p:cNvPr id="30" name="fraction Commercial Intelligence"/>
+          <p:cNvPr id="26" name="fraction Commercial Intelligence"/>
           <p:cNvSpPr txBox="1"/>
           <p:nvPr/>
         </p:nvSpPr>
@@ -8554,7 +8804,7 @@
             <a:r>
               <a:rPr lang="en-US" sz="1000" b="1" dirty="0">
                 <a:solidFill>
-                  <a:schemeClr val="accent1"/>
+                  <a:schemeClr val="accent2"/>
                 </a:solidFill>
               </a:rPr>
               <a:t>3</a:t>
@@ -8576,7 +8826,7 @@
       </p:sp>
       <p:sp>
         <p:nvSpPr>
-          <p:cNvPr id="31" name="workflow chip Commercial Intelligence"/>
+          <p:cNvPr id="27" name="workflow chip Commercial Intelligence"/>
           <p:cNvSpPr/>
           <p:nvPr/>
         </p:nvSpPr>
@@ -8603,7 +8853,7 @@
       </p:sp>
       <p:sp>
         <p:nvSpPr>
-          <p:cNvPr id="32" name="Text 29"/>
+          <p:cNvPr id="28" name="Text 25"/>
           <p:cNvSpPr txBox="1"/>
           <p:nvPr/>
         </p:nvSpPr>
@@ -8639,7 +8889,7 @@
       </p:sp>
       <p:sp>
         <p:nvSpPr>
-          <p:cNvPr id="33" name="Text 30"/>
+          <p:cNvPr id="29" name="Text 26"/>
           <p:cNvSpPr txBox="1"/>
           <p:nvPr/>
         </p:nvSpPr>
@@ -8675,7 +8925,7 @@
       </p:sp>
       <p:sp>
         <p:nvSpPr>
-          <p:cNvPr id="34" name="Text 31"/>
+          <p:cNvPr id="30" name="Text 27"/>
           <p:cNvSpPr txBox="1"/>
           <p:nvPr/>
         </p:nvSpPr>
@@ -8711,7 +8961,7 @@
       </p:sp>
       <p:sp>
         <p:nvSpPr>
-          <p:cNvPr id="35" name="chat status Commercial Intelligence"/>
+          <p:cNvPr id="31" name="chat status Commercial Intelligence"/>
           <p:cNvSpPr/>
           <p:nvPr/>
         </p:nvSpPr>
@@ -8733,7 +8983,7 @@
       </p:sp>
       <p:sp>
         <p:nvSpPr>
-          <p:cNvPr id="36" name="Shape 33"/>
+          <p:cNvPr id="32" name="Shape 29"/>
           <p:cNvSpPr/>
           <p:nvPr/>
         </p:nvSpPr>
@@ -8756,7 +9006,7 @@
       </p:sp>
       <p:sp>
         <p:nvSpPr>
-          <p:cNvPr id="37" name="fraction Medical / Regulatory Research"/>
+          <p:cNvPr id="33" name="fraction Medical / Regulatory Research"/>
           <p:cNvSpPr txBox="1"/>
           <p:nvPr/>
         </p:nvSpPr>
@@ -8781,7 +9031,7 @@
             <a:r>
               <a:rPr lang="en-US" sz="1000" b="1" dirty="0">
                 <a:solidFill>
-                  <a:schemeClr val="accent1"/>
+                  <a:schemeClr val="accent2"/>
                 </a:solidFill>
               </a:rPr>
               <a:t>3</a:t>
@@ -8803,7 +9053,7 @@
       </p:sp>
       <p:sp>
         <p:nvSpPr>
-          <p:cNvPr id="38" name="workflow chip Medical / Regulatory Research"/>
+          <p:cNvPr id="34" name="workflow chip Medical / Regulatory Research"/>
           <p:cNvSpPr/>
           <p:nvPr/>
         </p:nvSpPr>
@@ -8830,7 +9080,7 @@
       </p:sp>
       <p:sp>
         <p:nvSpPr>
-          <p:cNvPr id="39" name="Text 36"/>
+          <p:cNvPr id="35" name="Text 32"/>
           <p:cNvSpPr txBox="1"/>
           <p:nvPr/>
         </p:nvSpPr>
@@ -8866,7 +9116,7 @@
       </p:sp>
       <p:sp>
         <p:nvSpPr>
-          <p:cNvPr id="40" name="Text 37"/>
+          <p:cNvPr id="36" name="Text 33"/>
           <p:cNvSpPr txBox="1"/>
           <p:nvPr/>
         </p:nvSpPr>
@@ -8902,7 +9152,7 @@
       </p:sp>
       <p:sp>
         <p:nvSpPr>
-          <p:cNvPr id="41" name="Text 38"/>
+          <p:cNvPr id="37" name="Text 34"/>
           <p:cNvSpPr txBox="1"/>
           <p:nvPr/>
         </p:nvSpPr>
@@ -8938,7 +9188,7 @@
       </p:sp>
       <p:sp>
         <p:nvSpPr>
-          <p:cNvPr id="42" name="chat status Medical / Regulatory Research"/>
+          <p:cNvPr id="38" name="chat status Medical / Regulatory Research"/>
           <p:cNvSpPr/>
           <p:nvPr/>
         </p:nvSpPr>
@@ -8960,7 +9210,7 @@
       </p:sp>
       <p:sp>
         <p:nvSpPr>
-          <p:cNvPr id="43" name="Shape 40"/>
+          <p:cNvPr id="39" name="Shape 36"/>
           <p:cNvSpPr/>
           <p:nvPr/>
         </p:nvSpPr>
@@ -8983,7 +9233,7 @@
       </p:sp>
       <p:sp>
         <p:nvSpPr>
-          <p:cNvPr id="44" name="fraction Clinical Trials"/>
+          <p:cNvPr id="40" name="fraction Clinical Trials"/>
           <p:cNvSpPr txBox="1"/>
           <p:nvPr/>
         </p:nvSpPr>
@@ -9008,7 +9258,7 @@
             <a:r>
               <a:rPr lang="en-US" sz="1000" b="1" dirty="0">
                 <a:solidFill>
-                  <a:schemeClr val="accent1"/>
+                  <a:schemeClr val="accent2"/>
                 </a:solidFill>
               </a:rPr>
               <a:t>1</a:t>
@@ -9030,7 +9280,7 @@
       </p:sp>
       <p:sp>
         <p:nvSpPr>
-          <p:cNvPr id="45" name="workflow chip Clinical Trials"/>
+          <p:cNvPr id="41" name="workflow chip Clinical Trials"/>
           <p:cNvSpPr/>
           <p:nvPr/>
         </p:nvSpPr>
@@ -9057,7 +9307,7 @@
       </p:sp>
       <p:sp>
         <p:nvSpPr>
-          <p:cNvPr id="46" name="Text 43"/>
+          <p:cNvPr id="42" name="Text 39"/>
           <p:cNvSpPr txBox="1"/>
           <p:nvPr/>
         </p:nvSpPr>
@@ -9093,7 +9343,7 @@
       </p:sp>
       <p:sp>
         <p:nvSpPr>
-          <p:cNvPr id="47" name="Text 44"/>
+          <p:cNvPr id="43" name="Text 40"/>
           <p:cNvSpPr txBox="1"/>
           <p:nvPr/>
         </p:nvSpPr>
@@ -9129,7 +9379,7 @@
       </p:sp>
       <p:sp>
         <p:nvSpPr>
-          <p:cNvPr id="48" name="Text 45"/>
+          <p:cNvPr id="44" name="Text 41"/>
           <p:cNvSpPr txBox="1"/>
           <p:nvPr/>
         </p:nvSpPr>
@@ -9165,7 +9415,7 @@
       </p:sp>
       <p:sp>
         <p:nvSpPr>
-          <p:cNvPr id="49" name="chat status Clinical Trials"/>
+          <p:cNvPr id="45" name="chat status Clinical Trials"/>
           <p:cNvSpPr/>
           <p:nvPr/>
         </p:nvSpPr>
@@ -9187,7 +9437,7 @@
       </p:sp>
       <p:sp>
         <p:nvSpPr>
-          <p:cNvPr id="50" name="Shape 47"/>
+          <p:cNvPr id="46" name="Shape 43"/>
           <p:cNvSpPr/>
           <p:nvPr/>
         </p:nvSpPr>
@@ -9210,7 +9460,7 @@
       </p:sp>
       <p:sp>
         <p:nvSpPr>
-          <p:cNvPr id="51" name="fraction Market Access"/>
+          <p:cNvPr id="47" name="fraction Market Access"/>
           <p:cNvSpPr txBox="1"/>
           <p:nvPr/>
         </p:nvSpPr>
@@ -9235,7 +9485,7 @@
             <a:r>
               <a:rPr lang="en-US" sz="1000" b="1" dirty="0">
                 <a:solidFill>
-                  <a:schemeClr val="accent1"/>
+                  <a:schemeClr val="accent2"/>
                 </a:solidFill>
               </a:rPr>
               <a:t>1</a:t>
@@ -9257,7 +9507,7 @@
       </p:sp>
       <p:sp>
         <p:nvSpPr>
-          <p:cNvPr id="52" name="workflow chip Market Access"/>
+          <p:cNvPr id="48" name="workflow chip Market Access"/>
           <p:cNvSpPr/>
           <p:nvPr/>
         </p:nvSpPr>
@@ -9284,7 +9534,7 @@
       </p:sp>
       <p:sp>
         <p:nvSpPr>
-          <p:cNvPr id="53" name="Text 50"/>
+          <p:cNvPr id="49" name="Text 46"/>
           <p:cNvSpPr txBox="1"/>
           <p:nvPr/>
         </p:nvSpPr>
@@ -9320,7 +9570,7 @@
       </p:sp>
       <p:sp>
         <p:nvSpPr>
-          <p:cNvPr id="54" name="Text 51"/>
+          <p:cNvPr id="50" name="Text 47"/>
           <p:cNvSpPr txBox="1"/>
           <p:nvPr/>
         </p:nvSpPr>
@@ -9356,7 +9606,7 @@
       </p:sp>
       <p:sp>
         <p:nvSpPr>
-          <p:cNvPr id="55" name="Text 52"/>
+          <p:cNvPr id="51" name="Text 48"/>
           <p:cNvSpPr txBox="1"/>
           <p:nvPr/>
         </p:nvSpPr>
@@ -9392,7 +9642,7 @@
       </p:sp>
       <p:sp>
         <p:nvSpPr>
-          <p:cNvPr id="56" name="chat status Market Access"/>
+          <p:cNvPr id="52" name="chat status Market Access"/>
           <p:cNvSpPr/>
           <p:nvPr/>
         </p:nvSpPr>
@@ -9414,7 +9664,7 @@
       </p:sp>
       <p:sp>
         <p:nvSpPr>
-          <p:cNvPr id="57" name="Shape 54"/>
+          <p:cNvPr id="53" name="Shape 50"/>
           <p:cNvSpPr/>
           <p:nvPr/>
         </p:nvSpPr>
@@ -9437,7 +9687,7 @@
       </p:sp>
       <p:sp>
         <p:nvSpPr>
-          <p:cNvPr id="58" name="scope note"/>
+          <p:cNvPr id="54" name="scope note"/>
           <p:cNvSpPr txBox="1"/>
           <p:nvPr/>
         </p:nvSpPr>
@@ -9473,7 +9723,7 @@
       </p:sp>
       <p:sp>
         <p:nvSpPr>
-          <p:cNvPr id="59" name="chat claim legend"/>
+          <p:cNvPr id="55" name="chat claim legend"/>
           <p:cNvSpPr txBox="1"/>
           <p:nvPr/>
         </p:nvSpPr>
@@ -9509,7 +9759,7 @@
       </p:sp>
       <p:sp>
         <p:nvSpPr>
-          <p:cNvPr id="60" name="key takeaway card"/>
+          <p:cNvPr id="56" name="key takeaway card"/>
           <p:cNvSpPr/>
           <p:nvPr/>
         </p:nvSpPr>
@@ -9536,7 +9786,7 @@
       </p:sp>
       <p:sp>
         <p:nvSpPr>
-          <p:cNvPr id="61" name="label"/>
+          <p:cNvPr id="57" name="label"/>
           <p:cNvSpPr txBox="1"/>
           <p:nvPr/>
         </p:nvSpPr>
@@ -9572,14 +9822,14 @@
       </p:sp>
       <p:sp>
         <p:nvSpPr>
-          <p:cNvPr id="62" name="Text 59"/>
+          <p:cNvPr id="58" name="Text 55"/>
           <p:cNvSpPr txBox="1"/>
           <p:nvPr/>
         </p:nvSpPr>
         <p:spPr>
           <a:xfrm>
-            <a:off x="2331720" y="5596128"/>
-            <a:ext cx="9125712" cy="548640"/>
+            <a:off x="2926080" y="5596128"/>
+            <a:ext cx="8531352" cy="548640"/>
           </a:xfrm>
           <a:prstGeom prst="rect">
             <a:avLst/>
@@ -9600,7 +9850,21 @@
                   <a:schemeClr val="tx1"/>
                 </a:solidFill>
               </a:rPr>
-              <a:t>A publicly-marketed customer-facing conversational interface was not established in the reviewed materials for Optum LS across the five relevant business domains.</a:t>
+              <a:t>A publicly-marketed customer-facing conversational interface was not established in the reviewed materials for Optum LS</a:t>
+            </a:r>
+            <a:endParaRPr lang="en-US" sz="1050" dirty="0"/>
+          </a:p>
+          <a:p>
+            <a:pPr indent="0" marL="0">
+              <a:buNone/>
+            </a:pPr>
+            <a:r>
+              <a:rPr lang="en-US" sz="1050" b="1" dirty="0">
+                <a:solidFill>
+                  <a:schemeClr val="tx1"/>
+                </a:solidFill>
+              </a:rPr>
+              <a:t>across the five relevant business domains.</a:t>
             </a:r>
             <a:endParaRPr lang="en-US" sz="1050" dirty="0"/>
           </a:p>
@@ -9838,6 +10102,20 @@
                   <a:schemeClr val="bg1"/>
                 </a:solidFill>
               </a:rPr>
+              <a:t>International</a:t>
+            </a:r>
+            <a:endParaRPr lang="en-US" sz="900" dirty="0"/>
+          </a:p>
+          <a:p>
+            <a:pPr algn="ctr" indent="0" marL="0">
+              <a:buNone/>
+            </a:pPr>
+            <a:r>
+              <a:rPr lang="en-US" sz="900" b="1" dirty="0">
+                <a:solidFill>
+                  <a:schemeClr val="bg1"/>
+                </a:solidFill>
+              </a:rPr>
               <a:t>Screen</a:t>
             </a:r>
             <a:endParaRPr lang="en-US" sz="900" dirty="0"/>
@@ -11754,7 +12032,7 @@
         <p:spPr>
           <a:xfrm>
             <a:off x="8412480" y="1792224"/>
-            <a:ext cx="3227832" cy="1664208"/>
+            <a:ext cx="3227832" cy="1783080"/>
           </a:xfrm>
           <a:prstGeom prst="rect">
             <a:avLst/>
@@ -11774,23 +12052,23 @@
       </p:sp>
       <p:sp>
         <p:nvSpPr>
-          <p:cNvPr id="56" name="card label"/>
+          <p:cNvPr id="56" name="label"/>
           <p:cNvSpPr txBox="1"/>
           <p:nvPr/>
         </p:nvSpPr>
         <p:spPr>
           <a:xfrm>
-            <a:off x="8613648" y="1920240"/>
-            <a:ext cx="2825496" cy="237744"/>
-          </a:xfrm>
-          <a:prstGeom prst="rect">
-            <a:avLst/>
-          </a:prstGeom>
-          <a:noFill/>
-          <a:ln/>
-        </p:spPr>
-        <p:txBody>
-          <a:bodyPr wrap="square" lIns="0" tIns="0" rIns="0" bIns="0" rtlCol="0" anchor="ctr"/>
+            <a:off x="8613648" y="1988820"/>
+            <a:ext cx="2825496" cy="475488"/>
+          </a:xfrm>
+          <a:prstGeom prst="rect">
+            <a:avLst/>
+          </a:prstGeom>
+          <a:noFill/>
+          <a:ln/>
+        </p:spPr>
+        <p:txBody>
+          <a:bodyPr wrap="square" lIns="0" tIns="0" rIns="0" bIns="0" rtlCol="0" anchor="t"/>
           <a:lstStyle/>
           <a:p>
             <a:pPr indent="0" marL="0">
@@ -11816,8 +12094,8 @@
         </p:nvSpPr>
         <p:spPr>
           <a:xfrm>
-            <a:off x="8613648" y="2450592"/>
-            <a:ext cx="2825496" cy="914400"/>
+            <a:off x="8613648" y="2555748"/>
+            <a:ext cx="2825496" cy="822960"/>
           </a:xfrm>
           <a:prstGeom prst="rect">
             <a:avLst/>
@@ -11852,8 +12130,8 @@
         </p:nvSpPr>
         <p:spPr>
           <a:xfrm>
-            <a:off x="8412480" y="3621024"/>
-            <a:ext cx="3227832" cy="2487168"/>
+            <a:off x="8412480" y="3758184"/>
+            <a:ext cx="3227832" cy="2350008"/>
           </a:xfrm>
           <a:prstGeom prst="rect">
             <a:avLst/>
@@ -11879,8 +12157,8 @@
         </p:nvSpPr>
         <p:spPr>
           <a:xfrm>
-            <a:off x="8613648" y="3995928"/>
-            <a:ext cx="457200" cy="457200"/>
+            <a:off x="8613648" y="4247388"/>
+            <a:ext cx="402336" cy="402336"/>
           </a:xfrm>
           <a:prstGeom prst="ellipse">
             <a:avLst/>
@@ -11907,8 +12185,8 @@
         </p:blipFill>
         <p:spPr>
           <a:xfrm>
-            <a:off x="8714232" y="4096512"/>
-            <a:ext cx="256032" cy="256032"/>
+            <a:off x="8702162" y="4335902"/>
+            <a:ext cx="225308" cy="225308"/>
           </a:xfrm>
           <a:prstGeom prst="rect">
             <a:avLst/>
@@ -11917,14 +12195,14 @@
       </p:pic>
       <p:sp>
         <p:nvSpPr>
-          <p:cNvPr id="61" name="card label"/>
+          <p:cNvPr id="61" name="label"/>
           <p:cNvSpPr txBox="1"/>
           <p:nvPr/>
         </p:nvSpPr>
         <p:spPr>
           <a:xfrm>
-            <a:off x="8613648" y="4544568"/>
-            <a:ext cx="2825496" cy="475488"/>
+            <a:off x="9144000" y="4082796"/>
+            <a:ext cx="2295144" cy="731520"/>
           </a:xfrm>
           <a:prstGeom prst="rect">
             <a:avLst/>
@@ -11959,7 +12237,7 @@
         </p:nvSpPr>
         <p:spPr>
           <a:xfrm>
-            <a:off x="8613648" y="5138928"/>
+            <a:off x="8613648" y="4960620"/>
             <a:ext cx="2825496" cy="822960"/>
           </a:xfrm>
           <a:prstGeom prst="rect">

</xml_diff>

<commit_message>
Apply round-five copy and layout edits across the deck
Co-Authored-By: Claude Opus 5.5 <noreply@anthropic.com>
Claude-Session: https://claude.ai/code/session_0198bm9pfzRwgZQBqNvd56W8
</commit_message>
<xml_diff>
--- a/deck/Optum-LS-Conversational-AI.pptx
+++ b/deck/Optum-LS-Conversational-AI.pptx
@@ -118,27 +118,27 @@
   <p:extLst>
     <p:ext uri="{521415D9-36F7-43E2-AB2F-B90AF26B5E84}">
       <p14:sectionLst xmlns:p14="http://schemas.microsoft.com/office/powerpoint/2010/main">
-        <p14:section name="Executive summary" id="{5c9c7a13-c587-b780-a51c-dc2b13c4093d}">
+        <p14:section name="Executive summary" id="{24a83ca0-fbf1-5aa1-231e-0e9ee1b3a55d}">
           <p14:sldIdLst>
             <p14:sldId id="256"/>
           </p14:sldIdLst>
         </p14:section>
-        <p14:section name="Research catalyst" id="{d0411a08-de86-e269-ae86-2b2e47bffd53}">
+        <p14:section name="Research catalyst" id="{a3ae336b-83b3-7ccf-6aee-cd2831e1ba46}">
           <p14:sldIdLst>
             <p14:sldId id="257"/>
           </p14:sldIdLst>
         </p14:section>
-        <p14:section name="U.S. competitive landscape" id="{d38da37d-8120-5290-d975-821b4e5af839}">
+        <p14:section name="U.S. competitive landscape" id="{94ea1914-a217-df21-74d7-d7894557f7aa}">
           <p14:sldIdLst>
             <p14:sldId id="258"/>
           </p14:sldIdLst>
         </p14:section>
-        <p14:section name="International competitor screens" id="{1e360efe-ebba-2721-a891-c2e37f7cf88d}">
+        <p14:section name="International competitor screens" id="{5c2e99d5-36e9-0a01-e587-5d607015bf90}">
           <p14:sldIdLst>
             <p14:sldId id="259"/>
           </p14:sldIdLst>
         </p14:section>
-        <p14:section name="Workflow deep dives" id="{54ef858e-9456-c931-c8d9-b759bcb9f922}">
+        <p14:section name="Workflow deep dives" id="{8ddf841b-5ded-34d4-2bec-e63798bae4f9}">
           <p14:sldIdLst>
             <p14:sldId id="260"/>
             <p14:sldId id="261"/>
@@ -147,12 +147,12 @@
             <p14:sldId id="264"/>
           </p14:sldIdLst>
         </p14:section>
-        <p14:section name="AI suppliers" id="{674a1153-0968-bca4-0cf0-73cf565f366d}">
+        <p14:section name="AI suppliers" id="{8ce88946-6d30-3dca-4f63-319bce2eeb93}">
           <p14:sldIdLst>
             <p14:sldId id="265"/>
           </p14:sldIdLst>
         </p14:section>
-        <p14:section name="Methodology note" id="{224c7fbf-e05b-8c78-9c12-37c19b2e7852}">
+        <p14:section name="Methodology note" id="{195c6e09-c7e0-6bdb-94e4-1e5d4c03ac7f}">
           <p14:sldIdLst>
             <p14:sldId id="266"/>
             <p14:sldId id="267"/>
@@ -3223,9 +3223,9 @@
               <a:buNone/>
             </a:pPr>
             <a:r>
-              <a:rPr lang="en-US" sz="1100" b="1" dirty="0">
-                <a:solidFill>
-                  <a:schemeClr val="accent2"/>
+              <a:rPr lang="en-US" sz="1100" b="1" i="1" dirty="0">
+                <a:solidFill>
+                  <a:schemeClr val="tx1"/>
                 </a:solidFill>
               </a:rPr>
               <a:t>publicly-marketed</a:t>
@@ -3297,7 +3297,7 @@
               <a:buNone/>
             </a:pPr>
             <a:r>
-              <a:rPr lang="en-US" sz="950" b="1" dirty="0">
+              <a:rPr lang="en-US" sz="950" dirty="0">
                 <a:solidFill>
                   <a:schemeClr val="accent1"/>
                 </a:solidFill>
@@ -3360,7 +3360,7 @@
               <a:buNone/>
             </a:pPr>
             <a:r>
-              <a:rPr lang="en-US" sz="950" b="1" dirty="0">
+              <a:rPr lang="en-US" sz="950" dirty="0">
                 <a:solidFill>
                   <a:schemeClr val="accent1"/>
                 </a:solidFill>
@@ -3423,7 +3423,7 @@
               <a:buNone/>
             </a:pPr>
             <a:r>
-              <a:rPr lang="en-US" sz="950" b="1" dirty="0">
+              <a:rPr lang="en-US" sz="950" dirty="0">
                 <a:solidFill>
                   <a:schemeClr val="accent1"/>
                 </a:solidFill>
@@ -3486,7 +3486,7 @@
               <a:buNone/>
             </a:pPr>
             <a:r>
-              <a:rPr lang="en-US" sz="950" b="1" dirty="0">
+              <a:rPr lang="en-US" sz="950" dirty="0">
                 <a:solidFill>
                   <a:schemeClr val="accent1"/>
                 </a:solidFill>
@@ -3585,7 +3585,7 @@
               <a:buNone/>
             </a:pPr>
             <a:r>
-              <a:rPr lang="en-US" sz="950" b="1" dirty="0">
+              <a:rPr lang="en-US" sz="950" dirty="0">
                 <a:solidFill>
                   <a:schemeClr val="accent1"/>
                 </a:solidFill>
@@ -3621,7 +3621,7 @@
               <a:buNone/>
             </a:pPr>
             <a:r>
-              <a:rPr lang="en-US" sz="1100" dirty="0">
+              <a:rPr lang="en-US" sz="1100" b="1" dirty="0">
                 <a:solidFill>
                   <a:schemeClr val="tx1"/>
                 </a:solidFill>
@@ -3974,7 +3974,7 @@
       </p:sp>
       <p:sp>
         <p:nvSpPr>
-          <p:cNvPr id="30" name="optum positioning card"/>
+          <p:cNvPr id="30" name="optum ls positioning card"/>
           <p:cNvSpPr/>
           <p:nvPr/>
         </p:nvSpPr>
@@ -4073,7 +4073,7 @@
                   <a:schemeClr val="accent2"/>
                 </a:solidFill>
               </a:rPr>
-              <a:t>OPTUM POSITIONING</a:t>
+              <a:t>OPTUM LS POSITIONING</a:t>
             </a:r>
             <a:endParaRPr lang="en-US" sz="1300" dirty="0"/>
           </a:p>
@@ -4830,7 +4830,7 @@
                             <a:schemeClr val="tx1"/>
                           </a:solidFill>
                         </a:rPr>
-                        <a:t>AI suppliers can contribute underlying technology to existing life-sciences platforms while those companies retain specialized data, applications and customer relationships. Komodo and Veeva already appear in our competitive analysis.</a:t>
+                        <a:t>Conversational AI providers can contribute underlying technology to existing life-sciences platforms while those companies retain specialized data, applications and customer relationships. Komodo and Veeva already appear in our competitive analysis.</a:t>
                       </a:r>
                       <a:endParaRPr lang="en-US" sz="900" dirty="0"/>
                     </a:p>
@@ -5006,7 +5006,7 @@
                             <a:schemeClr val="tx1"/>
                           </a:solidFill>
                         </a:rPr>
-                        <a:t>Rather than acting only as technology suppliers, AI companies are building offerings aimed more directly at life-sciences users. These products are not necessarily direct substitutes for Optum's RWE and healthcare-data offerings, but they illustrate potential expansion into adjacent customer workflows.</a:t>
+                        <a:t>Rather than acting only as technology suppliers, conversational AI providers are building offerings aimed more directly at life-sciences users. These products are not necessarily direct substitutes for Optum LS's RWE and healthcare-data offerings, but they illustrate potential expansion into adjacent customer workflows.</a:t>
                       </a:r>
                       <a:endParaRPr lang="en-US" sz="900" dirty="0"/>
                     </a:p>
@@ -5154,7 +5154,7 @@
                             <a:schemeClr val="tx1"/>
                           </a:solidFill>
                         </a:rPr>
-                        <a:t>Acquisitions provide another way for AI companies to obtain industry-specific technology, expertise and pharmaceutical customer relationships—potentially strengthening their ability to supply or compete with established life-sciences platforms.</a:t>
+                        <a:t>Acquisitions provide another way for conversational AI providers to obtain industry-specific technology, expertise and pharmaceutical customer relationships—potentially strengthening their ability to supply or compete with established life-sciences platforms.</a:t>
                       </a:r>
                       <a:endParaRPr lang="en-US" sz="900" dirty="0"/>
                     </a:p>
@@ -5447,7 +5447,7 @@
                   <a:schemeClr val="accent2"/>
                 </a:solidFill>
               </a:rPr>
-              <a:t>METHODOLOGY NOTE</a:t>
+              <a:t>METHODOLOGY NOTES</a:t>
             </a:r>
             <a:endParaRPr lang="en-US" sz="1000" dirty="0"/>
           </a:p>
@@ -6223,7 +6223,7 @@
                   <a:schemeClr val="accent2"/>
                 </a:solidFill>
               </a:rPr>
-              <a:t>METHODOLOGY NOTE</a:t>
+              <a:t>METHODOLOGY NOTES (CONT.)</a:t>
             </a:r>
             <a:endParaRPr lang="en-US" sz="1000" dirty="0"/>
           </a:p>
@@ -7900,7 +7900,7 @@
                   <a:schemeClr val="tx1"/>
                 </a:solidFill>
               </a:rPr>
-              <a:t>Expand beyond RWE to assess publicly-marketed conversational AI across five Optum LS-aligned domains, prioritizing the U.S. competitive landscape and using selected international offerings for context.</a:t>
+              <a:t>We look beyond RWE to assess publicly-marketed conversational AI across five Optum LS-aligned domains, prioritizing the U.S. competitive landscape and using selected international offerings for context.</a:t>
             </a:r>
             <a:endParaRPr lang="en-US" sz="1200" dirty="0"/>
           </a:p>
@@ -8046,7 +8046,19 @@
                   <a:schemeClr val="accent1"/>
                 </a:solidFill>
               </a:rPr>
-              <a:t>Among U.S. competitors, conversational AI is most prominent in RWE; Optum LS has relevant offerings in all five domains</a:t>
+              <a:t>Among U.S. competitors, conversational AI is most prominent in RWE;</a:t>
+            </a:r>
+            <a:br/>
+            <a:pPr algn="l" indent="0" marL="0">
+              <a:buNone/>
+            </a:pPr>
+            <a:r>
+              <a:rPr lang="en-US" sz="2200" b="1" dirty="0">
+                <a:solidFill>
+                  <a:schemeClr val="accent1"/>
+                </a:solidFill>
+              </a:rPr>
+              <a:t>Optum LS has relevant offerings in all five domains</a:t>
             </a:r>
             <a:endParaRPr lang="en-US" sz="2200" dirty="0"/>
           </a:p>
@@ -8060,8 +8072,8 @@
         </p:nvSpPr>
         <p:spPr>
           <a:xfrm>
-            <a:off x="548640" y="1517904"/>
-            <a:ext cx="5180076" cy="548640"/>
+            <a:off x="2173986" y="1517904"/>
+            <a:ext cx="2939796" cy="548640"/>
           </a:xfrm>
           <a:prstGeom prst="rect">
             <a:avLst/>
@@ -8080,7 +8092,7 @@
         </p:nvSpPr>
         <p:spPr>
           <a:xfrm>
-            <a:off x="2050542" y="1517904"/>
+            <a:off x="2430018" y="1517904"/>
             <a:ext cx="420624" cy="548640"/>
           </a:xfrm>
           <a:prstGeom prst="rect">
@@ -8116,8 +8128,8 @@
         </p:nvSpPr>
         <p:spPr>
           <a:xfrm>
-            <a:off x="2580894" y="1517904"/>
-            <a:ext cx="1645920" cy="548640"/>
+            <a:off x="2960370" y="1517904"/>
+            <a:ext cx="1988820" cy="548640"/>
           </a:xfrm>
           <a:prstGeom prst="rect">
             <a:avLst/>
@@ -8138,7 +8150,7 @@
                   <a:schemeClr val="accent1"/>
                 </a:solidFill>
               </a:rPr>
-              <a:t>competitors screened</a:t>
+              <a:t>U.S. competitors screened</a:t>
             </a:r>
             <a:endParaRPr lang="en-US" sz="1100" dirty="0"/>
           </a:p>
@@ -8152,8 +8164,8 @@
         </p:nvSpPr>
         <p:spPr>
           <a:xfrm>
-            <a:off x="5911596" y="1673352"/>
-            <a:ext cx="365760" cy="237744"/>
+            <a:off x="5314950" y="1673352"/>
+            <a:ext cx="420624" cy="237744"/>
           </a:xfrm>
           <a:prstGeom prst="rightArrow">
             <a:avLst/>
@@ -8172,8 +8184,8 @@
         </p:nvSpPr>
         <p:spPr>
           <a:xfrm>
-            <a:off x="6460236" y="1517904"/>
-            <a:ext cx="5180076" cy="548640"/>
+            <a:off x="5936742" y="1517904"/>
+            <a:ext cx="4078224" cy="548640"/>
           </a:xfrm>
           <a:prstGeom prst="rect">
             <a:avLst/>
@@ -8192,7 +8204,7 @@
         </p:nvSpPr>
         <p:spPr>
           <a:xfrm>
-            <a:off x="7184898" y="1517904"/>
+            <a:off x="6192774" y="1517904"/>
             <a:ext cx="420624" cy="548640"/>
           </a:xfrm>
           <a:prstGeom prst="rect">
@@ -8228,8 +8240,8 @@
         </p:nvSpPr>
         <p:spPr>
           <a:xfrm>
-            <a:off x="7715250" y="1517904"/>
-            <a:ext cx="3200400" cy="548640"/>
+            <a:off x="6723126" y="1517904"/>
+            <a:ext cx="3127248" cy="548640"/>
           </a:xfrm>
           <a:prstGeom prst="rect">
             <a:avLst/>
@@ -8258,49 +8270,13 @@
       </p:sp>
       <p:sp>
         <p:nvSpPr>
-          <p:cNvPr id="11" name="label"/>
-          <p:cNvSpPr txBox="1"/>
-          <p:nvPr/>
-        </p:nvSpPr>
-        <p:spPr>
-          <a:xfrm>
-            <a:off x="548640" y="2231136"/>
-            <a:ext cx="6400800" cy="201168"/>
-          </a:xfrm>
-          <a:prstGeom prst="rect">
-            <a:avLst/>
-          </a:prstGeom>
-          <a:noFill/>
-          <a:ln/>
-        </p:spPr>
-        <p:txBody>
-          <a:bodyPr wrap="square" lIns="0" tIns="0" rIns="0" bIns="0" rtlCol="0" anchor="t"/>
-          <a:lstStyle/>
-          <a:p>
-            <a:pPr indent="0" marL="0">
-              <a:buNone/>
-            </a:pPr>
-            <a:r>
-              <a:rPr lang="en-US" sz="1000" b="1" spc="100" kern="0" dirty="0">
-                <a:solidFill>
-                  <a:schemeClr val="accent2"/>
-                </a:solidFill>
-              </a:rPr>
-              <a:t>COMPETITOR COVERAGE AND OPTUM LS POSITIONING</a:t>
-            </a:r>
-            <a:endParaRPr lang="en-US" sz="1000" dirty="0"/>
-          </a:p>
-        </p:txBody>
-      </p:sp>
-      <p:sp>
-        <p:nvSpPr>
-          <p:cNvPr id="12" name="table header"/>
+          <p:cNvPr id="11" name="table header"/>
           <p:cNvSpPr/>
           <p:nvPr/>
         </p:nvSpPr>
         <p:spPr>
           <a:xfrm>
-            <a:off x="548640" y="2468880"/>
+            <a:off x="548640" y="2286000"/>
             <a:ext cx="11091672" cy="457200"/>
           </a:xfrm>
           <a:prstGeom prst="rect">
@@ -8314,14 +8290,64 @@
       </p:sp>
       <p:sp>
         <p:nvSpPr>
+          <p:cNvPr id="12" name="Text 10"/>
+          <p:cNvSpPr txBox="1"/>
+          <p:nvPr/>
+        </p:nvSpPr>
+        <p:spPr>
+          <a:xfrm>
+            <a:off x="960120" y="2286000"/>
+            <a:ext cx="2423160" cy="457200"/>
+          </a:xfrm>
+          <a:prstGeom prst="rect">
+            <a:avLst/>
+          </a:prstGeom>
+          <a:noFill/>
+          <a:ln/>
+        </p:spPr>
+        <p:txBody>
+          <a:bodyPr wrap="square" lIns="0" tIns="0" rIns="0" bIns="0" rtlCol="0" anchor="ctr"/>
+          <a:lstStyle/>
+          <a:p>
+            <a:pPr algn="ctr" indent="0" marL="0">
+              <a:buNone/>
+            </a:pPr>
+            <a:r>
+              <a:rPr lang="en-US" sz="900" b="1" dirty="0">
+                <a:solidFill>
+                  <a:schemeClr val="bg1"/>
+                </a:solidFill>
+              </a:rPr>
+              <a:t>Competitors marketing conversational AI /</a:t>
+            </a:r>
+            <a:endParaRPr lang="en-US" sz="900" dirty="0"/>
+          </a:p>
+          <a:p>
+            <a:pPr algn="ctr" indent="0" marL="0">
+              <a:buNone/>
+            </a:pPr>
+            <a:r>
+              <a:rPr lang="en-US" sz="900" b="1" dirty="0">
+                <a:solidFill>
+                  <a:schemeClr val="bg1"/>
+                </a:solidFill>
+              </a:rPr>
+              <a:t>Total comparable competitors</a:t>
+            </a:r>
+            <a:endParaRPr lang="en-US" sz="900" dirty="0"/>
+          </a:p>
+        </p:txBody>
+      </p:sp>
+      <p:sp>
+        <p:nvSpPr>
           <p:cNvPr id="13" name="Text 11"/>
           <p:cNvSpPr txBox="1"/>
           <p:nvPr/>
         </p:nvSpPr>
         <p:spPr>
           <a:xfrm>
-            <a:off x="960120" y="2468880"/>
-            <a:ext cx="2423160" cy="457200"/>
+            <a:off x="3474720" y="2286000"/>
+            <a:ext cx="1965960" cy="457200"/>
           </a:xfrm>
           <a:prstGeom prst="rect">
             <a:avLst/>
@@ -8342,21 +8368,7 @@
                   <a:schemeClr val="bg1"/>
                 </a:solidFill>
               </a:rPr>
-              <a:t>Competitors marketing conversational AI /</a:t>
-            </a:r>
-            <a:endParaRPr lang="en-US" sz="900" dirty="0"/>
-          </a:p>
-          <a:p>
-            <a:pPr algn="ctr" indent="0" marL="0">
-              <a:buNone/>
-            </a:pPr>
-            <a:r>
-              <a:rPr lang="en-US" sz="900" b="1" dirty="0">
-                <a:solidFill>
-                  <a:schemeClr val="bg1"/>
-                </a:solidFill>
-              </a:rPr>
-              <a:t>Total comparable competitors</a:t>
+              <a:t>Domain</a:t>
             </a:r>
             <a:endParaRPr lang="en-US" sz="900" dirty="0"/>
           </a:p>
@@ -8370,8 +8382,8 @@
         </p:nvSpPr>
         <p:spPr>
           <a:xfrm>
-            <a:off x="3474720" y="2468880"/>
-            <a:ext cx="1965960" cy="457200"/>
+            <a:off x="5486400" y="2286000"/>
+            <a:ext cx="2880360" cy="457200"/>
           </a:xfrm>
           <a:prstGeom prst="rect">
             <a:avLst/>
@@ -8392,7 +8404,7 @@
                   <a:schemeClr val="bg1"/>
                 </a:solidFill>
               </a:rPr>
-              <a:t>Domain</a:t>
+              <a:t>Conversational AI offerings</a:t>
             </a:r>
             <a:endParaRPr lang="en-US" sz="900" dirty="0"/>
           </a:p>
@@ -8406,8 +8418,8 @@
         </p:nvSpPr>
         <p:spPr>
           <a:xfrm>
-            <a:off x="5486400" y="2468880"/>
-            <a:ext cx="2880360" cy="457200"/>
+            <a:off x="8503920" y="2286000"/>
+            <a:ext cx="2103120" cy="457200"/>
           </a:xfrm>
           <a:prstGeom prst="rect">
             <a:avLst/>
@@ -8428,7 +8440,21 @@
                   <a:schemeClr val="bg1"/>
                 </a:solidFill>
               </a:rPr>
-              <a:t>Conversational AI offerings</a:t>
+              <a:t>Relevant Optum LS</a:t>
+            </a:r>
+            <a:endParaRPr lang="en-US" sz="900" dirty="0"/>
+          </a:p>
+          <a:p>
+            <a:pPr algn="ctr" indent="0" marL="0">
+              <a:buNone/>
+            </a:pPr>
+            <a:r>
+              <a:rPr lang="en-US" sz="900" b="1" dirty="0">
+                <a:solidFill>
+                  <a:schemeClr val="bg1"/>
+                </a:solidFill>
+              </a:rPr>
+              <a:t>offerings</a:t>
             </a:r>
             <a:endParaRPr lang="en-US" sz="900" dirty="0"/>
           </a:p>
@@ -8442,57 +8468,7 @@
         </p:nvSpPr>
         <p:spPr>
           <a:xfrm>
-            <a:off x="8503920" y="2468880"/>
-            <a:ext cx="2103120" cy="457200"/>
-          </a:xfrm>
-          <a:prstGeom prst="rect">
-            <a:avLst/>
-          </a:prstGeom>
-          <a:noFill/>
-          <a:ln/>
-        </p:spPr>
-        <p:txBody>
-          <a:bodyPr wrap="square" lIns="0" tIns="0" rIns="0" bIns="0" rtlCol="0" anchor="ctr"/>
-          <a:lstStyle/>
-          <a:p>
-            <a:pPr algn="ctr" indent="0" marL="0">
-              <a:buNone/>
-            </a:pPr>
-            <a:r>
-              <a:rPr lang="en-US" sz="900" b="1" dirty="0">
-                <a:solidFill>
-                  <a:schemeClr val="bg1"/>
-                </a:solidFill>
-              </a:rPr>
-              <a:t>Relevant Optum LS</a:t>
-            </a:r>
-            <a:endParaRPr lang="en-US" sz="900" dirty="0"/>
-          </a:p>
-          <a:p>
-            <a:pPr algn="ctr" indent="0" marL="0">
-              <a:buNone/>
-            </a:pPr>
-            <a:r>
-              <a:rPr lang="en-US" sz="900" b="1" dirty="0">
-                <a:solidFill>
-                  <a:schemeClr val="bg1"/>
-                </a:solidFill>
-              </a:rPr>
-              <a:t>offerings</a:t>
-            </a:r>
-            <a:endParaRPr lang="en-US" sz="900" dirty="0"/>
-          </a:p>
-        </p:txBody>
-      </p:sp>
-      <p:sp>
-        <p:nvSpPr>
-          <p:cNvPr id="17" name="Text 15"/>
-          <p:cNvSpPr txBox="1"/>
-          <p:nvPr/>
-        </p:nvSpPr>
-        <p:spPr>
-          <a:xfrm>
-            <a:off x="10652760" y="2468880"/>
+            <a:off x="10652760" y="2286000"/>
             <a:ext cx="987552" cy="457200"/>
           </a:xfrm>
           <a:prstGeom prst="rect">
@@ -8536,13 +8512,13 @@
       </p:sp>
       <p:graphicFrame>
         <p:nvGraphicFramePr>
-          <p:cNvPr id="18" name="competitor coverage chart" descr=""/>
+          <p:cNvPr id="17" name="competitor coverage chart" descr=""/>
           <p:cNvGraphicFramePr/>
           <p:nvPr/>
         </p:nvGraphicFramePr>
         <p:xfrm>
-          <a:off x="1170432" y="2926080"/>
-          <a:ext cx="2212848" cy="2331720"/>
+          <a:off x="1170432" y="2743200"/>
+          <a:ext cx="2212848" cy="2514600"/>
         </p:xfrm>
         <a:graphic xmlns:a="http://schemas.openxmlformats.org/drawingml/2006/main">
           <a:graphicData uri="http://schemas.openxmlformats.org/drawingml/2006/chart">
@@ -8552,14 +8528,14 @@
       </p:graphicFrame>
       <p:sp>
         <p:nvSpPr>
-          <p:cNvPr id="19" name="fraction RWE"/>
+          <p:cNvPr id="18" name="fraction RWE"/>
           <p:cNvSpPr txBox="1"/>
           <p:nvPr/>
         </p:nvSpPr>
         <p:spPr>
           <a:xfrm>
-            <a:off x="566928" y="2926080"/>
-            <a:ext cx="548640" cy="466344"/>
+            <a:off x="566928" y="2743200"/>
+            <a:ext cx="548640" cy="502920"/>
           </a:xfrm>
           <a:prstGeom prst="rect">
             <a:avLst/>
@@ -8577,7 +8553,7 @@
             <a:r>
               <a:rPr lang="en-US" sz="1000" b="1" dirty="0">
                 <a:solidFill>
-                  <a:schemeClr val="accent2"/>
+                  <a:schemeClr val="accent1"/>
                 </a:solidFill>
               </a:rPr>
               <a:t>9</a:t>
@@ -8599,13 +8575,13 @@
       </p:sp>
       <p:sp>
         <p:nvSpPr>
-          <p:cNvPr id="20" name="workflow chip RWE"/>
+          <p:cNvPr id="19" name="workflow chip RWE"/>
           <p:cNvSpPr/>
           <p:nvPr/>
         </p:nvSpPr>
         <p:spPr>
           <a:xfrm>
-            <a:off x="3547872" y="3003804"/>
+            <a:off x="3547872" y="2839212"/>
             <a:ext cx="1819656" cy="310896"/>
           </a:xfrm>
           <a:prstGeom prst="roundRect">
@@ -8626,14 +8602,50 @@
       </p:sp>
       <p:sp>
         <p:nvSpPr>
+          <p:cNvPr id="20" name="Text 17"/>
+          <p:cNvSpPr txBox="1"/>
+          <p:nvPr/>
+        </p:nvSpPr>
+        <p:spPr>
+          <a:xfrm>
+            <a:off x="3547872" y="2839212"/>
+            <a:ext cx="1819656" cy="310896"/>
+          </a:xfrm>
+          <a:prstGeom prst="rect">
+            <a:avLst/>
+          </a:prstGeom>
+          <a:noFill/>
+          <a:ln/>
+        </p:spPr>
+        <p:txBody>
+          <a:bodyPr wrap="square" lIns="0" tIns="0" rIns="0" bIns="0" rtlCol="0" anchor="ctr"/>
+          <a:lstStyle/>
+          <a:p>
+            <a:pPr algn="ctr" indent="0" marL="0">
+              <a:buNone/>
+            </a:pPr>
+            <a:r>
+              <a:rPr lang="en-US" sz="900" b="1" dirty="0">
+                <a:solidFill>
+                  <a:schemeClr val="accent1"/>
+                </a:solidFill>
+              </a:rPr>
+              <a:t>RWE</a:t>
+            </a:r>
+            <a:endParaRPr lang="en-US" sz="900" dirty="0"/>
+          </a:p>
+        </p:txBody>
+      </p:sp>
+      <p:sp>
+        <p:nvSpPr>
           <p:cNvPr id="21" name="Text 18"/>
           <p:cNvSpPr txBox="1"/>
           <p:nvPr/>
         </p:nvSpPr>
         <p:spPr>
           <a:xfrm>
-            <a:off x="3547872" y="3003804"/>
-            <a:ext cx="1819656" cy="310896"/>
+            <a:off x="5577840" y="2743200"/>
+            <a:ext cx="2697480" cy="502920"/>
           </a:xfrm>
           <a:prstGeom prst="rect">
             <a:avLst/>
@@ -8645,16 +8657,16 @@
           <a:bodyPr wrap="square" lIns="0" tIns="0" rIns="0" bIns="0" rtlCol="0" anchor="ctr"/>
           <a:lstStyle/>
           <a:p>
-            <a:pPr algn="ctr" indent="0" marL="0">
-              <a:buNone/>
-            </a:pPr>
-            <a:r>
-              <a:rPr lang="en-US" sz="900" b="1" dirty="0">
-                <a:solidFill>
-                  <a:schemeClr val="accent1"/>
-                </a:solidFill>
-              </a:rPr>
-              <a:t>RWE</a:t>
+            <a:pPr indent="0" marL="0">
+              <a:buNone/>
+            </a:pPr>
+            <a:r>
+              <a:rPr lang="en-US" sz="900" dirty="0">
+                <a:solidFill>
+                  <a:schemeClr val="tx1"/>
+                </a:solidFill>
+              </a:rPr>
+              <a:t>Komodo Marmot and MapAI; Truveta Intelligence; Flatiron Telescope; Tempus Lens; and more</a:t>
             </a:r>
             <a:endParaRPr lang="en-US" sz="900" dirty="0"/>
           </a:p>
@@ -8668,8 +8680,8 @@
         </p:nvSpPr>
         <p:spPr>
           <a:xfrm>
-            <a:off x="5577840" y="2926080"/>
-            <a:ext cx="2697480" cy="466344"/>
+            <a:off x="8595360" y="2743200"/>
+            <a:ext cx="1920240" cy="502920"/>
           </a:xfrm>
           <a:prstGeom prst="rect">
             <a:avLst/>
@@ -8690,7 +8702,7 @@
                   <a:schemeClr val="tx1"/>
                 </a:solidFill>
               </a:rPr>
-              <a:t>Komodo Marmot and MapAI; Truveta Intelligence; Flatiron Telescope; Tempus Lens; and more</a:t>
+              <a:t>Analytics on Demand; epidemiology research</a:t>
             </a:r>
             <a:endParaRPr lang="en-US" sz="900" dirty="0"/>
           </a:p>
@@ -8698,49 +8710,13 @@
       </p:sp>
       <p:sp>
         <p:nvSpPr>
-          <p:cNvPr id="23" name="Text 20"/>
-          <p:cNvSpPr txBox="1"/>
-          <p:nvPr/>
-        </p:nvSpPr>
-        <p:spPr>
-          <a:xfrm>
-            <a:off x="8595360" y="2926080"/>
-            <a:ext cx="1920240" cy="466344"/>
-          </a:xfrm>
-          <a:prstGeom prst="rect">
-            <a:avLst/>
-          </a:prstGeom>
-          <a:noFill/>
-          <a:ln/>
-        </p:spPr>
-        <p:txBody>
-          <a:bodyPr wrap="square" lIns="0" tIns="0" rIns="0" bIns="0" rtlCol="0" anchor="ctr"/>
-          <a:lstStyle/>
-          <a:p>
-            <a:pPr indent="0" marL="0">
-              <a:buNone/>
-            </a:pPr>
-            <a:r>
-              <a:rPr lang="en-US" sz="900" dirty="0">
-                <a:solidFill>
-                  <a:schemeClr val="tx1"/>
-                </a:solidFill>
-              </a:rPr>
-              <a:t>Analytics on Demand; epidemiology research</a:t>
-            </a:r>
-            <a:endParaRPr lang="en-US" sz="900" dirty="0"/>
-          </a:p>
-        </p:txBody>
-      </p:sp>
-      <p:sp>
-        <p:nvSpPr>
-          <p:cNvPr id="24" name="chat status RWE"/>
+          <p:cNvPr id="23" name="chat status RWE"/>
           <p:cNvSpPr/>
           <p:nvPr/>
         </p:nvSpPr>
         <p:spPr>
           <a:xfrm>
-            <a:off x="11109960" y="3076956"/>
+            <a:off x="11109960" y="2912364"/>
             <a:ext cx="164592" cy="164592"/>
           </a:xfrm>
           <a:prstGeom prst="ellipse">
@@ -8756,13 +8732,13 @@
       </p:sp>
       <p:sp>
         <p:nvSpPr>
-          <p:cNvPr id="25" name="Shape 22"/>
+          <p:cNvPr id="24" name="Shape 21"/>
           <p:cNvSpPr/>
           <p:nvPr/>
         </p:nvSpPr>
         <p:spPr>
           <a:xfrm>
-            <a:off x="548640" y="3392424"/>
+            <a:off x="548640" y="3246120"/>
             <a:ext cx="11091672" cy="0"/>
           </a:xfrm>
           <a:prstGeom prst="line">
@@ -8779,14 +8755,14 @@
       </p:sp>
       <p:sp>
         <p:nvSpPr>
-          <p:cNvPr id="26" name="fraction Commercial Intelligence"/>
+          <p:cNvPr id="25" name="fraction Commercial Intelligence"/>
           <p:cNvSpPr txBox="1"/>
           <p:nvPr/>
         </p:nvSpPr>
         <p:spPr>
           <a:xfrm>
-            <a:off x="1282849" y="3392424"/>
-            <a:ext cx="548640" cy="466344"/>
+            <a:off x="1282849" y="3246120"/>
+            <a:ext cx="548640" cy="502920"/>
           </a:xfrm>
           <a:prstGeom prst="rect">
             <a:avLst/>
@@ -8804,7 +8780,7 @@
             <a:r>
               <a:rPr lang="en-US" sz="1000" b="1" dirty="0">
                 <a:solidFill>
-                  <a:schemeClr val="accent2"/>
+                  <a:schemeClr val="accent1"/>
                 </a:solidFill>
               </a:rPr>
               <a:t>3</a:t>
@@ -8826,13 +8802,13 @@
       </p:sp>
       <p:sp>
         <p:nvSpPr>
-          <p:cNvPr id="27" name="workflow chip Commercial Intelligence"/>
+          <p:cNvPr id="26" name="workflow chip Commercial Intelligence"/>
           <p:cNvSpPr/>
           <p:nvPr/>
         </p:nvSpPr>
         <p:spPr>
           <a:xfrm>
-            <a:off x="3547872" y="3470148"/>
+            <a:off x="3547872" y="3342132"/>
             <a:ext cx="1819656" cy="310896"/>
           </a:xfrm>
           <a:prstGeom prst="roundRect">
@@ -8853,14 +8829,50 @@
       </p:sp>
       <p:sp>
         <p:nvSpPr>
+          <p:cNvPr id="27" name="Text 24"/>
+          <p:cNvSpPr txBox="1"/>
+          <p:nvPr/>
+        </p:nvSpPr>
+        <p:spPr>
+          <a:xfrm>
+            <a:off x="3547872" y="3342132"/>
+            <a:ext cx="1819656" cy="310896"/>
+          </a:xfrm>
+          <a:prstGeom prst="rect">
+            <a:avLst/>
+          </a:prstGeom>
+          <a:noFill/>
+          <a:ln/>
+        </p:spPr>
+        <p:txBody>
+          <a:bodyPr wrap="square" lIns="0" tIns="0" rIns="0" bIns="0" rtlCol="0" anchor="ctr"/>
+          <a:lstStyle/>
+          <a:p>
+            <a:pPr algn="ctr" indent="0" marL="0">
+              <a:buNone/>
+            </a:pPr>
+            <a:r>
+              <a:rPr lang="en-US" sz="900" b="1" dirty="0">
+                <a:solidFill>
+                  <a:schemeClr val="accent1"/>
+                </a:solidFill>
+              </a:rPr>
+              <a:t>Commercial Intelligence</a:t>
+            </a:r>
+            <a:endParaRPr lang="en-US" sz="900" dirty="0"/>
+          </a:p>
+        </p:txBody>
+      </p:sp>
+      <p:sp>
+        <p:nvSpPr>
           <p:cNvPr id="28" name="Text 25"/>
           <p:cNvSpPr txBox="1"/>
           <p:nvPr/>
         </p:nvSpPr>
         <p:spPr>
           <a:xfrm>
-            <a:off x="3547872" y="3470148"/>
-            <a:ext cx="1819656" cy="310896"/>
+            <a:off x="5577840" y="3246120"/>
+            <a:ext cx="2697480" cy="502920"/>
           </a:xfrm>
           <a:prstGeom prst="rect">
             <a:avLst/>
@@ -8872,16 +8884,16 @@
           <a:bodyPr wrap="square" lIns="0" tIns="0" rIns="0" bIns="0" rtlCol="0" anchor="ctr"/>
           <a:lstStyle/>
           <a:p>
-            <a:pPr algn="ctr" indent="0" marL="0">
-              <a:buNone/>
-            </a:pPr>
-            <a:r>
-              <a:rPr lang="en-US" sz="900" b="1" dirty="0">
-                <a:solidFill>
-                  <a:schemeClr val="accent1"/>
-                </a:solidFill>
-              </a:rPr>
-              <a:t>Commercial Intelligence</a:t>
+            <a:pPr indent="0" marL="0">
+              <a:buNone/>
+            </a:pPr>
+            <a:r>
+              <a:rPr lang="en-US" sz="900" dirty="0">
+                <a:solidFill>
+                  <a:schemeClr val="tx1"/>
+                </a:solidFill>
+              </a:rPr>
+              <a:t>IQVIA Field Force Agent and GMI Agent; ZS Conversational AI for Commercial; Trinity InsightsEDGE Digital Twins</a:t>
             </a:r>
             <a:endParaRPr lang="en-US" sz="900" dirty="0"/>
           </a:p>
@@ -8895,8 +8907,8 @@
         </p:nvSpPr>
         <p:spPr>
           <a:xfrm>
-            <a:off x="5577840" y="3392424"/>
-            <a:ext cx="2697480" cy="466344"/>
+            <a:off x="8595360" y="3246120"/>
+            <a:ext cx="1920240" cy="502920"/>
           </a:xfrm>
           <a:prstGeom prst="rect">
             <a:avLst/>
@@ -8917,7 +8929,7 @@
                   <a:schemeClr val="tx1"/>
                 </a:solidFill>
               </a:rPr>
-              <a:t>IQVIA Field Force Agent and GMI Agent; ZS Conversational AI for Commercial; Trinity InsightsEDGE Digital Twins</a:t>
+              <a:t>Market Clarity: portfolio and patient/prescriber analytics</a:t>
             </a:r>
             <a:endParaRPr lang="en-US" sz="900" dirty="0"/>
           </a:p>
@@ -8925,49 +8937,13 @@
       </p:sp>
       <p:sp>
         <p:nvSpPr>
-          <p:cNvPr id="30" name="Text 27"/>
-          <p:cNvSpPr txBox="1"/>
-          <p:nvPr/>
-        </p:nvSpPr>
-        <p:spPr>
-          <a:xfrm>
-            <a:off x="8595360" y="3392424"/>
-            <a:ext cx="1920240" cy="466344"/>
-          </a:xfrm>
-          <a:prstGeom prst="rect">
-            <a:avLst/>
-          </a:prstGeom>
-          <a:noFill/>
-          <a:ln/>
-        </p:spPr>
-        <p:txBody>
-          <a:bodyPr wrap="square" lIns="0" tIns="0" rIns="0" bIns="0" rtlCol="0" anchor="ctr"/>
-          <a:lstStyle/>
-          <a:p>
-            <a:pPr indent="0" marL="0">
-              <a:buNone/>
-            </a:pPr>
-            <a:r>
-              <a:rPr lang="en-US" sz="900" dirty="0">
-                <a:solidFill>
-                  <a:schemeClr val="tx1"/>
-                </a:solidFill>
-              </a:rPr>
-              <a:t>Market Clarity: portfolio and patient/prescriber analytics</a:t>
-            </a:r>
-            <a:endParaRPr lang="en-US" sz="900" dirty="0"/>
-          </a:p>
-        </p:txBody>
-      </p:sp>
-      <p:sp>
-        <p:nvSpPr>
-          <p:cNvPr id="31" name="chat status Commercial Intelligence"/>
+          <p:cNvPr id="30" name="chat status Commercial Intelligence"/>
           <p:cNvSpPr/>
           <p:nvPr/>
         </p:nvSpPr>
         <p:spPr>
           <a:xfrm>
-            <a:off x="11109960" y="3543300"/>
+            <a:off x="11109960" y="3415284"/>
             <a:ext cx="164592" cy="164592"/>
           </a:xfrm>
           <a:prstGeom prst="ellipse">
@@ -8983,13 +8959,13 @@
       </p:sp>
       <p:sp>
         <p:nvSpPr>
-          <p:cNvPr id="32" name="Shape 29"/>
+          <p:cNvPr id="31" name="Shape 28"/>
           <p:cNvSpPr/>
           <p:nvPr/>
         </p:nvSpPr>
         <p:spPr>
           <a:xfrm>
-            <a:off x="548640" y="3858768"/>
+            <a:off x="548640" y="3749040"/>
             <a:ext cx="11091672" cy="0"/>
           </a:xfrm>
           <a:prstGeom prst="line">
@@ -9006,14 +8982,14 @@
       </p:sp>
       <p:sp>
         <p:nvSpPr>
-          <p:cNvPr id="33" name="fraction Medical / Regulatory Research"/>
+          <p:cNvPr id="32" name="fraction Medical / Regulatory Research"/>
           <p:cNvSpPr txBox="1"/>
           <p:nvPr/>
         </p:nvSpPr>
         <p:spPr>
           <a:xfrm>
-            <a:off x="1608268" y="3858768"/>
-            <a:ext cx="548640" cy="466344"/>
+            <a:off x="1608268" y="3749040"/>
+            <a:ext cx="548640" cy="502920"/>
           </a:xfrm>
           <a:prstGeom prst="rect">
             <a:avLst/>
@@ -9031,7 +9007,7 @@
             <a:r>
               <a:rPr lang="en-US" sz="1000" b="1" dirty="0">
                 <a:solidFill>
-                  <a:schemeClr val="accent2"/>
+                  <a:schemeClr val="accent1"/>
                 </a:solidFill>
               </a:rPr>
               <a:t>3</a:t>
@@ -9053,13 +9029,13 @@
       </p:sp>
       <p:sp>
         <p:nvSpPr>
-          <p:cNvPr id="34" name="workflow chip Medical / Regulatory Research"/>
+          <p:cNvPr id="33" name="workflow chip Medical / Regulatory Research"/>
           <p:cNvSpPr/>
           <p:nvPr/>
         </p:nvSpPr>
         <p:spPr>
           <a:xfrm>
-            <a:off x="3547872" y="3936492"/>
+            <a:off x="3547872" y="3845052"/>
             <a:ext cx="1819656" cy="310896"/>
           </a:xfrm>
           <a:prstGeom prst="roundRect">
@@ -9080,14 +9056,50 @@
       </p:sp>
       <p:sp>
         <p:nvSpPr>
+          <p:cNvPr id="34" name="Text 31"/>
+          <p:cNvSpPr txBox="1"/>
+          <p:nvPr/>
+        </p:nvSpPr>
+        <p:spPr>
+          <a:xfrm>
+            <a:off x="3547872" y="3845052"/>
+            <a:ext cx="1819656" cy="310896"/>
+          </a:xfrm>
+          <a:prstGeom prst="rect">
+            <a:avLst/>
+          </a:prstGeom>
+          <a:noFill/>
+          <a:ln/>
+        </p:spPr>
+        <p:txBody>
+          <a:bodyPr wrap="square" lIns="0" tIns="0" rIns="0" bIns="0" rtlCol="0" anchor="ctr"/>
+          <a:lstStyle/>
+          <a:p>
+            <a:pPr algn="ctr" indent="0" marL="0">
+              <a:buNone/>
+            </a:pPr>
+            <a:r>
+              <a:rPr lang="en-US" sz="900" b="1" dirty="0">
+                <a:solidFill>
+                  <a:schemeClr val="accent1"/>
+                </a:solidFill>
+              </a:rPr>
+              <a:t>Medical / Regulatory Research</a:t>
+            </a:r>
+            <a:endParaRPr lang="en-US" sz="900" dirty="0"/>
+          </a:p>
+        </p:txBody>
+      </p:sp>
+      <p:sp>
+        <p:nvSpPr>
           <p:cNvPr id="35" name="Text 32"/>
           <p:cNvSpPr txBox="1"/>
           <p:nvPr/>
         </p:nvSpPr>
         <p:spPr>
           <a:xfrm>
-            <a:off x="3547872" y="3936492"/>
-            <a:ext cx="1819656" cy="310896"/>
+            <a:off x="5577840" y="3749040"/>
+            <a:ext cx="2697480" cy="502920"/>
           </a:xfrm>
           <a:prstGeom prst="rect">
             <a:avLst/>
@@ -9099,16 +9111,16 @@
           <a:bodyPr wrap="square" lIns="0" tIns="0" rIns="0" bIns="0" rtlCol="0" anchor="ctr"/>
           <a:lstStyle/>
           <a:p>
-            <a:pPr algn="ctr" indent="0" marL="0">
-              <a:buNone/>
-            </a:pPr>
-            <a:r>
-              <a:rPr lang="en-US" sz="900" b="1" dirty="0">
-                <a:solidFill>
-                  <a:schemeClr val="accent1"/>
-                </a:solidFill>
-              </a:rPr>
-              <a:t>Medical / Regulatory Research</a:t>
+            <a:pPr indent="0" marL="0">
+              <a:buNone/>
+            </a:pPr>
+            <a:r>
+              <a:rPr lang="en-US" sz="900" dirty="0">
+                <a:solidFill>
+                  <a:schemeClr val="tx1"/>
+                </a:solidFill>
+              </a:rPr>
+              <a:t>IQVIA Med-R1; ZS Conversational AI for Medical; Veeva Vault AI Chat</a:t>
             </a:r>
             <a:endParaRPr lang="en-US" sz="900" dirty="0"/>
           </a:p>
@@ -9122,8 +9134,8 @@
         </p:nvSpPr>
         <p:spPr>
           <a:xfrm>
-            <a:off x="5577840" y="3858768"/>
-            <a:ext cx="2697480" cy="466344"/>
+            <a:off x="8595360" y="3749040"/>
+            <a:ext cx="1920240" cy="502920"/>
           </a:xfrm>
           <a:prstGeom prst="rect">
             <a:avLst/>
@@ -9144,7 +9156,7 @@
                   <a:schemeClr val="tx1"/>
                 </a:solidFill>
               </a:rPr>
-              <a:t>IQVIA Med-R1; ZS Conversational AI for Medical; Veeva Vault AI Chat</a:t>
+              <a:t>Postapproval safety studies; Market Clarity medical affairs insights</a:t>
             </a:r>
             <a:endParaRPr lang="en-US" sz="900" dirty="0"/>
           </a:p>
@@ -9152,49 +9164,13 @@
       </p:sp>
       <p:sp>
         <p:nvSpPr>
-          <p:cNvPr id="37" name="Text 34"/>
-          <p:cNvSpPr txBox="1"/>
-          <p:nvPr/>
-        </p:nvSpPr>
-        <p:spPr>
-          <a:xfrm>
-            <a:off x="8595360" y="3858768"/>
-            <a:ext cx="1920240" cy="466344"/>
-          </a:xfrm>
-          <a:prstGeom prst="rect">
-            <a:avLst/>
-          </a:prstGeom>
-          <a:noFill/>
-          <a:ln/>
-        </p:spPr>
-        <p:txBody>
-          <a:bodyPr wrap="square" lIns="0" tIns="0" rIns="0" bIns="0" rtlCol="0" anchor="ctr"/>
-          <a:lstStyle/>
-          <a:p>
-            <a:pPr indent="0" marL="0">
-              <a:buNone/>
-            </a:pPr>
-            <a:r>
-              <a:rPr lang="en-US" sz="900" dirty="0">
-                <a:solidFill>
-                  <a:schemeClr val="tx1"/>
-                </a:solidFill>
-              </a:rPr>
-              <a:t>Postapproval safety studies; Market Clarity medical affairs insights</a:t>
-            </a:r>
-            <a:endParaRPr lang="en-US" sz="900" dirty="0"/>
-          </a:p>
-        </p:txBody>
-      </p:sp>
-      <p:sp>
-        <p:nvSpPr>
-          <p:cNvPr id="38" name="chat status Medical / Regulatory Research"/>
+          <p:cNvPr id="37" name="chat status Medical / Regulatory Research"/>
           <p:cNvSpPr/>
           <p:nvPr/>
         </p:nvSpPr>
         <p:spPr>
           <a:xfrm>
-            <a:off x="11109960" y="4009644"/>
+            <a:off x="11109960" y="3918204"/>
             <a:ext cx="164592" cy="164592"/>
           </a:xfrm>
           <a:prstGeom prst="ellipse">
@@ -9210,13 +9186,13 @@
       </p:sp>
       <p:sp>
         <p:nvSpPr>
-          <p:cNvPr id="39" name="Shape 36"/>
+          <p:cNvPr id="38" name="Shape 35"/>
           <p:cNvSpPr/>
           <p:nvPr/>
         </p:nvSpPr>
         <p:spPr>
           <a:xfrm>
-            <a:off x="548640" y="4325112"/>
+            <a:off x="548640" y="4251960"/>
             <a:ext cx="11091672" cy="0"/>
           </a:xfrm>
           <a:prstGeom prst="line">
@@ -9233,14 +9209,14 @@
       </p:sp>
       <p:sp>
         <p:nvSpPr>
-          <p:cNvPr id="40" name="fraction Clinical Trials"/>
+          <p:cNvPr id="39" name="fraction Clinical Trials"/>
           <p:cNvSpPr txBox="1"/>
           <p:nvPr/>
         </p:nvSpPr>
         <p:spPr>
           <a:xfrm>
-            <a:off x="1152682" y="4325112"/>
-            <a:ext cx="548640" cy="466344"/>
+            <a:off x="1152682" y="4251960"/>
+            <a:ext cx="548640" cy="502920"/>
           </a:xfrm>
           <a:prstGeom prst="rect">
             <a:avLst/>
@@ -9258,7 +9234,7 @@
             <a:r>
               <a:rPr lang="en-US" sz="1000" b="1" dirty="0">
                 <a:solidFill>
-                  <a:schemeClr val="accent2"/>
+                  <a:schemeClr val="accent1"/>
                 </a:solidFill>
               </a:rPr>
               <a:t>1</a:t>
@@ -9280,13 +9256,13 @@
       </p:sp>
       <p:sp>
         <p:nvSpPr>
-          <p:cNvPr id="41" name="workflow chip Clinical Trials"/>
+          <p:cNvPr id="40" name="workflow chip Clinical Trials"/>
           <p:cNvSpPr/>
           <p:nvPr/>
         </p:nvSpPr>
         <p:spPr>
           <a:xfrm>
-            <a:off x="3547872" y="4402836"/>
+            <a:off x="3547872" y="4347972"/>
             <a:ext cx="1819656" cy="310896"/>
           </a:xfrm>
           <a:prstGeom prst="roundRect">
@@ -9307,14 +9283,50 @@
       </p:sp>
       <p:sp>
         <p:nvSpPr>
+          <p:cNvPr id="41" name="Text 38"/>
+          <p:cNvSpPr txBox="1"/>
+          <p:nvPr/>
+        </p:nvSpPr>
+        <p:spPr>
+          <a:xfrm>
+            <a:off x="3547872" y="4347972"/>
+            <a:ext cx="1819656" cy="310896"/>
+          </a:xfrm>
+          <a:prstGeom prst="rect">
+            <a:avLst/>
+          </a:prstGeom>
+          <a:noFill/>
+          <a:ln/>
+        </p:spPr>
+        <p:txBody>
+          <a:bodyPr wrap="square" lIns="0" tIns="0" rIns="0" bIns="0" rtlCol="0" anchor="ctr"/>
+          <a:lstStyle/>
+          <a:p>
+            <a:pPr algn="ctr" indent="0" marL="0">
+              <a:buNone/>
+            </a:pPr>
+            <a:r>
+              <a:rPr lang="en-US" sz="900" b="1" dirty="0">
+                <a:solidFill>
+                  <a:schemeClr val="accent1"/>
+                </a:solidFill>
+              </a:rPr>
+              <a:t>Clinical Trials</a:t>
+            </a:r>
+            <a:endParaRPr lang="en-US" sz="900" dirty="0"/>
+          </a:p>
+        </p:txBody>
+      </p:sp>
+      <p:sp>
+        <p:nvSpPr>
           <p:cNvPr id="42" name="Text 39"/>
           <p:cNvSpPr txBox="1"/>
           <p:nvPr/>
         </p:nvSpPr>
         <p:spPr>
           <a:xfrm>
-            <a:off x="3547872" y="4402836"/>
-            <a:ext cx="1819656" cy="310896"/>
+            <a:off x="5577840" y="4251960"/>
+            <a:ext cx="2697480" cy="502920"/>
           </a:xfrm>
           <a:prstGeom prst="rect">
             <a:avLst/>
@@ -9326,16 +9338,16 @@
           <a:bodyPr wrap="square" lIns="0" tIns="0" rIns="0" bIns="0" rtlCol="0" anchor="ctr"/>
           <a:lstStyle/>
           <a:p>
-            <a:pPr algn="ctr" indent="0" marL="0">
-              <a:buNone/>
-            </a:pPr>
-            <a:r>
-              <a:rPr lang="en-US" sz="900" b="1" dirty="0">
-                <a:solidFill>
-                  <a:schemeClr val="accent1"/>
-                </a:solidFill>
-              </a:rPr>
-              <a:t>Clinical Trials</a:t>
+            <a:pPr indent="0" marL="0">
+              <a:buNone/>
+            </a:pPr>
+            <a:r>
+              <a:rPr lang="en-US" sz="900" dirty="0">
+                <a:solidFill>
+                  <a:schemeClr val="tx1"/>
+                </a:solidFill>
+              </a:rPr>
+              <a:t>TriNetX Terrain AI Assistant</a:t>
             </a:r>
             <a:endParaRPr lang="en-US" sz="900" dirty="0"/>
           </a:p>
@@ -9349,8 +9361,8 @@
         </p:nvSpPr>
         <p:spPr>
           <a:xfrm>
-            <a:off x="5577840" y="4325112"/>
-            <a:ext cx="2697480" cy="466344"/>
+            <a:off x="8595360" y="4251960"/>
+            <a:ext cx="1920240" cy="502920"/>
           </a:xfrm>
           <a:prstGeom prst="rect">
             <a:avLst/>
@@ -9371,7 +9383,7 @@
                   <a:schemeClr val="tx1"/>
                 </a:solidFill>
               </a:rPr>
-              <a:t>TriNetX Terrain AI Assistant</a:t>
+              <a:t>Prospector; Digital Research Network; True Source</a:t>
             </a:r>
             <a:endParaRPr lang="en-US" sz="900" dirty="0"/>
           </a:p>
@@ -9379,49 +9391,13 @@
       </p:sp>
       <p:sp>
         <p:nvSpPr>
-          <p:cNvPr id="44" name="Text 41"/>
-          <p:cNvSpPr txBox="1"/>
-          <p:nvPr/>
-        </p:nvSpPr>
-        <p:spPr>
-          <a:xfrm>
-            <a:off x="8595360" y="4325112"/>
-            <a:ext cx="1920240" cy="466344"/>
-          </a:xfrm>
-          <a:prstGeom prst="rect">
-            <a:avLst/>
-          </a:prstGeom>
-          <a:noFill/>
-          <a:ln/>
-        </p:spPr>
-        <p:txBody>
-          <a:bodyPr wrap="square" lIns="0" tIns="0" rIns="0" bIns="0" rtlCol="0" anchor="ctr"/>
-          <a:lstStyle/>
-          <a:p>
-            <a:pPr indent="0" marL="0">
-              <a:buNone/>
-            </a:pPr>
-            <a:r>
-              <a:rPr lang="en-US" sz="900" dirty="0">
-                <a:solidFill>
-                  <a:schemeClr val="tx1"/>
-                </a:solidFill>
-              </a:rPr>
-              <a:t>Prospector; Digital Research Network; True Source</a:t>
-            </a:r>
-            <a:endParaRPr lang="en-US" sz="900" dirty="0"/>
-          </a:p>
-        </p:txBody>
-      </p:sp>
-      <p:sp>
-        <p:nvSpPr>
-          <p:cNvPr id="45" name="chat status Clinical Trials"/>
+          <p:cNvPr id="44" name="chat status Clinical Trials"/>
           <p:cNvSpPr/>
           <p:nvPr/>
         </p:nvSpPr>
         <p:spPr>
           <a:xfrm>
-            <a:off x="11109960" y="4475988"/>
+            <a:off x="11109960" y="4421124"/>
             <a:ext cx="164592" cy="164592"/>
           </a:xfrm>
           <a:prstGeom prst="ellipse">
@@ -9437,13 +9413,13 @@
       </p:sp>
       <p:sp>
         <p:nvSpPr>
-          <p:cNvPr id="46" name="Shape 43"/>
+          <p:cNvPr id="45" name="Shape 42"/>
           <p:cNvSpPr/>
           <p:nvPr/>
         </p:nvSpPr>
         <p:spPr>
           <a:xfrm>
-            <a:off x="548640" y="4791456"/>
+            <a:off x="548640" y="4754880"/>
             <a:ext cx="11091672" cy="0"/>
           </a:xfrm>
           <a:prstGeom prst="line">
@@ -9460,14 +9436,14 @@
       </p:sp>
       <p:sp>
         <p:nvSpPr>
-          <p:cNvPr id="47" name="fraction Market Access"/>
+          <p:cNvPr id="46" name="fraction Market Access"/>
           <p:cNvSpPr txBox="1"/>
           <p:nvPr/>
         </p:nvSpPr>
         <p:spPr>
           <a:xfrm>
-            <a:off x="1217766" y="4791456"/>
-            <a:ext cx="548640" cy="466344"/>
+            <a:off x="1217766" y="4754880"/>
+            <a:ext cx="548640" cy="502920"/>
           </a:xfrm>
           <a:prstGeom prst="rect">
             <a:avLst/>
@@ -9485,7 +9461,7 @@
             <a:r>
               <a:rPr lang="en-US" sz="1000" b="1" dirty="0">
                 <a:solidFill>
-                  <a:schemeClr val="accent2"/>
+                  <a:schemeClr val="accent1"/>
                 </a:solidFill>
               </a:rPr>
               <a:t>1</a:t>
@@ -9507,13 +9483,13 @@
       </p:sp>
       <p:sp>
         <p:nvSpPr>
-          <p:cNvPr id="48" name="workflow chip Market Access"/>
+          <p:cNvPr id="47" name="workflow chip Market Access"/>
           <p:cNvSpPr/>
           <p:nvPr/>
         </p:nvSpPr>
         <p:spPr>
           <a:xfrm>
-            <a:off x="3547872" y="4869180"/>
+            <a:off x="3547872" y="4850892"/>
             <a:ext cx="1819656" cy="310896"/>
           </a:xfrm>
           <a:prstGeom prst="roundRect">
@@ -9534,14 +9510,50 @@
       </p:sp>
       <p:sp>
         <p:nvSpPr>
+          <p:cNvPr id="48" name="Text 45"/>
+          <p:cNvSpPr txBox="1"/>
+          <p:nvPr/>
+        </p:nvSpPr>
+        <p:spPr>
+          <a:xfrm>
+            <a:off x="3547872" y="4850892"/>
+            <a:ext cx="1819656" cy="310896"/>
+          </a:xfrm>
+          <a:prstGeom prst="rect">
+            <a:avLst/>
+          </a:prstGeom>
+          <a:noFill/>
+          <a:ln/>
+        </p:spPr>
+        <p:txBody>
+          <a:bodyPr wrap="square" lIns="0" tIns="0" rIns="0" bIns="0" rtlCol="0" anchor="ctr"/>
+          <a:lstStyle/>
+          <a:p>
+            <a:pPr algn="ctr" indent="0" marL="0">
+              <a:buNone/>
+            </a:pPr>
+            <a:r>
+              <a:rPr lang="en-US" sz="900" b="1" dirty="0">
+                <a:solidFill>
+                  <a:schemeClr val="accent1"/>
+                </a:solidFill>
+              </a:rPr>
+              <a:t>Market Access</a:t>
+            </a:r>
+            <a:endParaRPr lang="en-US" sz="900" dirty="0"/>
+          </a:p>
+        </p:txBody>
+      </p:sp>
+      <p:sp>
+        <p:nvSpPr>
           <p:cNvPr id="49" name="Text 46"/>
           <p:cNvSpPr txBox="1"/>
           <p:nvPr/>
         </p:nvSpPr>
         <p:spPr>
           <a:xfrm>
-            <a:off x="3547872" y="4869180"/>
-            <a:ext cx="1819656" cy="310896"/>
+            <a:off x="5577840" y="4754880"/>
+            <a:ext cx="2697480" cy="502920"/>
           </a:xfrm>
           <a:prstGeom prst="rect">
             <a:avLst/>
@@ -9553,16 +9565,16 @@
           <a:bodyPr wrap="square" lIns="0" tIns="0" rIns="0" bIns="0" rtlCol="0" anchor="ctr"/>
           <a:lstStyle/>
           <a:p>
-            <a:pPr algn="ctr" indent="0" marL="0">
-              <a:buNone/>
-            </a:pPr>
-            <a:r>
-              <a:rPr lang="en-US" sz="900" b="1" dirty="0">
-                <a:solidFill>
-                  <a:schemeClr val="accent1"/>
-                </a:solidFill>
-              </a:rPr>
-              <a:t>Market Access</a:t>
+            <a:pPr indent="0" marL="0">
+              <a:buNone/>
+            </a:pPr>
+            <a:r>
+              <a:rPr lang="en-US" sz="900" dirty="0">
+                <a:solidFill>
+                  <a:schemeClr val="tx1"/>
+                </a:solidFill>
+              </a:rPr>
+              <a:t>EVERSANA Ask NAVLIN</a:t>
             </a:r>
             <a:endParaRPr lang="en-US" sz="900" dirty="0"/>
           </a:p>
@@ -9576,8 +9588,8 @@
         </p:nvSpPr>
         <p:spPr>
           <a:xfrm>
-            <a:off x="5577840" y="4791456"/>
-            <a:ext cx="2697480" cy="466344"/>
+            <a:off x="8595360" y="4754880"/>
+            <a:ext cx="1920240" cy="502920"/>
           </a:xfrm>
           <a:prstGeom prst="rect">
             <a:avLst/>
@@ -9598,7 +9610,7 @@
                   <a:schemeClr val="tx1"/>
                 </a:solidFill>
               </a:rPr>
-              <a:t>EVERSANA Ask NAVLIN</a:t>
+              <a:t>HEOR/value evidence; Evidence Engine</a:t>
             </a:r>
             <a:endParaRPr lang="en-US" sz="900" dirty="0"/>
           </a:p>
@@ -9606,49 +9618,13 @@
       </p:sp>
       <p:sp>
         <p:nvSpPr>
-          <p:cNvPr id="51" name="Text 48"/>
-          <p:cNvSpPr txBox="1"/>
-          <p:nvPr/>
-        </p:nvSpPr>
-        <p:spPr>
-          <a:xfrm>
-            <a:off x="8595360" y="4791456"/>
-            <a:ext cx="1920240" cy="466344"/>
-          </a:xfrm>
-          <a:prstGeom prst="rect">
-            <a:avLst/>
-          </a:prstGeom>
-          <a:noFill/>
-          <a:ln/>
-        </p:spPr>
-        <p:txBody>
-          <a:bodyPr wrap="square" lIns="0" tIns="0" rIns="0" bIns="0" rtlCol="0" anchor="ctr"/>
-          <a:lstStyle/>
-          <a:p>
-            <a:pPr indent="0" marL="0">
-              <a:buNone/>
-            </a:pPr>
-            <a:r>
-              <a:rPr lang="en-US" sz="900" dirty="0">
-                <a:solidFill>
-                  <a:schemeClr val="tx1"/>
-                </a:solidFill>
-              </a:rPr>
-              <a:t>HEOR/value evidence; Evidence Engine</a:t>
-            </a:r>
-            <a:endParaRPr lang="en-US" sz="900" dirty="0"/>
-          </a:p>
-        </p:txBody>
-      </p:sp>
-      <p:sp>
-        <p:nvSpPr>
-          <p:cNvPr id="52" name="chat status Market Access"/>
+          <p:cNvPr id="51" name="chat status Market Access"/>
           <p:cNvSpPr/>
           <p:nvPr/>
         </p:nvSpPr>
         <p:spPr>
           <a:xfrm>
-            <a:off x="11109960" y="4942332"/>
+            <a:off x="11109960" y="4924044"/>
             <a:ext cx="164592" cy="164592"/>
           </a:xfrm>
           <a:prstGeom prst="ellipse">
@@ -9664,7 +9640,7 @@
       </p:sp>
       <p:sp>
         <p:nvSpPr>
-          <p:cNvPr id="53" name="Shape 50"/>
+          <p:cNvPr id="52" name="Shape 49"/>
           <p:cNvSpPr/>
           <p:nvPr/>
         </p:nvSpPr>
@@ -9687,7 +9663,7 @@
       </p:sp>
       <p:sp>
         <p:nvSpPr>
-          <p:cNvPr id="54" name="scope note"/>
+          <p:cNvPr id="53" name="scope note"/>
           <p:cNvSpPr txBox="1"/>
           <p:nvPr/>
         </p:nvSpPr>
@@ -9723,7 +9699,7 @@
       </p:sp>
       <p:sp>
         <p:nvSpPr>
-          <p:cNvPr id="55" name="chat claim legend"/>
+          <p:cNvPr id="54" name="chat claim legend"/>
           <p:cNvSpPr txBox="1"/>
           <p:nvPr/>
         </p:nvSpPr>
@@ -9759,7 +9735,7 @@
       </p:sp>
       <p:sp>
         <p:nvSpPr>
-          <p:cNvPr id="56" name="key takeaway card"/>
+          <p:cNvPr id="55" name="key takeaway card"/>
           <p:cNvSpPr/>
           <p:nvPr/>
         </p:nvSpPr>
@@ -9786,14 +9762,14 @@
       </p:sp>
       <p:sp>
         <p:nvSpPr>
-          <p:cNvPr id="57" name="label"/>
+          <p:cNvPr id="56" name="label"/>
           <p:cNvSpPr txBox="1"/>
           <p:nvPr/>
         </p:nvSpPr>
         <p:spPr>
           <a:xfrm>
-            <a:off x="731520" y="5596128"/>
-            <a:ext cx="1920240" cy="548640"/>
+            <a:off x="548640" y="5596128"/>
+            <a:ext cx="2377440" cy="548640"/>
           </a:xfrm>
           <a:prstGeom prst="rect">
             <a:avLst/>
@@ -9805,7 +9781,7 @@
           <a:bodyPr wrap="square" lIns="0" tIns="0" rIns="0" bIns="0" rtlCol="0" anchor="ctr"/>
           <a:lstStyle/>
           <a:p>
-            <a:pPr indent="0" marL="0">
+            <a:pPr algn="ctr" indent="0" marL="0">
               <a:buNone/>
             </a:pPr>
             <a:r>
@@ -9822,7 +9798,7 @@
       </p:sp>
       <p:sp>
         <p:nvSpPr>
-          <p:cNvPr id="58" name="Text 55"/>
+          <p:cNvPr id="57" name="Text 54"/>
           <p:cNvSpPr txBox="1"/>
           <p:nvPr/>
         </p:nvSpPr>
@@ -10010,7 +9986,7 @@
                   <a:schemeClr val="accent1"/>
                 </a:solidFill>
               </a:rPr>
-              <a:t>Selected international screens identify additional competitors marketing conversational AI across Optum LS-relevant domains</a:t>
+              <a:t>Selected international screens identify additional companies marketing conversational AI across Optum LS-relevant domains</a:t>
             </a:r>
             <a:endParaRPr lang="en-US" sz="2200" dirty="0"/>
           </a:p>
@@ -10152,7 +10128,7 @@
                   <a:schemeClr val="bg1"/>
                 </a:solidFill>
               </a:rPr>
-              <a:t>Companies with conversational AI /</a:t>
+              <a:t>Companies marketing conversational AI /</a:t>
             </a:r>
             <a:endParaRPr lang="en-US" sz="900" dirty="0"/>
           </a:p>
@@ -14133,7 +14109,7 @@
                   <a:schemeClr val="accent1"/>
                 </a:solidFill>
               </a:rPr>
-              <a:t>research and more narrowly defined evidence questions</a:t>
+              <a:t>research and more narrowly-defined evidence questions</a:t>
             </a:r>
             <a:endParaRPr lang="en-US" sz="2200" dirty="0"/>
           </a:p>
@@ -17828,7 +17804,7 @@
                             <a:schemeClr val="tx1"/>
                           </a:solidFill>
                         </a:rPr>
-                        <a:t>Optum's safety and evidence-research services are adjacent; a directly comparable document-chat offering was not established in the review</a:t>
+                        <a:t>Optum's safety and evidence-research services are adjacent; a comparable conversational interface for regulated documents was not established</a:t>
                       </a:r>
                       <a:endParaRPr lang="en-US" sz="950" dirty="0"/>
                     </a:p>
@@ -19363,7 +19339,7 @@
                   <a:schemeClr val="tx1"/>
                 </a:solidFill>
               </a:rPr>
-              <a:t>For Market Access, is the customer asking for pricing intelligence, reimbursement information or new economic evidence? Where do the vendor offerings overlap with Optum, and where do they solve a different problem?</a:t>
+              <a:t>For Market Access, is the customer asking for pricing intelligence, reimbursement information or new economic evidence? Where do the vendor offerings overlap with Optum LS, and where do they solve a different problem?</a:t>
             </a:r>
             <a:endParaRPr lang="en-US" sz="1050" dirty="0"/>
           </a:p>

</xml_diff>